<commit_message>
Préparation des cartes actions et de la piste de scores pour Tabletopia
</commit_message>
<xml_diff>
--- a/pictures/Cartes-Actions-et-Evenements/Design-Cartes.pptx
+++ b/pictures/Cartes-Actions-et-Evenements/Design-Cartes.pptx
@@ -5,7 +5,7 @@
     <p:sldMasterId id="2147483648" r:id="rId1"/>
   </p:sldMasterIdLst>
   <p:notesMasterIdLst>
-    <p:notesMasterId r:id="rId8"/>
+    <p:notesMasterId r:id="rId9"/>
   </p:notesMasterIdLst>
   <p:sldIdLst>
     <p:sldId id="281" r:id="rId2"/>
@@ -14,6 +14,7 @@
     <p:sldId id="284" r:id="rId5"/>
     <p:sldId id="287" r:id="rId6"/>
     <p:sldId id="286" r:id="rId7"/>
+    <p:sldId id="288" r:id="rId8"/>
   </p:sldIdLst>
   <p:sldSz cx="12192000" cy="6858000"/>
   <p:notesSz cx="6888163" cy="10020300"/>
@@ -202,7 +203,7 @@
           <a:p>
             <a:fld id="{263B0988-6DB9-4E3D-B7FD-EFF3BCABE954}" type="datetimeFigureOut">
               <a:rPr lang="fr-FR" smtClean="0"/>
-              <a:t>14/03/2026</a:t>
+              <a:t>15/03/2026</a:t>
             </a:fld>
             <a:endParaRPr lang="fr-FR"/>
           </a:p>
@@ -700,7 +701,7 @@
           <a:p>
             <a:fld id="{588505E2-0C4C-443F-8F57-41958F504CA2}" type="datetimeFigureOut">
               <a:rPr lang="fr-FR" smtClean="0"/>
-              <a:t>14/03/2026</a:t>
+              <a:t>15/03/2026</a:t>
             </a:fld>
             <a:endParaRPr lang="fr-FR"/>
           </a:p>
@@ -898,7 +899,7 @@
           <a:p>
             <a:fld id="{588505E2-0C4C-443F-8F57-41958F504CA2}" type="datetimeFigureOut">
               <a:rPr lang="fr-FR" smtClean="0"/>
-              <a:t>14/03/2026</a:t>
+              <a:t>15/03/2026</a:t>
             </a:fld>
             <a:endParaRPr lang="fr-FR"/>
           </a:p>
@@ -1106,7 +1107,7 @@
           <a:p>
             <a:fld id="{588505E2-0C4C-443F-8F57-41958F504CA2}" type="datetimeFigureOut">
               <a:rPr lang="fr-FR" smtClean="0"/>
-              <a:t>14/03/2026</a:t>
+              <a:t>15/03/2026</a:t>
             </a:fld>
             <a:endParaRPr lang="fr-FR"/>
           </a:p>
@@ -1304,7 +1305,7 @@
           <a:p>
             <a:fld id="{588505E2-0C4C-443F-8F57-41958F504CA2}" type="datetimeFigureOut">
               <a:rPr lang="fr-FR" smtClean="0"/>
-              <a:t>14/03/2026</a:t>
+              <a:t>15/03/2026</a:t>
             </a:fld>
             <a:endParaRPr lang="fr-FR"/>
           </a:p>
@@ -1579,7 +1580,7 @@
           <a:p>
             <a:fld id="{588505E2-0C4C-443F-8F57-41958F504CA2}" type="datetimeFigureOut">
               <a:rPr lang="fr-FR" smtClean="0"/>
-              <a:t>14/03/2026</a:t>
+              <a:t>15/03/2026</a:t>
             </a:fld>
             <a:endParaRPr lang="fr-FR"/>
           </a:p>
@@ -1844,7 +1845,7 @@
           <a:p>
             <a:fld id="{588505E2-0C4C-443F-8F57-41958F504CA2}" type="datetimeFigureOut">
               <a:rPr lang="fr-FR" smtClean="0"/>
-              <a:t>14/03/2026</a:t>
+              <a:t>15/03/2026</a:t>
             </a:fld>
             <a:endParaRPr lang="fr-FR"/>
           </a:p>
@@ -2256,7 +2257,7 @@
           <a:p>
             <a:fld id="{588505E2-0C4C-443F-8F57-41958F504CA2}" type="datetimeFigureOut">
               <a:rPr lang="fr-FR" smtClean="0"/>
-              <a:t>14/03/2026</a:t>
+              <a:t>15/03/2026</a:t>
             </a:fld>
             <a:endParaRPr lang="fr-FR"/>
           </a:p>
@@ -2397,7 +2398,7 @@
           <a:p>
             <a:fld id="{588505E2-0C4C-443F-8F57-41958F504CA2}" type="datetimeFigureOut">
               <a:rPr lang="fr-FR" smtClean="0"/>
-              <a:t>14/03/2026</a:t>
+              <a:t>15/03/2026</a:t>
             </a:fld>
             <a:endParaRPr lang="fr-FR"/>
           </a:p>
@@ -2510,7 +2511,7 @@
           <a:p>
             <a:fld id="{588505E2-0C4C-443F-8F57-41958F504CA2}" type="datetimeFigureOut">
               <a:rPr lang="fr-FR" smtClean="0"/>
-              <a:t>14/03/2026</a:t>
+              <a:t>15/03/2026</a:t>
             </a:fld>
             <a:endParaRPr lang="fr-FR"/>
           </a:p>
@@ -2821,7 +2822,7 @@
           <a:p>
             <a:fld id="{588505E2-0C4C-443F-8F57-41958F504CA2}" type="datetimeFigureOut">
               <a:rPr lang="fr-FR" smtClean="0"/>
-              <a:t>14/03/2026</a:t>
+              <a:t>15/03/2026</a:t>
             </a:fld>
             <a:endParaRPr lang="fr-FR"/>
           </a:p>
@@ -3109,7 +3110,7 @@
           <a:p>
             <a:fld id="{588505E2-0C4C-443F-8F57-41958F504CA2}" type="datetimeFigureOut">
               <a:rPr lang="fr-FR" smtClean="0"/>
-              <a:t>14/03/2026</a:t>
+              <a:t>15/03/2026</a:t>
             </a:fld>
             <a:endParaRPr lang="fr-FR"/>
           </a:p>
@@ -3350,7 +3351,7 @@
           <a:p>
             <a:fld id="{588505E2-0C4C-443F-8F57-41958F504CA2}" type="datetimeFigureOut">
               <a:rPr lang="fr-FR" smtClean="0"/>
-              <a:t>14/03/2026</a:t>
+              <a:t>15/03/2026</a:t>
             </a:fld>
             <a:endParaRPr lang="fr-FR"/>
           </a:p>
@@ -13244,537 +13245,6 @@
       </p:grpSp>
       <p:grpSp>
         <p:nvGrpSpPr>
-          <p:cNvPr id="22" name="Groupe 21">
-            <a:extLst>
-              <a:ext uri="{FF2B5EF4-FFF2-40B4-BE49-F238E27FC236}">
-                <a16:creationId xmlns:a16="http://schemas.microsoft.com/office/drawing/2014/main" id="{8E5BAE97-5409-F4A3-FE7B-5D5DEB3DCC1F}"/>
-              </a:ext>
-            </a:extLst>
-          </p:cNvPr>
-          <p:cNvGrpSpPr/>
-          <p:nvPr/>
-        </p:nvGrpSpPr>
-        <p:grpSpPr>
-          <a:xfrm>
-            <a:off x="5978073" y="1543946"/>
-            <a:ext cx="2124000" cy="3328669"/>
-            <a:chOff x="5978073" y="1543946"/>
-            <a:chExt cx="2124000" cy="3328669"/>
-          </a:xfrm>
-        </p:grpSpPr>
-        <p:sp>
-          <p:nvSpPr>
-            <p:cNvPr id="18" name="Rectangle 17">
-              <a:extLst>
-                <a:ext uri="{FF2B5EF4-FFF2-40B4-BE49-F238E27FC236}">
-                  <a16:creationId xmlns:a16="http://schemas.microsoft.com/office/drawing/2014/main" id="{335F17C6-1312-7E12-3A37-75114398AC4E}"/>
-                </a:ext>
-              </a:extLst>
-            </p:cNvPr>
-            <p:cNvSpPr/>
-            <p:nvPr/>
-          </p:nvSpPr>
-          <p:spPr>
-            <a:xfrm>
-              <a:off x="5978073" y="1543946"/>
-              <a:ext cx="2124000" cy="3312000"/>
-            </a:xfrm>
-            <a:prstGeom prst="rect">
-              <a:avLst/>
-            </a:prstGeom>
-            <a:blipFill dpi="0" rotWithShape="1">
-              <a:blip r:embed="rId2">
-                <a:alphaModFix amt="75000"/>
-              </a:blip>
-              <a:srcRect/>
-              <a:tile tx="0" ty="0" sx="100000" sy="100000" flip="none" algn="tl"/>
-            </a:blipFill>
-          </p:spPr>
-          <p:style>
-            <a:lnRef idx="2">
-              <a:schemeClr val="accent1">
-                <a:shade val="15000"/>
-              </a:schemeClr>
-            </a:lnRef>
-            <a:fillRef idx="1">
-              <a:schemeClr val="accent1"/>
-            </a:fillRef>
-            <a:effectRef idx="0">
-              <a:schemeClr val="accent1"/>
-            </a:effectRef>
-            <a:fontRef idx="minor">
-              <a:schemeClr val="lt1"/>
-            </a:fontRef>
-          </p:style>
-          <p:txBody>
-            <a:bodyPr rtlCol="0" anchor="ctr"/>
-            <a:lstStyle/>
-            <a:p>
-              <a:pPr algn="ctr"/>
-              <a:endParaRPr lang="fr-FR"/>
-            </a:p>
-          </p:txBody>
-        </p:sp>
-        <p:sp>
-          <p:nvSpPr>
-            <p:cNvPr id="20" name="Rectangle 19">
-              <a:extLst>
-                <a:ext uri="{FF2B5EF4-FFF2-40B4-BE49-F238E27FC236}">
-                  <a16:creationId xmlns:a16="http://schemas.microsoft.com/office/drawing/2014/main" id="{F9EC661C-5DCA-3B72-BC59-DD4B176ACBEC}"/>
-                </a:ext>
-              </a:extLst>
-            </p:cNvPr>
-            <p:cNvSpPr/>
-            <p:nvPr/>
-          </p:nvSpPr>
-          <p:spPr>
-            <a:xfrm>
-              <a:off x="5978073" y="1543946"/>
-              <a:ext cx="2124000" cy="432000"/>
-            </a:xfrm>
-            <a:prstGeom prst="rect">
-              <a:avLst/>
-            </a:prstGeom>
-            <a:blipFill>
-              <a:blip r:embed="rId3">
-                <a:extLst>
-                  <a:ext uri="{BEBA8EAE-BF5A-486C-A8C5-ECC9F3942E4B}">
-                    <a14:imgProps xmlns:a14="http://schemas.microsoft.com/office/drawing/2010/main">
-                      <a14:imgLayer r:embed="rId4">
-                        <a14:imgEffect>
-                          <a14:artisticWatercolorSponge/>
-                        </a14:imgEffect>
-                      </a14:imgLayer>
-                    </a14:imgProps>
-                  </a:ext>
-                </a:extLst>
-              </a:blip>
-              <a:tile tx="0" ty="0" sx="100000" sy="100000" flip="none" algn="tl"/>
-            </a:blipFill>
-          </p:spPr>
-          <p:style>
-            <a:lnRef idx="2">
-              <a:schemeClr val="accent1">
-                <a:shade val="15000"/>
-              </a:schemeClr>
-            </a:lnRef>
-            <a:fillRef idx="1">
-              <a:schemeClr val="accent1"/>
-            </a:fillRef>
-            <a:effectRef idx="0">
-              <a:schemeClr val="accent1"/>
-            </a:effectRef>
-            <a:fontRef idx="minor">
-              <a:schemeClr val="lt1"/>
-            </a:fontRef>
-          </p:style>
-          <p:txBody>
-            <a:bodyPr lIns="0" rIns="0" rtlCol="0" anchor="ctr"/>
-            <a:lstStyle/>
-            <a:p>
-              <a:pPr algn="ctr"/>
-              <a:r>
-                <a:rPr lang="fr-FR" sz="1600" b="1" dirty="0">
-                  <a:solidFill>
-                    <a:schemeClr val="tx1"/>
-                  </a:solidFill>
-                  <a:latin typeface="Segoe UI" panose="020B0502040204020203" pitchFamily="34" charset="0"/>
-                  <a:cs typeface="Segoe UI" panose="020B0502040204020203" pitchFamily="34" charset="0"/>
-                </a:rPr>
-                <a:t>Chevauchée lointaine</a:t>
-              </a:r>
-            </a:p>
-          </p:txBody>
-        </p:sp>
-        <p:sp>
-          <p:nvSpPr>
-            <p:cNvPr id="21" name="Cercle : creux 20">
-              <a:extLst>
-                <a:ext uri="{FF2B5EF4-FFF2-40B4-BE49-F238E27FC236}">
-                  <a16:creationId xmlns:a16="http://schemas.microsoft.com/office/drawing/2014/main" id="{71BEC6CA-95D4-973F-EE5F-9097DA99BB78}"/>
-                </a:ext>
-              </a:extLst>
-            </p:cNvPr>
-            <p:cNvSpPr/>
-            <p:nvPr/>
-          </p:nvSpPr>
-          <p:spPr>
-            <a:xfrm>
-              <a:off x="6058815" y="4364328"/>
-              <a:ext cx="360000" cy="360000"/>
-            </a:xfrm>
-            <a:prstGeom prst="donut">
-              <a:avLst>
-                <a:gd name="adj" fmla="val 15271"/>
-              </a:avLst>
-            </a:prstGeom>
-            <a:blipFill>
-              <a:blip r:embed="rId5"/>
-              <a:tile tx="0" ty="0" sx="100000" sy="100000" flip="none" algn="tl"/>
-            </a:blipFill>
-            <a:ln w="12700"/>
-          </p:spPr>
-          <p:style>
-            <a:lnRef idx="2">
-              <a:schemeClr val="dk1">
-                <a:shade val="15000"/>
-              </a:schemeClr>
-            </a:lnRef>
-            <a:fillRef idx="1">
-              <a:schemeClr val="dk1"/>
-            </a:fillRef>
-            <a:effectRef idx="0">
-              <a:schemeClr val="dk1"/>
-            </a:effectRef>
-            <a:fontRef idx="minor">
-              <a:schemeClr val="lt1"/>
-            </a:fontRef>
-          </p:style>
-          <p:txBody>
-            <a:bodyPr rtlCol="0" anchor="ctr"/>
-            <a:lstStyle/>
-            <a:p>
-              <a:pPr algn="ctr"/>
-              <a:r>
-                <a:rPr lang="fr-FR" b="1" dirty="0">
-                  <a:solidFill>
-                    <a:schemeClr val="tx1"/>
-                  </a:solidFill>
-                  <a:latin typeface="Segoe UI" panose="020B0502040204020203" pitchFamily="34" charset="0"/>
-                  <a:cs typeface="Segoe UI" panose="020B0502040204020203" pitchFamily="34" charset="0"/>
-                </a:rPr>
-                <a:t>3</a:t>
-              </a:r>
-            </a:p>
-          </p:txBody>
-        </p:sp>
-        <p:sp>
-          <p:nvSpPr>
-            <p:cNvPr id="23" name="ZoneTexte 22">
-              <a:extLst>
-                <a:ext uri="{FF2B5EF4-FFF2-40B4-BE49-F238E27FC236}">
-                  <a16:creationId xmlns:a16="http://schemas.microsoft.com/office/drawing/2014/main" id="{55DD1EA9-E357-1BB9-9BAD-43DB1D789BA7}"/>
-                </a:ext>
-              </a:extLst>
-            </p:cNvPr>
-            <p:cNvSpPr txBox="1"/>
-            <p:nvPr/>
-          </p:nvSpPr>
-          <p:spPr>
-            <a:xfrm>
-              <a:off x="6080358" y="2078686"/>
-              <a:ext cx="1919430" cy="646331"/>
-            </a:xfrm>
-            <a:prstGeom prst="rect">
-              <a:avLst/>
-            </a:prstGeom>
-            <a:noFill/>
-          </p:spPr>
-          <p:txBody>
-            <a:bodyPr wrap="square" rtlCol="0">
-              <a:spAutoFit/>
-            </a:bodyPr>
-            <a:lstStyle/>
-            <a:p>
-              <a:pPr algn="just">
-                <a:spcAft>
-                  <a:spcPts val="600"/>
-                </a:spcAft>
-              </a:pPr>
-              <a:r>
-                <a:rPr lang="fr-FR" sz="1200" b="1" dirty="0">
-                  <a:latin typeface="Segoe UI" panose="020B0502040204020203" pitchFamily="34" charset="0"/>
-                  <a:cs typeface="Segoe UI" panose="020B0502040204020203" pitchFamily="34" charset="0"/>
-                </a:rPr>
-                <a:t>Déplacer un baron ou un chevalier d’autant de tuiles que vous voulez</a:t>
-              </a:r>
-            </a:p>
-          </p:txBody>
-        </p:sp>
-        <p:sp>
-          <p:nvSpPr>
-            <p:cNvPr id="37" name="Hexagone 36">
-              <a:extLst>
-                <a:ext uri="{FF2B5EF4-FFF2-40B4-BE49-F238E27FC236}">
-                  <a16:creationId xmlns:a16="http://schemas.microsoft.com/office/drawing/2014/main" id="{C6A81F94-0E85-4AEA-331A-44D8B4A2ECAE}"/>
-                </a:ext>
-              </a:extLst>
-            </p:cNvPr>
-            <p:cNvSpPr/>
-            <p:nvPr/>
-          </p:nvSpPr>
-          <p:spPr>
-            <a:xfrm rot="5400000">
-              <a:off x="7440043" y="4364328"/>
-              <a:ext cx="396000" cy="360000"/>
-            </a:xfrm>
-            <a:prstGeom prst="hexagon">
-              <a:avLst/>
-            </a:prstGeom>
-            <a:blipFill>
-              <a:blip r:embed="rId11">
-                <a:extLst>
-                  <a:ext uri="{BEBA8EAE-BF5A-486C-A8C5-ECC9F3942E4B}">
-                    <a14:imgProps xmlns:a14="http://schemas.microsoft.com/office/drawing/2010/main">
-                      <a14:imgLayer r:embed="rId12">
-                        <a14:imgEffect>
-                          <a14:brightnessContrast bright="-20000" contrast="-40000"/>
-                        </a14:imgEffect>
-                      </a14:imgLayer>
-                    </a14:imgProps>
-                  </a:ext>
-                </a:extLst>
-              </a:blip>
-              <a:tile tx="0" ty="0" sx="100000" sy="100000" flip="none" algn="tl"/>
-            </a:blipFill>
-            <a:ln w="12700">
-              <a:solidFill>
-                <a:schemeClr val="tx1"/>
-              </a:solidFill>
-            </a:ln>
-          </p:spPr>
-          <p:style>
-            <a:lnRef idx="2">
-              <a:schemeClr val="accent1">
-                <a:shade val="15000"/>
-              </a:schemeClr>
-            </a:lnRef>
-            <a:fillRef idx="1">
-              <a:schemeClr val="accent1"/>
-            </a:fillRef>
-            <a:effectRef idx="0">
-              <a:schemeClr val="accent1"/>
-            </a:effectRef>
-            <a:fontRef idx="minor">
-              <a:schemeClr val="lt1"/>
-            </a:fontRef>
-          </p:style>
-          <p:txBody>
-            <a:bodyPr rtlCol="0" anchor="ctr"/>
-            <a:lstStyle/>
-            <a:p>
-              <a:pPr algn="ctr"/>
-              <a:endParaRPr lang="fr-FR"/>
-            </a:p>
-          </p:txBody>
-        </p:sp>
-        <p:sp>
-          <p:nvSpPr>
-            <p:cNvPr id="25" name="Hexagone 24">
-              <a:extLst>
-                <a:ext uri="{FF2B5EF4-FFF2-40B4-BE49-F238E27FC236}">
-                  <a16:creationId xmlns:a16="http://schemas.microsoft.com/office/drawing/2014/main" id="{83815794-831A-7ADF-EB70-4C74F51023A6}"/>
-                </a:ext>
-              </a:extLst>
-            </p:cNvPr>
-            <p:cNvSpPr/>
-            <p:nvPr/>
-          </p:nvSpPr>
-          <p:spPr>
-            <a:xfrm rot="5400000">
-              <a:off x="6621493" y="4364328"/>
-              <a:ext cx="396000" cy="360000"/>
-            </a:xfrm>
-            <a:prstGeom prst="hexagon">
-              <a:avLst/>
-            </a:prstGeom>
-            <a:solidFill>
-              <a:schemeClr val="bg1"/>
-            </a:solidFill>
-            <a:ln w="12700">
-              <a:solidFill>
-                <a:schemeClr val="tx1"/>
-              </a:solidFill>
-            </a:ln>
-          </p:spPr>
-          <p:style>
-            <a:lnRef idx="2">
-              <a:schemeClr val="accent1">
-                <a:shade val="15000"/>
-              </a:schemeClr>
-            </a:lnRef>
-            <a:fillRef idx="1">
-              <a:schemeClr val="accent1"/>
-            </a:fillRef>
-            <a:effectRef idx="0">
-              <a:schemeClr val="accent1"/>
-            </a:effectRef>
-            <a:fontRef idx="minor">
-              <a:schemeClr val="lt1"/>
-            </a:fontRef>
-          </p:style>
-          <p:txBody>
-            <a:bodyPr rtlCol="0" anchor="ctr"/>
-            <a:lstStyle/>
-            <a:p>
-              <a:pPr algn="ctr"/>
-              <a:endParaRPr lang="fr-FR"/>
-            </a:p>
-          </p:txBody>
-        </p:sp>
-        <p:pic>
-          <p:nvPicPr>
-            <p:cNvPr id="50" name="Image 49" descr="Une image contenant peinture, dessin, Fournitures pour cheval, Rêne&#10;&#10;Le contenu généré par l’IA peut être incorrect.">
-              <a:extLst>
-                <a:ext uri="{FF2B5EF4-FFF2-40B4-BE49-F238E27FC236}">
-                  <a16:creationId xmlns:a16="http://schemas.microsoft.com/office/drawing/2014/main" id="{BC8ACAC4-6D11-9AB4-BEF8-6EDB14F6259A}"/>
-                </a:ext>
-              </a:extLst>
-            </p:cNvPr>
-            <p:cNvPicPr>
-              <a:picLocks noChangeAspect="1"/>
-            </p:cNvPicPr>
-            <p:nvPr/>
-          </p:nvPicPr>
-          <p:blipFill>
-            <a:blip r:embed="rId13">
-              <a:duotone>
-                <a:prstClr val="black"/>
-                <a:srgbClr val="ECF3C9">
-                  <a:tint val="45000"/>
-                  <a:satMod val="400000"/>
-                </a:srgbClr>
-              </a:duotone>
-              <a:extLst>
-                <a:ext uri="{BEBA8EAE-BF5A-486C-A8C5-ECC9F3942E4B}">
-                  <a14:imgProps xmlns:a14="http://schemas.microsoft.com/office/drawing/2010/main">
-                    <a14:imgLayer r:embed="rId14">
-                      <a14:imgEffect>
-                        <a14:backgroundRemoval t="10000" b="90000" l="10000" r="90000">
-                          <a14:foregroundMark x1="51367" y1="73438" x2="51563" y2="73535"/>
-                          <a14:foregroundMark x1="51074" y1="74414" x2="51367" y2="74316"/>
-                          <a14:foregroundMark x1="50879" y1="74512" x2="50977" y2="74512"/>
-                          <a14:foregroundMark x1="50684" y1="75000" x2="50293" y2="75098"/>
-                          <a14:foregroundMark x1="50293" y1="73340" x2="50977" y2="73438"/>
-                          <a14:backgroundMark x1="10547" y1="41699" x2="20801" y2="33301"/>
-                          <a14:backgroundMark x1="20801" y1="33301" x2="35156" y2="40137"/>
-                          <a14:backgroundMark x1="35156" y1="40137" x2="42676" y2="46875"/>
-                          <a14:backgroundMark x1="42676" y1="46875" x2="42969" y2="75000"/>
-                          <a14:backgroundMark x1="42969" y1="75000" x2="46680" y2="83008"/>
-                          <a14:backgroundMark x1="46680" y1="83008" x2="25293" y2="88965"/>
-                          <a14:backgroundMark x1="25293" y1="88965" x2="10547" y2="76660"/>
-                          <a14:backgroundMark x1="10547" y1="76660" x2="8789" y2="43359"/>
-                          <a14:backgroundMark x1="8789" y1="43359" x2="12402" y2="41113"/>
-                          <a14:backgroundMark x1="78516" y1="44043" x2="80957" y2="51074"/>
-                          <a14:backgroundMark x1="80957" y1="51074" x2="88867" y2="51855"/>
-                          <a14:backgroundMark x1="88867" y1="51855" x2="93457" y2="43750"/>
-                          <a14:backgroundMark x1="93457" y1="43750" x2="82520" y2="41602"/>
-                          <a14:backgroundMark x1="82520" y1="41602" x2="78418" y2="44141"/>
-                          <a14:backgroundMark x1="47949" y1="64063" x2="50684" y2="72070"/>
-                          <a14:backgroundMark x1="50099" y1="74840" x2="49219" y2="79004"/>
-                          <a14:backgroundMark x1="50684" y1="72070" x2="50200" y2="74360"/>
-                          <a14:backgroundMark x1="49219" y1="79004" x2="54590" y2="73145"/>
-                          <a14:backgroundMark x1="54590" y1="73145" x2="53418" y2="66211"/>
-                          <a14:backgroundMark x1="46387" y1="80566" x2="59863" y2="78906"/>
-                          <a14:backgroundMark x1="59863" y1="78906" x2="60449" y2="67285"/>
-                          <a14:backgroundMark x1="60449" y1="67285" x2="57910" y2="59961"/>
-                          <a14:backgroundMark x1="57910" y1="59961" x2="57910" y2="59766"/>
-                          <a14:backgroundMark x1="61230" y1="68066" x2="68066" y2="73633"/>
-                          <a14:backgroundMark x1="68066" y1="73633" x2="65234" y2="86914"/>
-                          <a14:backgroundMark x1="65234" y1="86914" x2="51660" y2="89844"/>
-                          <a14:backgroundMark x1="51660" y1="89844" x2="44629" y2="87500"/>
-                          <a14:backgroundMark x1="44629" y1="87500" x2="52539" y2="80273"/>
-                          <a14:backgroundMark x1="52539" y1="80273" x2="59473" y2="78809"/>
-                          <a14:backgroundMark x1="59473" y1="78809" x2="62402" y2="70410"/>
-                          <a14:backgroundMark x1="62402" y1="70410" x2="61914" y2="68652"/>
-                          <a14:backgroundMark x1="73047" y1="67773" x2="73047" y2="70508"/>
-                          <a14:backgroundMark x1="73242" y1="74023" x2="73242" y2="74023"/>
-                          <a14:backgroundMark x1="79004" y1="66113" x2="77051" y2="85547"/>
-                          <a14:backgroundMark x1="85254" y1="60742" x2="88184" y2="76953"/>
-                          <a14:backgroundMark x1="88184" y1="76953" x2="80273" y2="77832"/>
-                          <a14:backgroundMark x1="80273" y1="77832" x2="87305" y2="65918"/>
-                          <a14:backgroundMark x1="67480" y1="15918" x2="67480" y2="15918"/>
-                          <a14:backgroundMark x1="87988" y1="59082" x2="87988" y2="59082"/>
-                          <a14:backgroundMark x1="84375" y1="58594" x2="84375" y2="58594"/>
-                          <a14:backgroundMark x1="83594" y1="58105" x2="83594" y2="58105"/>
-                          <a14:backgroundMark x1="85742" y1="57910" x2="85742" y2="57910"/>
-                          <a14:backgroundMark x1="86914" y1="55859" x2="86914" y2="55859"/>
-                          <a14:backgroundMark x1="45410" y1="36816" x2="45410" y2="36816"/>
-                          <a14:backgroundMark x1="46387" y1="35059" x2="46387" y2="35059"/>
-                        </a14:backgroundRemoval>
-                      </a14:imgEffect>
-                      <a14:imgEffect>
-                        <a14:brightnessContrast bright="40000" contrast="-40000"/>
-                      </a14:imgEffect>
-                    </a14:imgLayer>
-                  </a14:imgProps>
-                </a:ext>
-                <a:ext uri="{28A0092B-C50C-407E-A947-70E740481C1C}">
-                  <a14:useLocalDpi xmlns:a14="http://schemas.microsoft.com/office/drawing/2010/main" val="0"/>
-                </a:ext>
-              </a:extLst>
-            </a:blip>
-            <a:srcRect l="39260" t="12963" r="9752" b="49602"/>
-            <a:stretch>
-              <a:fillRect/>
-            </a:stretch>
-          </p:blipFill>
-          <p:spPr>
-            <a:xfrm flipH="1">
-              <a:off x="6208924" y="2859086"/>
-              <a:ext cx="1564884" cy="1148912"/>
-            </a:xfrm>
-            <a:prstGeom prst="rect">
-              <a:avLst/>
-            </a:prstGeom>
-          </p:spPr>
-        </p:pic>
-        <p:sp>
-          <p:nvSpPr>
-            <p:cNvPr id="9" name="Arc 8">
-              <a:extLst>
-                <a:ext uri="{FF2B5EF4-FFF2-40B4-BE49-F238E27FC236}">
-                  <a16:creationId xmlns:a16="http://schemas.microsoft.com/office/drawing/2014/main" id="{111FC888-ABD1-68D5-B0B7-972998BFACE0}"/>
-                </a:ext>
-              </a:extLst>
-            </p:cNvPr>
-            <p:cNvSpPr/>
-            <p:nvPr/>
-          </p:nvSpPr>
-          <p:spPr>
-            <a:xfrm>
-              <a:off x="6808430" y="4303954"/>
-              <a:ext cx="859018" cy="568661"/>
-            </a:xfrm>
-            <a:prstGeom prst="arc">
-              <a:avLst>
-                <a:gd name="adj1" fmla="val 11337146"/>
-                <a:gd name="adj2" fmla="val 8076"/>
-              </a:avLst>
-            </a:prstGeom>
-            <a:ln w="50800">
-              <a:solidFill>
-                <a:schemeClr val="tx1"/>
-              </a:solidFill>
-              <a:tailEnd type="triangle" w="med" len="med"/>
-            </a:ln>
-          </p:spPr>
-          <p:style>
-            <a:lnRef idx="2">
-              <a:schemeClr val="accent1"/>
-            </a:lnRef>
-            <a:fillRef idx="0">
-              <a:schemeClr val="accent1"/>
-            </a:fillRef>
-            <a:effectRef idx="1">
-              <a:schemeClr val="accent1"/>
-            </a:effectRef>
-            <a:fontRef idx="minor">
-              <a:schemeClr val="tx1"/>
-            </a:fontRef>
-          </p:style>
-          <p:txBody>
-            <a:bodyPr rtlCol="0" anchor="ctr"/>
-            <a:lstStyle/>
-            <a:p>
-              <a:pPr algn="ctr"/>
-              <a:endParaRPr lang="fr-FR"/>
-            </a:p>
-          </p:txBody>
-        </p:sp>
-      </p:grpSp>
-      <p:grpSp>
-        <p:nvGrpSpPr>
           <p:cNvPr id="24" name="Groupe 23">
             <a:extLst>
               <a:ext uri="{FF2B5EF4-FFF2-40B4-BE49-F238E27FC236}">
@@ -13814,11 +13284,11 @@
               <a:avLst/>
             </a:prstGeom>
             <a:blipFill dpi="0" rotWithShape="1">
-              <a:blip r:embed="rId15">
+              <a:blip r:embed="rId11">
                 <a:extLst>
                   <a:ext uri="{BEBA8EAE-BF5A-486C-A8C5-ECC9F3942E4B}">
                     <a14:imgProps xmlns:a14="http://schemas.microsoft.com/office/drawing/2010/main">
-                      <a14:imgLayer r:embed="rId16">
+                      <a14:imgLayer r:embed="rId12">
                         <a14:imgEffect>
                           <a14:artisticPaintBrush/>
                         </a14:imgEffect>
@@ -13877,11 +13347,11 @@
               <a:avLst/>
             </a:prstGeom>
             <a:blipFill dpi="0" rotWithShape="1">
-              <a:blip r:embed="rId17">
+              <a:blip r:embed="rId13">
                 <a:extLst>
                   <a:ext uri="{BEBA8EAE-BF5A-486C-A8C5-ECC9F3942E4B}">
                     <a14:imgProps xmlns:a14="http://schemas.microsoft.com/office/drawing/2010/main">
-                      <a14:imgLayer r:embed="rId16">
+                      <a14:imgLayer r:embed="rId12">
                         <a14:imgEffect>
                           <a14:artisticPaintBrush/>
                         </a14:imgEffect>
@@ -14078,7 +13548,7 @@
             <p:nvPr/>
           </p:nvPicPr>
           <p:blipFill>
-            <a:blip r:embed="rId18">
+            <a:blip r:embed="rId14">
               <a:duotone>
                 <a:prstClr val="black"/>
                 <a:srgbClr val="ECF3C9">
@@ -14089,7 +13559,7 @@
               <a:extLst>
                 <a:ext uri="{BEBA8EAE-BF5A-486C-A8C5-ECC9F3942E4B}">
                   <a14:imgProps xmlns:a14="http://schemas.microsoft.com/office/drawing/2010/main">
-                    <a14:imgLayer r:embed="rId19">
+                    <a14:imgLayer r:embed="rId15">
                       <a14:imgEffect>
                         <a14:backgroundRemoval t="25781" b="99023" l="11719" r="95508">
                           <a14:foregroundMark x1="36967" y1="30558" x2="36735" y2="30971"/>
@@ -14203,11 +13673,11 @@
               <a:avLst/>
             </a:prstGeom>
             <a:blipFill dpi="0" rotWithShape="1">
-              <a:blip r:embed="rId20">
+              <a:blip r:embed="rId16">
                 <a:extLst>
                   <a:ext uri="{BEBA8EAE-BF5A-486C-A8C5-ECC9F3942E4B}">
                     <a14:imgProps xmlns:a14="http://schemas.microsoft.com/office/drawing/2010/main">
-                      <a14:imgLayer r:embed="rId16">
+                      <a14:imgLayer r:embed="rId12">
                         <a14:imgEffect>
                           <a14:artisticPaintBrush/>
                         </a14:imgEffect>
@@ -14271,11 +13741,11 @@
               <a:avLst/>
             </a:prstGeom>
             <a:blipFill dpi="0" rotWithShape="1">
-              <a:blip r:embed="rId20">
+              <a:blip r:embed="rId16">
                 <a:extLst>
                   <a:ext uri="{BEBA8EAE-BF5A-486C-A8C5-ECC9F3942E4B}">
                     <a14:imgProps xmlns:a14="http://schemas.microsoft.com/office/drawing/2010/main">
-                      <a14:imgLayer r:embed="rId16">
+                      <a14:imgLayer r:embed="rId12">
                         <a14:imgEffect>
                           <a14:artisticPaintBrush/>
                         </a14:imgEffect>
@@ -14339,11 +13809,11 @@
               <a:avLst/>
             </a:prstGeom>
             <a:blipFill dpi="0" rotWithShape="1">
-              <a:blip r:embed="rId20">
+              <a:blip r:embed="rId16">
                 <a:extLst>
                   <a:ext uri="{BEBA8EAE-BF5A-486C-A8C5-ECC9F3942E4B}">
                     <a14:imgProps xmlns:a14="http://schemas.microsoft.com/office/drawing/2010/main">
-                      <a14:imgLayer r:embed="rId16">
+                      <a14:imgLayer r:embed="rId12">
                         <a14:imgEffect>
                           <a14:artisticPaintBrush/>
                         </a14:imgEffect>
@@ -14407,11 +13877,11 @@
               <a:avLst/>
             </a:prstGeom>
             <a:blipFill dpi="0" rotWithShape="1">
-              <a:blip r:embed="rId20">
+              <a:blip r:embed="rId16">
                 <a:extLst>
                   <a:ext uri="{BEBA8EAE-BF5A-486C-A8C5-ECC9F3942E4B}">
                     <a14:imgProps xmlns:a14="http://schemas.microsoft.com/office/drawing/2010/main">
-                      <a14:imgLayer r:embed="rId16">
+                      <a14:imgLayer r:embed="rId12">
                         <a14:imgEffect>
                           <a14:artisticPaintBrush/>
                         </a14:imgEffect>
@@ -14475,11 +13945,11 @@
               <a:avLst/>
             </a:prstGeom>
             <a:blipFill dpi="0" rotWithShape="1">
-              <a:blip r:embed="rId21">
+              <a:blip r:embed="rId17">
                 <a:extLst>
                   <a:ext uri="{BEBA8EAE-BF5A-486C-A8C5-ECC9F3942E4B}">
                     <a14:imgProps xmlns:a14="http://schemas.microsoft.com/office/drawing/2010/main">
-                      <a14:imgLayer r:embed="rId16">
+                      <a14:imgLayer r:embed="rId12">
                         <a14:imgEffect>
                           <a14:artisticWatercolorSponge/>
                         </a14:imgEffect>
@@ -14543,11 +14013,11 @@
               <a:avLst/>
             </a:prstGeom>
             <a:blipFill dpi="0" rotWithShape="1">
-              <a:blip r:embed="rId20">
+              <a:blip r:embed="rId16">
                 <a:extLst>
                   <a:ext uri="{BEBA8EAE-BF5A-486C-A8C5-ECC9F3942E4B}">
                     <a14:imgProps xmlns:a14="http://schemas.microsoft.com/office/drawing/2010/main">
-                      <a14:imgLayer r:embed="rId16">
+                      <a14:imgLayer r:embed="rId12">
                         <a14:imgEffect>
                           <a14:artisticPaintBrush/>
                         </a14:imgEffect>
@@ -14577,6 +14047,537 @@
             </a:effectRef>
             <a:fontRef idx="minor">
               <a:schemeClr val="lt1"/>
+            </a:fontRef>
+          </p:style>
+          <p:txBody>
+            <a:bodyPr rtlCol="0" anchor="ctr"/>
+            <a:lstStyle/>
+            <a:p>
+              <a:pPr algn="ctr"/>
+              <a:endParaRPr lang="fr-FR"/>
+            </a:p>
+          </p:txBody>
+        </p:sp>
+      </p:grpSp>
+      <p:grpSp>
+        <p:nvGrpSpPr>
+          <p:cNvPr id="8" name="Groupe 7">
+            <a:extLst>
+              <a:ext uri="{FF2B5EF4-FFF2-40B4-BE49-F238E27FC236}">
+                <a16:creationId xmlns:a16="http://schemas.microsoft.com/office/drawing/2014/main" id="{FE771348-D763-83A0-C51D-851A82BDA552}"/>
+              </a:ext>
+            </a:extLst>
+          </p:cNvPr>
+          <p:cNvGrpSpPr/>
+          <p:nvPr/>
+        </p:nvGrpSpPr>
+        <p:grpSpPr>
+          <a:xfrm>
+            <a:off x="5995832" y="1543946"/>
+            <a:ext cx="2124000" cy="3312000"/>
+            <a:chOff x="3418344" y="1543946"/>
+            <a:chExt cx="2124000" cy="3312000"/>
+          </a:xfrm>
+        </p:grpSpPr>
+        <p:sp>
+          <p:nvSpPr>
+            <p:cNvPr id="7" name="Rectangle 6">
+              <a:extLst>
+                <a:ext uri="{FF2B5EF4-FFF2-40B4-BE49-F238E27FC236}">
+                  <a16:creationId xmlns:a16="http://schemas.microsoft.com/office/drawing/2014/main" id="{6128C7DA-C656-8691-BDA2-09EC288B8E64}"/>
+                </a:ext>
+              </a:extLst>
+            </p:cNvPr>
+            <p:cNvSpPr/>
+            <p:nvPr/>
+          </p:nvSpPr>
+          <p:spPr>
+            <a:xfrm>
+              <a:off x="3418344" y="1543946"/>
+              <a:ext cx="2124000" cy="3312000"/>
+            </a:xfrm>
+            <a:prstGeom prst="rect">
+              <a:avLst/>
+            </a:prstGeom>
+            <a:blipFill dpi="0" rotWithShape="1">
+              <a:blip r:embed="rId2">
+                <a:alphaModFix amt="75000"/>
+              </a:blip>
+              <a:srcRect/>
+              <a:tile tx="0" ty="0" sx="100000" sy="100000" flip="none" algn="tl"/>
+            </a:blipFill>
+          </p:spPr>
+          <p:style>
+            <a:lnRef idx="2">
+              <a:schemeClr val="accent1">
+                <a:shade val="15000"/>
+              </a:schemeClr>
+            </a:lnRef>
+            <a:fillRef idx="1">
+              <a:schemeClr val="accent1"/>
+            </a:fillRef>
+            <a:effectRef idx="0">
+              <a:schemeClr val="accent1"/>
+            </a:effectRef>
+            <a:fontRef idx="minor">
+              <a:schemeClr val="lt1"/>
+            </a:fontRef>
+          </p:style>
+          <p:txBody>
+            <a:bodyPr rtlCol="0" anchor="ctr"/>
+            <a:lstStyle/>
+            <a:p>
+              <a:pPr algn="ctr"/>
+              <a:endParaRPr lang="fr-FR"/>
+            </a:p>
+          </p:txBody>
+        </p:sp>
+        <p:sp>
+          <p:nvSpPr>
+            <p:cNvPr id="11" name="Rectangle 10">
+              <a:extLst>
+                <a:ext uri="{FF2B5EF4-FFF2-40B4-BE49-F238E27FC236}">
+                  <a16:creationId xmlns:a16="http://schemas.microsoft.com/office/drawing/2014/main" id="{D97EABB2-F73F-D0D9-4412-7C9BB8CF8FEE}"/>
+                </a:ext>
+              </a:extLst>
+            </p:cNvPr>
+            <p:cNvSpPr/>
+            <p:nvPr/>
+          </p:nvSpPr>
+          <p:spPr>
+            <a:xfrm>
+              <a:off x="3418344" y="1543946"/>
+              <a:ext cx="2124000" cy="432000"/>
+            </a:xfrm>
+            <a:prstGeom prst="rect">
+              <a:avLst/>
+            </a:prstGeom>
+            <a:blipFill>
+              <a:blip r:embed="rId3">
+                <a:extLst>
+                  <a:ext uri="{BEBA8EAE-BF5A-486C-A8C5-ECC9F3942E4B}">
+                    <a14:imgProps xmlns:a14="http://schemas.microsoft.com/office/drawing/2010/main">
+                      <a14:imgLayer r:embed="rId4">
+                        <a14:imgEffect>
+                          <a14:artisticWatercolorSponge/>
+                        </a14:imgEffect>
+                      </a14:imgLayer>
+                    </a14:imgProps>
+                  </a:ext>
+                </a:extLst>
+              </a:blip>
+              <a:tile tx="0" ty="0" sx="100000" sy="100000" flip="none" algn="tl"/>
+            </a:blipFill>
+          </p:spPr>
+          <p:style>
+            <a:lnRef idx="2">
+              <a:schemeClr val="accent1">
+                <a:shade val="15000"/>
+              </a:schemeClr>
+            </a:lnRef>
+            <a:fillRef idx="1">
+              <a:schemeClr val="accent1"/>
+            </a:fillRef>
+            <a:effectRef idx="0">
+              <a:schemeClr val="accent1"/>
+            </a:effectRef>
+            <a:fontRef idx="minor">
+              <a:schemeClr val="lt1"/>
+            </a:fontRef>
+          </p:style>
+          <p:txBody>
+            <a:bodyPr lIns="0" rIns="0" rtlCol="0" anchor="ctr"/>
+            <a:lstStyle/>
+            <a:p>
+              <a:pPr algn="ctr"/>
+              <a:r>
+                <a:rPr lang="fr-FR" sz="1600" b="1" dirty="0">
+                  <a:solidFill>
+                    <a:schemeClr val="tx1"/>
+                  </a:solidFill>
+                  <a:latin typeface="Segoe UI" panose="020B0502040204020203" pitchFamily="34" charset="0"/>
+                  <a:cs typeface="Segoe UI" panose="020B0502040204020203" pitchFamily="34" charset="0"/>
+                </a:rPr>
+                <a:t>Chevauchée lointaine</a:t>
+              </a:r>
+            </a:p>
+          </p:txBody>
+        </p:sp>
+        <p:sp>
+          <p:nvSpPr>
+            <p:cNvPr id="12" name="Cercle : creux 11">
+              <a:extLst>
+                <a:ext uri="{FF2B5EF4-FFF2-40B4-BE49-F238E27FC236}">
+                  <a16:creationId xmlns:a16="http://schemas.microsoft.com/office/drawing/2014/main" id="{897FE0C3-3ADF-7943-E285-761B07A5B081}"/>
+                </a:ext>
+              </a:extLst>
+            </p:cNvPr>
+            <p:cNvSpPr/>
+            <p:nvPr/>
+          </p:nvSpPr>
+          <p:spPr>
+            <a:xfrm>
+              <a:off x="3494074" y="4393905"/>
+              <a:ext cx="360000" cy="360000"/>
+            </a:xfrm>
+            <a:prstGeom prst="donut">
+              <a:avLst>
+                <a:gd name="adj" fmla="val 15271"/>
+              </a:avLst>
+            </a:prstGeom>
+            <a:blipFill>
+              <a:blip r:embed="rId5"/>
+              <a:tile tx="0" ty="0" sx="100000" sy="100000" flip="none" algn="tl"/>
+            </a:blipFill>
+            <a:ln w="12700"/>
+          </p:spPr>
+          <p:style>
+            <a:lnRef idx="2">
+              <a:schemeClr val="dk1">
+                <a:shade val="15000"/>
+              </a:schemeClr>
+            </a:lnRef>
+            <a:fillRef idx="1">
+              <a:schemeClr val="dk1"/>
+            </a:fillRef>
+            <a:effectRef idx="0">
+              <a:schemeClr val="dk1"/>
+            </a:effectRef>
+            <a:fontRef idx="minor">
+              <a:schemeClr val="lt1"/>
+            </a:fontRef>
+          </p:style>
+          <p:txBody>
+            <a:bodyPr rtlCol="0" anchor="ctr"/>
+            <a:lstStyle/>
+            <a:p>
+              <a:pPr algn="ctr"/>
+              <a:r>
+                <a:rPr lang="fr-FR" b="1" dirty="0">
+                  <a:solidFill>
+                    <a:schemeClr val="tx1"/>
+                  </a:solidFill>
+                  <a:latin typeface="Segoe UI" panose="020B0502040204020203" pitchFamily="34" charset="0"/>
+                  <a:cs typeface="Segoe UI" panose="020B0502040204020203" pitchFamily="34" charset="0"/>
+                </a:rPr>
+                <a:t>3</a:t>
+              </a:r>
+            </a:p>
+          </p:txBody>
+        </p:sp>
+        <p:sp>
+          <p:nvSpPr>
+            <p:cNvPr id="13" name="ZoneTexte 12">
+              <a:extLst>
+                <a:ext uri="{FF2B5EF4-FFF2-40B4-BE49-F238E27FC236}">
+                  <a16:creationId xmlns:a16="http://schemas.microsoft.com/office/drawing/2014/main" id="{500A76FA-93FC-67C4-C0BC-9F88B60C266C}"/>
+                </a:ext>
+              </a:extLst>
+            </p:cNvPr>
+            <p:cNvSpPr txBox="1"/>
+            <p:nvPr/>
+          </p:nvSpPr>
+          <p:spPr>
+            <a:xfrm>
+              <a:off x="3518594" y="2060755"/>
+              <a:ext cx="1923499" cy="646331"/>
+            </a:xfrm>
+            <a:prstGeom prst="rect">
+              <a:avLst/>
+            </a:prstGeom>
+            <a:noFill/>
+          </p:spPr>
+          <p:txBody>
+            <a:bodyPr wrap="square" rtlCol="0">
+              <a:spAutoFit/>
+            </a:bodyPr>
+            <a:lstStyle/>
+            <a:p>
+              <a:pPr algn="just">
+                <a:spcAft>
+                  <a:spcPts val="600"/>
+                </a:spcAft>
+              </a:pPr>
+              <a:r>
+                <a:rPr lang="fr-FR" sz="1200" b="1" dirty="0">
+                  <a:latin typeface="Segoe UI" panose="020B0502040204020203" pitchFamily="34" charset="0"/>
+                  <a:cs typeface="Segoe UI" panose="020B0502040204020203" pitchFamily="34" charset="0"/>
+                </a:rPr>
+                <a:t>Déplacer un baron ou un chevalier d’autant de tuiles que vous voulez</a:t>
+              </a:r>
+            </a:p>
+          </p:txBody>
+        </p:sp>
+        <p:pic>
+          <p:nvPicPr>
+            <p:cNvPr id="14" name="Image 13" descr="Une image contenant peinture, dessin, Fournitures pour cheval, Rêne&#10;&#10;Le contenu généré par l’IA peut être incorrect.">
+              <a:extLst>
+                <a:ext uri="{FF2B5EF4-FFF2-40B4-BE49-F238E27FC236}">
+                  <a16:creationId xmlns:a16="http://schemas.microsoft.com/office/drawing/2014/main" id="{BFA3B552-9E59-28BA-38DF-C3B383B3C9E5}"/>
+                </a:ext>
+              </a:extLst>
+            </p:cNvPr>
+            <p:cNvPicPr>
+              <a:picLocks noChangeAspect="1"/>
+            </p:cNvPicPr>
+            <p:nvPr/>
+          </p:nvPicPr>
+          <p:blipFill>
+            <a:blip r:embed="rId18">
+              <a:duotone>
+                <a:prstClr val="black"/>
+                <a:srgbClr val="ECF3C9">
+                  <a:tint val="45000"/>
+                  <a:satMod val="400000"/>
+                </a:srgbClr>
+              </a:duotone>
+              <a:extLst>
+                <a:ext uri="{BEBA8EAE-BF5A-486C-A8C5-ECC9F3942E4B}">
+                  <a14:imgProps xmlns:a14="http://schemas.microsoft.com/office/drawing/2010/main">
+                    <a14:imgLayer r:embed="rId19">
+                      <a14:imgEffect>
+                        <a14:backgroundRemoval t="10000" b="90000" l="10000" r="90000">
+                          <a14:foregroundMark x1="51367" y1="73438" x2="51563" y2="73535"/>
+                          <a14:foregroundMark x1="51074" y1="74414" x2="51367" y2="74316"/>
+                          <a14:foregroundMark x1="50879" y1="74512" x2="50977" y2="74512"/>
+                          <a14:foregroundMark x1="50684" y1="75000" x2="50293" y2="75098"/>
+                          <a14:foregroundMark x1="50293" y1="73340" x2="50977" y2="73438"/>
+                          <a14:backgroundMark x1="10547" y1="41699" x2="20801" y2="33301"/>
+                          <a14:backgroundMark x1="20801" y1="33301" x2="35156" y2="40137"/>
+                          <a14:backgroundMark x1="35156" y1="40137" x2="42676" y2="46875"/>
+                          <a14:backgroundMark x1="42676" y1="46875" x2="42969" y2="75000"/>
+                          <a14:backgroundMark x1="42969" y1="75000" x2="46680" y2="83008"/>
+                          <a14:backgroundMark x1="46680" y1="83008" x2="25293" y2="88965"/>
+                          <a14:backgroundMark x1="25293" y1="88965" x2="10547" y2="76660"/>
+                          <a14:backgroundMark x1="10547" y1="76660" x2="8789" y2="43359"/>
+                          <a14:backgroundMark x1="8789" y1="43359" x2="12402" y2="41113"/>
+                          <a14:backgroundMark x1="78516" y1="44043" x2="80957" y2="51074"/>
+                          <a14:backgroundMark x1="80957" y1="51074" x2="88867" y2="51855"/>
+                          <a14:backgroundMark x1="88867" y1="51855" x2="93457" y2="43750"/>
+                          <a14:backgroundMark x1="93457" y1="43750" x2="82520" y2="41602"/>
+                          <a14:backgroundMark x1="82520" y1="41602" x2="78418" y2="44141"/>
+                          <a14:backgroundMark x1="47949" y1="64063" x2="50684" y2="72070"/>
+                          <a14:backgroundMark x1="50099" y1="74840" x2="49219" y2="79004"/>
+                          <a14:backgroundMark x1="50684" y1="72070" x2="50200" y2="74360"/>
+                          <a14:backgroundMark x1="49219" y1="79004" x2="54590" y2="73145"/>
+                          <a14:backgroundMark x1="54590" y1="73145" x2="53418" y2="66211"/>
+                          <a14:backgroundMark x1="46387" y1="80566" x2="59863" y2="78906"/>
+                          <a14:backgroundMark x1="59863" y1="78906" x2="60449" y2="67285"/>
+                          <a14:backgroundMark x1="60449" y1="67285" x2="57910" y2="59961"/>
+                          <a14:backgroundMark x1="57910" y1="59961" x2="57910" y2="59766"/>
+                          <a14:backgroundMark x1="61230" y1="68066" x2="68066" y2="73633"/>
+                          <a14:backgroundMark x1="68066" y1="73633" x2="65234" y2="86914"/>
+                          <a14:backgroundMark x1="65234" y1="86914" x2="51660" y2="89844"/>
+                          <a14:backgroundMark x1="51660" y1="89844" x2="44629" y2="87500"/>
+                          <a14:backgroundMark x1="44629" y1="87500" x2="52539" y2="80273"/>
+                          <a14:backgroundMark x1="52539" y1="80273" x2="59473" y2="78809"/>
+                          <a14:backgroundMark x1="59473" y1="78809" x2="62402" y2="70410"/>
+                          <a14:backgroundMark x1="62402" y1="70410" x2="61914" y2="68652"/>
+                          <a14:backgroundMark x1="73047" y1="67773" x2="73047" y2="70508"/>
+                          <a14:backgroundMark x1="73242" y1="74023" x2="73242" y2="74023"/>
+                          <a14:backgroundMark x1="79004" y1="66113" x2="77051" y2="85547"/>
+                          <a14:backgroundMark x1="85254" y1="60742" x2="88184" y2="76953"/>
+                          <a14:backgroundMark x1="88184" y1="76953" x2="80273" y2="77832"/>
+                          <a14:backgroundMark x1="80273" y1="77832" x2="87305" y2="65918"/>
+                          <a14:backgroundMark x1="67480" y1="15918" x2="67480" y2="15918"/>
+                          <a14:backgroundMark x1="87988" y1="59082" x2="87988" y2="59082"/>
+                          <a14:backgroundMark x1="84375" y1="58594" x2="84375" y2="58594"/>
+                          <a14:backgroundMark x1="83594" y1="58105" x2="83594" y2="58105"/>
+                          <a14:backgroundMark x1="85742" y1="57910" x2="85742" y2="57910"/>
+                          <a14:backgroundMark x1="86914" y1="55859" x2="86914" y2="55859"/>
+                          <a14:backgroundMark x1="45410" y1="36816" x2="45410" y2="36816"/>
+                          <a14:backgroundMark x1="46387" y1="35059" x2="46387" y2="35059"/>
+                        </a14:backgroundRemoval>
+                      </a14:imgEffect>
+                      <a14:imgEffect>
+                        <a14:brightnessContrast bright="40000" contrast="-40000"/>
+                      </a14:imgEffect>
+                    </a14:imgLayer>
+                  </a14:imgProps>
+                </a:ext>
+                <a:ext uri="{28A0092B-C50C-407E-A947-70E740481C1C}">
+                  <a14:useLocalDpi xmlns:a14="http://schemas.microsoft.com/office/drawing/2010/main" val="0"/>
+                </a:ext>
+              </a:extLst>
+            </a:blip>
+            <a:srcRect l="39260" t="12963" r="9752" b="49602"/>
+            <a:stretch>
+              <a:fillRect/>
+            </a:stretch>
+          </p:blipFill>
+          <p:spPr>
+            <a:xfrm flipH="1">
+              <a:off x="3629932" y="2791895"/>
+              <a:ext cx="1564884" cy="1148912"/>
+            </a:xfrm>
+            <a:prstGeom prst="rect">
+              <a:avLst/>
+            </a:prstGeom>
+          </p:spPr>
+        </p:pic>
+        <p:sp>
+          <p:nvSpPr>
+            <p:cNvPr id="16" name="Hexagone 15">
+              <a:extLst>
+                <a:ext uri="{FF2B5EF4-FFF2-40B4-BE49-F238E27FC236}">
+                  <a16:creationId xmlns:a16="http://schemas.microsoft.com/office/drawing/2014/main" id="{B35F99C8-D390-D543-C59F-73896BA37C2D}"/>
+                </a:ext>
+              </a:extLst>
+            </p:cNvPr>
+            <p:cNvSpPr/>
+            <p:nvPr/>
+          </p:nvSpPr>
+          <p:spPr>
+            <a:xfrm rot="5400000">
+              <a:off x="4816816" y="4309559"/>
+              <a:ext cx="396000" cy="360000"/>
+            </a:xfrm>
+            <a:prstGeom prst="hexagon">
+              <a:avLst/>
+            </a:prstGeom>
+            <a:blipFill>
+              <a:blip r:embed="rId20">
+                <a:extLst>
+                  <a:ext uri="{BEBA8EAE-BF5A-486C-A8C5-ECC9F3942E4B}">
+                    <a14:imgProps xmlns:a14="http://schemas.microsoft.com/office/drawing/2010/main">
+                      <a14:imgLayer r:embed="rId21">
+                        <a14:imgEffect>
+                          <a14:brightnessContrast bright="-20000" contrast="-40000"/>
+                        </a14:imgEffect>
+                      </a14:imgLayer>
+                    </a14:imgProps>
+                  </a:ext>
+                </a:extLst>
+              </a:blip>
+              <a:tile tx="0" ty="0" sx="100000" sy="100000" flip="none" algn="tl"/>
+            </a:blipFill>
+            <a:ln w="12700">
+              <a:solidFill>
+                <a:schemeClr val="tx1"/>
+              </a:solidFill>
+            </a:ln>
+          </p:spPr>
+          <p:style>
+            <a:lnRef idx="2">
+              <a:schemeClr val="accent1">
+                <a:shade val="15000"/>
+              </a:schemeClr>
+            </a:lnRef>
+            <a:fillRef idx="1">
+              <a:schemeClr val="accent1"/>
+            </a:fillRef>
+            <a:effectRef idx="0">
+              <a:schemeClr val="accent1"/>
+            </a:effectRef>
+            <a:fontRef idx="minor">
+              <a:schemeClr val="lt1"/>
+            </a:fontRef>
+          </p:style>
+          <p:txBody>
+            <a:bodyPr rtlCol="0" anchor="ctr"/>
+            <a:lstStyle/>
+            <a:p>
+              <a:pPr algn="ctr"/>
+              <a:endParaRPr lang="fr-FR"/>
+            </a:p>
+          </p:txBody>
+        </p:sp>
+        <p:sp>
+          <p:nvSpPr>
+            <p:cNvPr id="17" name="Hexagone 16">
+              <a:extLst>
+                <a:ext uri="{FF2B5EF4-FFF2-40B4-BE49-F238E27FC236}">
+                  <a16:creationId xmlns:a16="http://schemas.microsoft.com/office/drawing/2014/main" id="{2A6B8627-0025-FC3E-AA62-AAE10CCF5769}"/>
+                </a:ext>
+              </a:extLst>
+            </p:cNvPr>
+            <p:cNvSpPr/>
+            <p:nvPr/>
+          </p:nvSpPr>
+          <p:spPr>
+            <a:xfrm rot="5400000">
+              <a:off x="3998266" y="4309559"/>
+              <a:ext cx="396000" cy="360000"/>
+            </a:xfrm>
+            <a:prstGeom prst="hexagon">
+              <a:avLst/>
+            </a:prstGeom>
+            <a:solidFill>
+              <a:schemeClr val="bg1"/>
+            </a:solidFill>
+            <a:ln w="12700">
+              <a:solidFill>
+                <a:schemeClr val="tx1"/>
+              </a:solidFill>
+            </a:ln>
+          </p:spPr>
+          <p:style>
+            <a:lnRef idx="2">
+              <a:schemeClr val="accent1">
+                <a:shade val="15000"/>
+              </a:schemeClr>
+            </a:lnRef>
+            <a:fillRef idx="1">
+              <a:schemeClr val="accent1"/>
+            </a:fillRef>
+            <a:effectRef idx="0">
+              <a:schemeClr val="accent1"/>
+            </a:effectRef>
+            <a:fontRef idx="minor">
+              <a:schemeClr val="lt1"/>
+            </a:fontRef>
+          </p:style>
+          <p:txBody>
+            <a:bodyPr rtlCol="0" anchor="ctr"/>
+            <a:lstStyle/>
+            <a:p>
+              <a:pPr algn="ctr"/>
+              <a:endParaRPr lang="fr-FR"/>
+            </a:p>
+          </p:txBody>
+        </p:sp>
+        <p:sp>
+          <p:nvSpPr>
+            <p:cNvPr id="19" name="Arc 18">
+              <a:extLst>
+                <a:ext uri="{FF2B5EF4-FFF2-40B4-BE49-F238E27FC236}">
+                  <a16:creationId xmlns:a16="http://schemas.microsoft.com/office/drawing/2014/main" id="{B3212AA8-FF38-B6ED-08FA-FFC2892B0788}"/>
+                </a:ext>
+              </a:extLst>
+            </p:cNvPr>
+            <p:cNvSpPr/>
+            <p:nvPr/>
+          </p:nvSpPr>
+          <p:spPr>
+            <a:xfrm>
+              <a:off x="4185203" y="4249185"/>
+              <a:ext cx="859018" cy="568661"/>
+            </a:xfrm>
+            <a:prstGeom prst="arc">
+              <a:avLst>
+                <a:gd name="adj1" fmla="val 11337146"/>
+                <a:gd name="adj2" fmla="val 8076"/>
+              </a:avLst>
+            </a:prstGeom>
+            <a:ln w="50800">
+              <a:solidFill>
+                <a:schemeClr val="tx1"/>
+              </a:solidFill>
+              <a:tailEnd type="triangle" w="med" len="med"/>
+            </a:ln>
+          </p:spPr>
+          <p:style>
+            <a:lnRef idx="2">
+              <a:schemeClr val="accent1"/>
+            </a:lnRef>
+            <a:fillRef idx="0">
+              <a:schemeClr val="accent1"/>
+            </a:fillRef>
+            <a:effectRef idx="1">
+              <a:schemeClr val="accent1"/>
+            </a:effectRef>
+            <a:fontRef idx="minor">
+              <a:schemeClr val="tx1"/>
             </a:fontRef>
           </p:style>
           <p:txBody>
@@ -16617,6 +16618,891 @@
     <p:extLst>
       <p:ext uri="{BB962C8B-B14F-4D97-AF65-F5344CB8AC3E}">
         <p14:creationId xmlns:p14="http://schemas.microsoft.com/office/powerpoint/2010/main" val="4209361346"/>
+      </p:ext>
+    </p:extLst>
+  </p:cSld>
+  <p:clrMapOvr>
+    <a:masterClrMapping/>
+  </p:clrMapOvr>
+</p:sld>
+</file>
+
+<file path=ppt/slides/slide7.xml><?xml version="1.0" encoding="utf-8"?>
+<p:sld xmlns:a="http://schemas.openxmlformats.org/drawingml/2006/main" xmlns:r="http://schemas.openxmlformats.org/officeDocument/2006/relationships" xmlns:p="http://schemas.openxmlformats.org/presentationml/2006/main">
+  <p:cSld>
+    <p:spTree>
+      <p:nvGrpSpPr>
+        <p:cNvPr id="1" name="">
+          <a:extLst>
+            <a:ext uri="{FF2B5EF4-FFF2-40B4-BE49-F238E27FC236}">
+              <a16:creationId xmlns:a16="http://schemas.microsoft.com/office/drawing/2014/main" id="{1BA97D16-D92A-53B1-BA09-B702E1C90C5B}"/>
+            </a:ext>
+          </a:extLst>
+        </p:cNvPr>
+        <p:cNvGrpSpPr/>
+        <p:nvPr/>
+      </p:nvGrpSpPr>
+      <p:grpSpPr>
+        <a:xfrm>
+          <a:off x="0" y="0"/>
+          <a:ext cx="0" cy="0"/>
+          <a:chOff x="0" y="0"/>
+          <a:chExt cx="0" cy="0"/>
+        </a:xfrm>
+      </p:grpSpPr>
+      <p:grpSp>
+        <p:nvGrpSpPr>
+          <p:cNvPr id="134" name="Groupe 133">
+            <a:extLst>
+              <a:ext uri="{FF2B5EF4-FFF2-40B4-BE49-F238E27FC236}">
+                <a16:creationId xmlns:a16="http://schemas.microsoft.com/office/drawing/2014/main" id="{8197B654-E2F4-A614-69C4-2E8C211522F2}"/>
+              </a:ext>
+            </a:extLst>
+          </p:cNvPr>
+          <p:cNvGrpSpPr/>
+          <p:nvPr/>
+        </p:nvGrpSpPr>
+        <p:grpSpPr>
+          <a:xfrm>
+            <a:off x="1336612" y="1773000"/>
+            <a:ext cx="2124000" cy="3312000"/>
+            <a:chOff x="1336612" y="1773000"/>
+            <a:chExt cx="2124000" cy="3312000"/>
+          </a:xfrm>
+        </p:grpSpPr>
+        <p:sp>
+          <p:nvSpPr>
+            <p:cNvPr id="4" name="Rectangle 3">
+              <a:extLst>
+                <a:ext uri="{FF2B5EF4-FFF2-40B4-BE49-F238E27FC236}">
+                  <a16:creationId xmlns:a16="http://schemas.microsoft.com/office/drawing/2014/main" id="{877516E0-138E-3B87-A2BC-53D966977BE0}"/>
+                </a:ext>
+              </a:extLst>
+            </p:cNvPr>
+            <p:cNvSpPr/>
+            <p:nvPr/>
+          </p:nvSpPr>
+          <p:spPr>
+            <a:xfrm>
+              <a:off x="1336612" y="1773000"/>
+              <a:ext cx="2124000" cy="3312000"/>
+            </a:xfrm>
+            <a:prstGeom prst="rect">
+              <a:avLst/>
+            </a:prstGeom>
+            <a:blipFill dpi="0" rotWithShape="1">
+              <a:blip r:embed="rId2"/>
+              <a:srcRect/>
+              <a:tile tx="0" ty="0" sx="100000" sy="100000" flip="none" algn="tl"/>
+            </a:blipFill>
+          </p:spPr>
+          <p:style>
+            <a:lnRef idx="2">
+              <a:schemeClr val="accent1">
+                <a:shade val="15000"/>
+              </a:schemeClr>
+            </a:lnRef>
+            <a:fillRef idx="1">
+              <a:schemeClr val="accent1"/>
+            </a:fillRef>
+            <a:effectRef idx="0">
+              <a:schemeClr val="accent1"/>
+            </a:effectRef>
+            <a:fontRef idx="minor">
+              <a:schemeClr val="lt1"/>
+            </a:fontRef>
+          </p:style>
+          <p:txBody>
+            <a:bodyPr rtlCol="0" anchor="ctr"/>
+            <a:lstStyle/>
+            <a:p>
+              <a:pPr algn="ctr"/>
+              <a:endParaRPr lang="fr-FR"/>
+            </a:p>
+          </p:txBody>
+        </p:sp>
+        <p:pic>
+          <p:nvPicPr>
+            <p:cNvPr id="2" name="Image 1">
+              <a:extLst>
+                <a:ext uri="{FF2B5EF4-FFF2-40B4-BE49-F238E27FC236}">
+                  <a16:creationId xmlns:a16="http://schemas.microsoft.com/office/drawing/2014/main" id="{7C0E9DF3-C374-ECE8-83DB-4EF846F17B81}"/>
+                </a:ext>
+              </a:extLst>
+            </p:cNvPr>
+            <p:cNvPicPr>
+              <a:picLocks noChangeAspect="1"/>
+            </p:cNvPicPr>
+            <p:nvPr/>
+          </p:nvPicPr>
+          <p:blipFill>
+            <a:blip r:embed="rId3"/>
+            <a:stretch>
+              <a:fillRect/>
+            </a:stretch>
+          </p:blipFill>
+          <p:spPr>
+            <a:xfrm>
+              <a:off x="1431700" y="1997262"/>
+              <a:ext cx="415785" cy="360000"/>
+            </a:xfrm>
+            <a:prstGeom prst="rect">
+              <a:avLst/>
+            </a:prstGeom>
+          </p:spPr>
+        </p:pic>
+        <p:pic>
+          <p:nvPicPr>
+            <p:cNvPr id="10" name="Image 9">
+              <a:extLst>
+                <a:ext uri="{FF2B5EF4-FFF2-40B4-BE49-F238E27FC236}">
+                  <a16:creationId xmlns:a16="http://schemas.microsoft.com/office/drawing/2014/main" id="{250DBF72-03BE-152A-4B8D-D65206F99018}"/>
+                </a:ext>
+              </a:extLst>
+            </p:cNvPr>
+            <p:cNvPicPr>
+              <a:picLocks noChangeAspect="1"/>
+            </p:cNvPicPr>
+            <p:nvPr/>
+          </p:nvPicPr>
+          <p:blipFill>
+            <a:blip r:embed="rId4"/>
+            <a:stretch>
+              <a:fillRect/>
+            </a:stretch>
+          </p:blipFill>
+          <p:spPr>
+            <a:xfrm>
+              <a:off x="1414772" y="2450423"/>
+              <a:ext cx="415785" cy="360000"/>
+            </a:xfrm>
+            <a:prstGeom prst="rect">
+              <a:avLst/>
+            </a:prstGeom>
+          </p:spPr>
+        </p:pic>
+        <p:pic>
+          <p:nvPicPr>
+            <p:cNvPr id="15" name="Image 14">
+              <a:extLst>
+                <a:ext uri="{FF2B5EF4-FFF2-40B4-BE49-F238E27FC236}">
+                  <a16:creationId xmlns:a16="http://schemas.microsoft.com/office/drawing/2014/main" id="{A4B71B59-ADCD-0C16-D359-7088AC9C5BA7}"/>
+                </a:ext>
+              </a:extLst>
+            </p:cNvPr>
+            <p:cNvPicPr>
+              <a:picLocks noChangeAspect="1"/>
+            </p:cNvPicPr>
+            <p:nvPr/>
+          </p:nvPicPr>
+          <p:blipFill>
+            <a:blip r:embed="rId5"/>
+            <a:stretch>
+              <a:fillRect/>
+            </a:stretch>
+          </p:blipFill>
+          <p:spPr>
+            <a:xfrm>
+              <a:off x="2017273" y="2313583"/>
+              <a:ext cx="415909" cy="360000"/>
+            </a:xfrm>
+            <a:prstGeom prst="rect">
+              <a:avLst/>
+            </a:prstGeom>
+          </p:spPr>
+        </p:pic>
+        <p:pic>
+          <p:nvPicPr>
+            <p:cNvPr id="17" name="Image 16">
+              <a:extLst>
+                <a:ext uri="{FF2B5EF4-FFF2-40B4-BE49-F238E27FC236}">
+                  <a16:creationId xmlns:a16="http://schemas.microsoft.com/office/drawing/2014/main" id="{329C4BC3-A789-5F71-072D-C79BCEF505DB}"/>
+                </a:ext>
+              </a:extLst>
+            </p:cNvPr>
+            <p:cNvPicPr>
+              <a:picLocks noChangeAspect="1"/>
+            </p:cNvPicPr>
+            <p:nvPr/>
+          </p:nvPicPr>
+          <p:blipFill>
+            <a:blip r:embed="rId6"/>
+            <a:stretch>
+              <a:fillRect/>
+            </a:stretch>
+          </p:blipFill>
+          <p:spPr>
+            <a:xfrm>
+              <a:off x="1470817" y="3430581"/>
+              <a:ext cx="415785" cy="360000"/>
+            </a:xfrm>
+            <a:prstGeom prst="rect">
+              <a:avLst/>
+            </a:prstGeom>
+          </p:spPr>
+        </p:pic>
+        <p:pic>
+          <p:nvPicPr>
+            <p:cNvPr id="18" name="Image 17">
+              <a:extLst>
+                <a:ext uri="{FF2B5EF4-FFF2-40B4-BE49-F238E27FC236}">
+                  <a16:creationId xmlns:a16="http://schemas.microsoft.com/office/drawing/2014/main" id="{BDA581E9-F9A3-3A2B-317D-16EEED29B07A}"/>
+                </a:ext>
+              </a:extLst>
+            </p:cNvPr>
+            <p:cNvPicPr>
+              <a:picLocks noChangeAspect="1"/>
+            </p:cNvPicPr>
+            <p:nvPr/>
+          </p:nvPicPr>
+          <p:blipFill>
+            <a:blip r:embed="rId3"/>
+            <a:stretch>
+              <a:fillRect/>
+            </a:stretch>
+          </p:blipFill>
+          <p:spPr>
+            <a:xfrm>
+              <a:off x="1567885" y="2954309"/>
+              <a:ext cx="415785" cy="360000"/>
+            </a:xfrm>
+            <a:prstGeom prst="rect">
+              <a:avLst/>
+            </a:prstGeom>
+          </p:spPr>
+        </p:pic>
+        <p:pic>
+          <p:nvPicPr>
+            <p:cNvPr id="20" name="Image 19">
+              <a:extLst>
+                <a:ext uri="{FF2B5EF4-FFF2-40B4-BE49-F238E27FC236}">
+                  <a16:creationId xmlns:a16="http://schemas.microsoft.com/office/drawing/2014/main" id="{BEE48979-DD8D-8B92-AFEC-950E3F8B632A}"/>
+                </a:ext>
+              </a:extLst>
+            </p:cNvPr>
+            <p:cNvPicPr>
+              <a:picLocks noChangeAspect="1"/>
+            </p:cNvPicPr>
+            <p:nvPr/>
+          </p:nvPicPr>
+          <p:blipFill>
+            <a:blip r:embed="rId4"/>
+            <a:stretch>
+              <a:fillRect/>
+            </a:stretch>
+          </p:blipFill>
+          <p:spPr>
+            <a:xfrm>
+              <a:off x="1986530" y="3290171"/>
+              <a:ext cx="415785" cy="360000"/>
+            </a:xfrm>
+            <a:prstGeom prst="rect">
+              <a:avLst/>
+            </a:prstGeom>
+          </p:spPr>
+        </p:pic>
+        <p:pic>
+          <p:nvPicPr>
+            <p:cNvPr id="23" name="Image 22">
+              <a:extLst>
+                <a:ext uri="{FF2B5EF4-FFF2-40B4-BE49-F238E27FC236}">
+                  <a16:creationId xmlns:a16="http://schemas.microsoft.com/office/drawing/2014/main" id="{6B50CCF9-E3C9-CFCA-E00B-537C6C139D73}"/>
+                </a:ext>
+              </a:extLst>
+            </p:cNvPr>
+            <p:cNvPicPr>
+              <a:picLocks noChangeAspect="1"/>
+            </p:cNvPicPr>
+            <p:nvPr/>
+          </p:nvPicPr>
+          <p:blipFill>
+            <a:blip r:embed="rId6"/>
+            <a:stretch>
+              <a:fillRect/>
+            </a:stretch>
+          </p:blipFill>
+          <p:spPr>
+            <a:xfrm>
+              <a:off x="1989046" y="3766036"/>
+              <a:ext cx="415785" cy="360000"/>
+            </a:xfrm>
+            <a:prstGeom prst="rect">
+              <a:avLst/>
+            </a:prstGeom>
+          </p:spPr>
+        </p:pic>
+        <p:pic>
+          <p:nvPicPr>
+            <p:cNvPr id="25" name="Image 24">
+              <a:extLst>
+                <a:ext uri="{FF2B5EF4-FFF2-40B4-BE49-F238E27FC236}">
+                  <a16:creationId xmlns:a16="http://schemas.microsoft.com/office/drawing/2014/main" id="{B40B2305-367D-10E9-FEB3-F078B6647D70}"/>
+                </a:ext>
+              </a:extLst>
+            </p:cNvPr>
+            <p:cNvPicPr>
+              <a:picLocks noChangeAspect="1"/>
+            </p:cNvPicPr>
+            <p:nvPr/>
+          </p:nvPicPr>
+          <p:blipFill>
+            <a:blip r:embed="rId3"/>
+            <a:stretch>
+              <a:fillRect/>
+            </a:stretch>
+          </p:blipFill>
+          <p:spPr>
+            <a:xfrm>
+              <a:off x="2486154" y="3601353"/>
+              <a:ext cx="415785" cy="360000"/>
+            </a:xfrm>
+            <a:prstGeom prst="rect">
+              <a:avLst/>
+            </a:prstGeom>
+          </p:spPr>
+        </p:pic>
+        <p:pic>
+          <p:nvPicPr>
+            <p:cNvPr id="32" name="Image 31">
+              <a:extLst>
+                <a:ext uri="{FF2B5EF4-FFF2-40B4-BE49-F238E27FC236}">
+                  <a16:creationId xmlns:a16="http://schemas.microsoft.com/office/drawing/2014/main" id="{F197A6B3-6915-6AB3-A286-4934EAA6BF44}"/>
+                </a:ext>
+              </a:extLst>
+            </p:cNvPr>
+            <p:cNvPicPr>
+              <a:picLocks noChangeAspect="1"/>
+            </p:cNvPicPr>
+            <p:nvPr/>
+          </p:nvPicPr>
+          <p:blipFill>
+            <a:blip r:embed="rId5"/>
+            <a:stretch>
+              <a:fillRect/>
+            </a:stretch>
+          </p:blipFill>
+          <p:spPr>
+            <a:xfrm>
+              <a:off x="2393714" y="4130201"/>
+              <a:ext cx="415909" cy="360000"/>
+            </a:xfrm>
+            <a:prstGeom prst="rect">
+              <a:avLst/>
+            </a:prstGeom>
+          </p:spPr>
+        </p:pic>
+        <p:pic>
+          <p:nvPicPr>
+            <p:cNvPr id="33" name="Image 32">
+              <a:extLst>
+                <a:ext uri="{FF2B5EF4-FFF2-40B4-BE49-F238E27FC236}">
+                  <a16:creationId xmlns:a16="http://schemas.microsoft.com/office/drawing/2014/main" id="{655AC0EC-15C5-C8DE-BCA8-48522EEFB583}"/>
+                </a:ext>
+              </a:extLst>
+            </p:cNvPr>
+            <p:cNvPicPr>
+              <a:picLocks noChangeAspect="1"/>
+            </p:cNvPicPr>
+            <p:nvPr/>
+          </p:nvPicPr>
+          <p:blipFill>
+            <a:blip r:embed="rId6"/>
+            <a:stretch>
+              <a:fillRect/>
+            </a:stretch>
+          </p:blipFill>
+          <p:spPr>
+            <a:xfrm>
+              <a:off x="2060920" y="4601902"/>
+              <a:ext cx="415785" cy="360000"/>
+            </a:xfrm>
+            <a:prstGeom prst="rect">
+              <a:avLst/>
+            </a:prstGeom>
+          </p:spPr>
+        </p:pic>
+        <p:pic>
+          <p:nvPicPr>
+            <p:cNvPr id="35" name="Image 34">
+              <a:extLst>
+                <a:ext uri="{FF2B5EF4-FFF2-40B4-BE49-F238E27FC236}">
+                  <a16:creationId xmlns:a16="http://schemas.microsoft.com/office/drawing/2014/main" id="{10C4DB58-7DC4-9398-F33D-41D6E0B410E4}"/>
+                </a:ext>
+              </a:extLst>
+            </p:cNvPr>
+            <p:cNvPicPr>
+              <a:picLocks noChangeAspect="1"/>
+            </p:cNvPicPr>
+            <p:nvPr/>
+          </p:nvPicPr>
+          <p:blipFill>
+            <a:blip r:embed="rId4"/>
+            <a:stretch>
+              <a:fillRect/>
+            </a:stretch>
+          </p:blipFill>
+          <p:spPr>
+            <a:xfrm>
+              <a:off x="1387493" y="3923396"/>
+              <a:ext cx="415785" cy="360000"/>
+            </a:xfrm>
+            <a:prstGeom prst="rect">
+              <a:avLst/>
+            </a:prstGeom>
+          </p:spPr>
+        </p:pic>
+        <p:pic>
+          <p:nvPicPr>
+            <p:cNvPr id="37" name="Image 36">
+              <a:extLst>
+                <a:ext uri="{FF2B5EF4-FFF2-40B4-BE49-F238E27FC236}">
+                  <a16:creationId xmlns:a16="http://schemas.microsoft.com/office/drawing/2014/main" id="{C06614DA-1BB7-DDB7-64A4-A1422B91EA3C}"/>
+                </a:ext>
+              </a:extLst>
+            </p:cNvPr>
+            <p:cNvPicPr>
+              <a:picLocks noChangeAspect="1"/>
+            </p:cNvPicPr>
+            <p:nvPr/>
+          </p:nvPicPr>
+          <p:blipFill>
+            <a:blip r:embed="rId5"/>
+            <a:stretch>
+              <a:fillRect/>
+            </a:stretch>
+          </p:blipFill>
+          <p:spPr>
+            <a:xfrm>
+              <a:off x="1387432" y="4564715"/>
+              <a:ext cx="415909" cy="360000"/>
+            </a:xfrm>
+            <a:prstGeom prst="rect">
+              <a:avLst/>
+            </a:prstGeom>
+          </p:spPr>
+        </p:pic>
+        <p:pic>
+          <p:nvPicPr>
+            <p:cNvPr id="43" name="Image 42">
+              <a:extLst>
+                <a:ext uri="{FF2B5EF4-FFF2-40B4-BE49-F238E27FC236}">
+                  <a16:creationId xmlns:a16="http://schemas.microsoft.com/office/drawing/2014/main" id="{20A4755E-E8FF-0A68-CE24-E70CEF8F8AED}"/>
+                </a:ext>
+              </a:extLst>
+            </p:cNvPr>
+            <p:cNvPicPr>
+              <a:picLocks noChangeAspect="1"/>
+            </p:cNvPicPr>
+            <p:nvPr/>
+          </p:nvPicPr>
+          <p:blipFill>
+            <a:blip r:embed="rId4"/>
+            <a:stretch>
+              <a:fillRect/>
+            </a:stretch>
+          </p:blipFill>
+          <p:spPr>
+            <a:xfrm>
+              <a:off x="2569599" y="4615137"/>
+              <a:ext cx="415785" cy="360000"/>
+            </a:xfrm>
+            <a:prstGeom prst="rect">
+              <a:avLst/>
+            </a:prstGeom>
+          </p:spPr>
+        </p:pic>
+        <p:pic>
+          <p:nvPicPr>
+            <p:cNvPr id="46" name="Image 45">
+              <a:extLst>
+                <a:ext uri="{FF2B5EF4-FFF2-40B4-BE49-F238E27FC236}">
+                  <a16:creationId xmlns:a16="http://schemas.microsoft.com/office/drawing/2014/main" id="{5C06BE25-8E71-881F-C82D-B95BD8F3A254}"/>
+                </a:ext>
+              </a:extLst>
+            </p:cNvPr>
+            <p:cNvPicPr>
+              <a:picLocks noChangeAspect="1"/>
+            </p:cNvPicPr>
+            <p:nvPr/>
+          </p:nvPicPr>
+          <p:blipFill>
+            <a:blip r:embed="rId3"/>
+            <a:stretch>
+              <a:fillRect/>
+            </a:stretch>
+          </p:blipFill>
+          <p:spPr>
+            <a:xfrm>
+              <a:off x="2433182" y="1866522"/>
+              <a:ext cx="415785" cy="360000"/>
+            </a:xfrm>
+            <a:prstGeom prst="rect">
+              <a:avLst/>
+            </a:prstGeom>
+          </p:spPr>
+        </p:pic>
+        <p:pic>
+          <p:nvPicPr>
+            <p:cNvPr id="47" name="Image 46">
+              <a:extLst>
+                <a:ext uri="{FF2B5EF4-FFF2-40B4-BE49-F238E27FC236}">
+                  <a16:creationId xmlns:a16="http://schemas.microsoft.com/office/drawing/2014/main" id="{D8B8A1E7-AAA9-093B-A211-EBB320A7C5D9}"/>
+                </a:ext>
+              </a:extLst>
+            </p:cNvPr>
+            <p:cNvPicPr>
+              <a:picLocks noChangeAspect="1"/>
+            </p:cNvPicPr>
+            <p:nvPr/>
+          </p:nvPicPr>
+          <p:blipFill>
+            <a:blip r:embed="rId4"/>
+            <a:stretch>
+              <a:fillRect/>
+            </a:stretch>
+          </p:blipFill>
+          <p:spPr>
+            <a:xfrm>
+              <a:off x="2491645" y="2398573"/>
+              <a:ext cx="415785" cy="360000"/>
+            </a:xfrm>
+            <a:prstGeom prst="rect">
+              <a:avLst/>
+            </a:prstGeom>
+          </p:spPr>
+        </p:pic>
+        <p:pic>
+          <p:nvPicPr>
+            <p:cNvPr id="48" name="Image 47">
+              <a:extLst>
+                <a:ext uri="{FF2B5EF4-FFF2-40B4-BE49-F238E27FC236}">
+                  <a16:creationId xmlns:a16="http://schemas.microsoft.com/office/drawing/2014/main" id="{A5A80953-6770-2B5E-45FB-7F21B54766CD}"/>
+                </a:ext>
+              </a:extLst>
+            </p:cNvPr>
+            <p:cNvPicPr>
+              <a:picLocks noChangeAspect="1"/>
+            </p:cNvPicPr>
+            <p:nvPr/>
+          </p:nvPicPr>
+          <p:blipFill>
+            <a:blip r:embed="rId5"/>
+            <a:stretch>
+              <a:fillRect/>
+            </a:stretch>
+          </p:blipFill>
+          <p:spPr>
+            <a:xfrm>
+              <a:off x="2491946" y="3051221"/>
+              <a:ext cx="415909" cy="360000"/>
+            </a:xfrm>
+            <a:prstGeom prst="rect">
+              <a:avLst/>
+            </a:prstGeom>
+          </p:spPr>
+        </p:pic>
+        <p:pic>
+          <p:nvPicPr>
+            <p:cNvPr id="49" name="Image 48">
+              <a:extLst>
+                <a:ext uri="{FF2B5EF4-FFF2-40B4-BE49-F238E27FC236}">
+                  <a16:creationId xmlns:a16="http://schemas.microsoft.com/office/drawing/2014/main" id="{437D484B-A536-D9AC-629C-956A7E77D5FE}"/>
+                </a:ext>
+              </a:extLst>
+            </p:cNvPr>
+            <p:cNvPicPr>
+              <a:picLocks noChangeAspect="1"/>
+            </p:cNvPicPr>
+            <p:nvPr/>
+          </p:nvPicPr>
+          <p:blipFill>
+            <a:blip r:embed="rId6"/>
+            <a:stretch>
+              <a:fillRect/>
+            </a:stretch>
+          </p:blipFill>
+          <p:spPr>
+            <a:xfrm>
+              <a:off x="2075864" y="2786797"/>
+              <a:ext cx="415785" cy="360000"/>
+            </a:xfrm>
+            <a:prstGeom prst="rect">
+              <a:avLst/>
+            </a:prstGeom>
+          </p:spPr>
+        </p:pic>
+        <p:pic>
+          <p:nvPicPr>
+            <p:cNvPr id="50" name="Image 49">
+              <a:extLst>
+                <a:ext uri="{FF2B5EF4-FFF2-40B4-BE49-F238E27FC236}">
+                  <a16:creationId xmlns:a16="http://schemas.microsoft.com/office/drawing/2014/main" id="{559053EF-E478-A66B-09E1-49933552EF22}"/>
+                </a:ext>
+              </a:extLst>
+            </p:cNvPr>
+            <p:cNvPicPr>
+              <a:picLocks noChangeAspect="1"/>
+            </p:cNvPicPr>
+            <p:nvPr/>
+          </p:nvPicPr>
+          <p:blipFill>
+            <a:blip r:embed="rId3"/>
+            <a:stretch>
+              <a:fillRect/>
+            </a:stretch>
+          </p:blipFill>
+          <p:spPr>
+            <a:xfrm>
+              <a:off x="2914468" y="2695145"/>
+              <a:ext cx="415785" cy="360000"/>
+            </a:xfrm>
+            <a:prstGeom prst="rect">
+              <a:avLst/>
+            </a:prstGeom>
+          </p:spPr>
+        </p:pic>
+        <p:pic>
+          <p:nvPicPr>
+            <p:cNvPr id="51" name="Image 50">
+              <a:extLst>
+                <a:ext uri="{FF2B5EF4-FFF2-40B4-BE49-F238E27FC236}">
+                  <a16:creationId xmlns:a16="http://schemas.microsoft.com/office/drawing/2014/main" id="{83F6B3A7-60F8-A8A2-8047-3C109C09AFAB}"/>
+                </a:ext>
+              </a:extLst>
+            </p:cNvPr>
+            <p:cNvPicPr>
+              <a:picLocks noChangeAspect="1"/>
+            </p:cNvPicPr>
+            <p:nvPr/>
+          </p:nvPicPr>
+          <p:blipFill>
+            <a:blip r:embed="rId4"/>
+            <a:stretch>
+              <a:fillRect/>
+            </a:stretch>
+          </p:blipFill>
+          <p:spPr>
+            <a:xfrm>
+              <a:off x="2918029" y="3258586"/>
+              <a:ext cx="415785" cy="360000"/>
+            </a:xfrm>
+            <a:prstGeom prst="rect">
+              <a:avLst/>
+            </a:prstGeom>
+          </p:spPr>
+        </p:pic>
+        <p:pic>
+          <p:nvPicPr>
+            <p:cNvPr id="52" name="Image 51">
+              <a:extLst>
+                <a:ext uri="{FF2B5EF4-FFF2-40B4-BE49-F238E27FC236}">
+                  <a16:creationId xmlns:a16="http://schemas.microsoft.com/office/drawing/2014/main" id="{685C7A16-05C1-81E6-21C2-E43B30CF1E5F}"/>
+                </a:ext>
+              </a:extLst>
+            </p:cNvPr>
+            <p:cNvPicPr>
+              <a:picLocks noChangeAspect="1"/>
+            </p:cNvPicPr>
+            <p:nvPr/>
+          </p:nvPicPr>
+          <p:blipFill>
+            <a:blip r:embed="rId5"/>
+            <a:stretch>
+              <a:fillRect/>
+            </a:stretch>
+          </p:blipFill>
+          <p:spPr>
+            <a:xfrm>
+              <a:off x="2972269" y="3790581"/>
+              <a:ext cx="415909" cy="360000"/>
+            </a:xfrm>
+            <a:prstGeom prst="rect">
+              <a:avLst/>
+            </a:prstGeom>
+          </p:spPr>
+        </p:pic>
+        <p:pic>
+          <p:nvPicPr>
+            <p:cNvPr id="53" name="Image 52">
+              <a:extLst>
+                <a:ext uri="{FF2B5EF4-FFF2-40B4-BE49-F238E27FC236}">
+                  <a16:creationId xmlns:a16="http://schemas.microsoft.com/office/drawing/2014/main" id="{B93EF8FD-99BA-3420-0E33-DF6241ED471F}"/>
+                </a:ext>
+              </a:extLst>
+            </p:cNvPr>
+            <p:cNvPicPr>
+              <a:picLocks noChangeAspect="1"/>
+            </p:cNvPicPr>
+            <p:nvPr/>
+          </p:nvPicPr>
+          <p:blipFill>
+            <a:blip r:embed="rId6"/>
+            <a:stretch>
+              <a:fillRect/>
+            </a:stretch>
+          </p:blipFill>
+          <p:spPr>
+            <a:xfrm>
+              <a:off x="2927225" y="4309066"/>
+              <a:ext cx="415785" cy="360000"/>
+            </a:xfrm>
+            <a:prstGeom prst="rect">
+              <a:avLst/>
+            </a:prstGeom>
+          </p:spPr>
+        </p:pic>
+        <p:pic>
+          <p:nvPicPr>
+            <p:cNvPr id="54" name="Image 53">
+              <a:extLst>
+                <a:ext uri="{FF2B5EF4-FFF2-40B4-BE49-F238E27FC236}">
+                  <a16:creationId xmlns:a16="http://schemas.microsoft.com/office/drawing/2014/main" id="{786973C1-A179-2C61-7F62-D8F6C8482557}"/>
+                </a:ext>
+              </a:extLst>
+            </p:cNvPr>
+            <p:cNvPicPr>
+              <a:picLocks noChangeAspect="1"/>
+            </p:cNvPicPr>
+            <p:nvPr/>
+          </p:nvPicPr>
+          <p:blipFill>
+            <a:blip r:embed="rId3"/>
+            <a:stretch>
+              <a:fillRect/>
+            </a:stretch>
+          </p:blipFill>
+          <p:spPr>
+            <a:xfrm>
+              <a:off x="1762591" y="4227265"/>
+              <a:ext cx="415785" cy="360000"/>
+            </a:xfrm>
+            <a:prstGeom prst="rect">
+              <a:avLst/>
+            </a:prstGeom>
+          </p:spPr>
+        </p:pic>
+        <p:pic>
+          <p:nvPicPr>
+            <p:cNvPr id="59" name="Image 58">
+              <a:extLst>
+                <a:ext uri="{FF2B5EF4-FFF2-40B4-BE49-F238E27FC236}">
+                  <a16:creationId xmlns:a16="http://schemas.microsoft.com/office/drawing/2014/main" id="{CD85D323-0DD5-76DF-5798-24FCA2346928}"/>
+                </a:ext>
+              </a:extLst>
+            </p:cNvPr>
+            <p:cNvPicPr>
+              <a:picLocks noChangeAspect="1"/>
+            </p:cNvPicPr>
+            <p:nvPr/>
+          </p:nvPicPr>
+          <p:blipFill>
+            <a:blip r:embed="rId4"/>
+            <a:stretch>
+              <a:fillRect/>
+            </a:stretch>
+          </p:blipFill>
+          <p:spPr>
+            <a:xfrm>
+              <a:off x="2933927" y="2029074"/>
+              <a:ext cx="415785" cy="360000"/>
+            </a:xfrm>
+            <a:prstGeom prst="rect">
+              <a:avLst/>
+            </a:prstGeom>
+          </p:spPr>
+        </p:pic>
+        <p:pic>
+          <p:nvPicPr>
+            <p:cNvPr id="133" name="Image 132">
+              <a:extLst>
+                <a:ext uri="{FF2B5EF4-FFF2-40B4-BE49-F238E27FC236}">
+                  <a16:creationId xmlns:a16="http://schemas.microsoft.com/office/drawing/2014/main" id="{DA68FCDC-4957-CA4B-3E59-048764D246C5}"/>
+                </a:ext>
+              </a:extLst>
+            </p:cNvPr>
+            <p:cNvPicPr>
+              <a:picLocks noChangeAspect="1"/>
+            </p:cNvPicPr>
+            <p:nvPr/>
+          </p:nvPicPr>
+          <p:blipFill>
+            <a:blip r:embed="rId6"/>
+            <a:stretch>
+              <a:fillRect/>
+            </a:stretch>
+          </p:blipFill>
+          <p:spPr>
+            <a:xfrm>
+              <a:off x="1912769" y="1837718"/>
+              <a:ext cx="415785" cy="360000"/>
+            </a:xfrm>
+            <a:prstGeom prst="rect">
+              <a:avLst/>
+            </a:prstGeom>
+          </p:spPr>
+        </p:pic>
+      </p:grpSp>
+      <p:sp>
+        <p:nvSpPr>
+          <p:cNvPr id="5" name="Rectangle 4">
+            <a:extLst>
+              <a:ext uri="{FF2B5EF4-FFF2-40B4-BE49-F238E27FC236}">
+                <a16:creationId xmlns:a16="http://schemas.microsoft.com/office/drawing/2014/main" id="{34F2869D-4370-8CE4-5591-E052C3D21EDA}"/>
+              </a:ext>
+            </a:extLst>
+          </p:cNvPr>
+          <p:cNvSpPr/>
+          <p:nvPr/>
+        </p:nvSpPr>
+        <p:spPr>
+          <a:xfrm>
+            <a:off x="4414164" y="1782586"/>
+            <a:ext cx="2124000" cy="3312000"/>
+          </a:xfrm>
+          <a:prstGeom prst="rect">
+            <a:avLst/>
+          </a:prstGeom>
+          <a:blipFill dpi="0" rotWithShape="1">
+            <a:blip r:embed="rId2"/>
+            <a:srcRect/>
+            <a:tile tx="0" ty="0" sx="100000" sy="100000" flip="none" algn="tl"/>
+          </a:blipFill>
+          <a:ln w="57150">
+            <a:solidFill>
+              <a:srgbClr val="E58FB0"/>
+            </a:solidFill>
+            <a:prstDash val="sysDot"/>
+          </a:ln>
+        </p:spPr>
+        <p:style>
+          <a:lnRef idx="2">
+            <a:schemeClr val="accent1">
+              <a:shade val="15000"/>
+            </a:schemeClr>
+          </a:lnRef>
+          <a:fillRef idx="1">
+            <a:schemeClr val="accent1"/>
+          </a:fillRef>
+          <a:effectRef idx="0">
+            <a:schemeClr val="accent1"/>
+          </a:effectRef>
+          <a:fontRef idx="minor">
+            <a:schemeClr val="lt1"/>
+          </a:fontRef>
+        </p:style>
+        <p:txBody>
+          <a:bodyPr rtlCol="0" anchor="ctr"/>
+          <a:lstStyle/>
+          <a:p>
+            <a:pPr algn="ctr"/>
+            <a:endParaRPr lang="fr-FR" dirty="0"/>
+          </a:p>
+        </p:txBody>
+      </p:sp>
+    </p:spTree>
+    <p:extLst>
+      <p:ext uri="{BB962C8B-B14F-4D97-AF65-F5344CB8AC3E}">
+        <p14:creationId xmlns:p14="http://schemas.microsoft.com/office/powerpoint/2010/main" val="1803082896"/>
       </p:ext>
     </p:extLst>
   </p:cSld>

</xml_diff>

<commit_message>
Enlever le credit aux cartes événements
</commit_message>
<xml_diff>
--- a/pictures/Cartes-Actions-et-Evenements/Design-Cartes.pptx
+++ b/pictures/Cartes-Actions-et-Evenements/Design-Cartes.pptx
@@ -203,7 +203,7 @@
           <a:p>
             <a:fld id="{263B0988-6DB9-4E3D-B7FD-EFF3BCABE954}" type="datetimeFigureOut">
               <a:rPr lang="fr-FR" smtClean="0"/>
-              <a:t>15/03/2026</a:t>
+              <a:t>24/03/2026</a:t>
             </a:fld>
             <a:endParaRPr lang="fr-FR"/>
           </a:p>
@@ -701,7 +701,7 @@
           <a:p>
             <a:fld id="{588505E2-0C4C-443F-8F57-41958F504CA2}" type="datetimeFigureOut">
               <a:rPr lang="fr-FR" smtClean="0"/>
-              <a:t>15/03/2026</a:t>
+              <a:t>24/03/2026</a:t>
             </a:fld>
             <a:endParaRPr lang="fr-FR"/>
           </a:p>
@@ -899,7 +899,7 @@
           <a:p>
             <a:fld id="{588505E2-0C4C-443F-8F57-41958F504CA2}" type="datetimeFigureOut">
               <a:rPr lang="fr-FR" smtClean="0"/>
-              <a:t>15/03/2026</a:t>
+              <a:t>24/03/2026</a:t>
             </a:fld>
             <a:endParaRPr lang="fr-FR"/>
           </a:p>
@@ -1107,7 +1107,7 @@
           <a:p>
             <a:fld id="{588505E2-0C4C-443F-8F57-41958F504CA2}" type="datetimeFigureOut">
               <a:rPr lang="fr-FR" smtClean="0"/>
-              <a:t>15/03/2026</a:t>
+              <a:t>24/03/2026</a:t>
             </a:fld>
             <a:endParaRPr lang="fr-FR"/>
           </a:p>
@@ -1305,7 +1305,7 @@
           <a:p>
             <a:fld id="{588505E2-0C4C-443F-8F57-41958F504CA2}" type="datetimeFigureOut">
               <a:rPr lang="fr-FR" smtClean="0"/>
-              <a:t>15/03/2026</a:t>
+              <a:t>24/03/2026</a:t>
             </a:fld>
             <a:endParaRPr lang="fr-FR"/>
           </a:p>
@@ -1580,7 +1580,7 @@
           <a:p>
             <a:fld id="{588505E2-0C4C-443F-8F57-41958F504CA2}" type="datetimeFigureOut">
               <a:rPr lang="fr-FR" smtClean="0"/>
-              <a:t>15/03/2026</a:t>
+              <a:t>24/03/2026</a:t>
             </a:fld>
             <a:endParaRPr lang="fr-FR"/>
           </a:p>
@@ -1845,7 +1845,7 @@
           <a:p>
             <a:fld id="{588505E2-0C4C-443F-8F57-41958F504CA2}" type="datetimeFigureOut">
               <a:rPr lang="fr-FR" smtClean="0"/>
-              <a:t>15/03/2026</a:t>
+              <a:t>24/03/2026</a:t>
             </a:fld>
             <a:endParaRPr lang="fr-FR"/>
           </a:p>
@@ -2257,7 +2257,7 @@
           <a:p>
             <a:fld id="{588505E2-0C4C-443F-8F57-41958F504CA2}" type="datetimeFigureOut">
               <a:rPr lang="fr-FR" smtClean="0"/>
-              <a:t>15/03/2026</a:t>
+              <a:t>24/03/2026</a:t>
             </a:fld>
             <a:endParaRPr lang="fr-FR"/>
           </a:p>
@@ -2398,7 +2398,7 @@
           <a:p>
             <a:fld id="{588505E2-0C4C-443F-8F57-41958F504CA2}" type="datetimeFigureOut">
               <a:rPr lang="fr-FR" smtClean="0"/>
-              <a:t>15/03/2026</a:t>
+              <a:t>24/03/2026</a:t>
             </a:fld>
             <a:endParaRPr lang="fr-FR"/>
           </a:p>
@@ -2511,7 +2511,7 @@
           <a:p>
             <a:fld id="{588505E2-0C4C-443F-8F57-41958F504CA2}" type="datetimeFigureOut">
               <a:rPr lang="fr-FR" smtClean="0"/>
-              <a:t>15/03/2026</a:t>
+              <a:t>24/03/2026</a:t>
             </a:fld>
             <a:endParaRPr lang="fr-FR"/>
           </a:p>
@@ -2822,7 +2822,7 @@
           <a:p>
             <a:fld id="{588505E2-0C4C-443F-8F57-41958F504CA2}" type="datetimeFigureOut">
               <a:rPr lang="fr-FR" smtClean="0"/>
-              <a:t>15/03/2026</a:t>
+              <a:t>24/03/2026</a:t>
             </a:fld>
             <a:endParaRPr lang="fr-FR"/>
           </a:p>
@@ -3110,7 +3110,7 @@
           <a:p>
             <a:fld id="{588505E2-0C4C-443F-8F57-41958F504CA2}" type="datetimeFigureOut">
               <a:rPr lang="fr-FR" smtClean="0"/>
-              <a:t>15/03/2026</a:t>
+              <a:t>24/03/2026</a:t>
             </a:fld>
             <a:endParaRPr lang="fr-FR"/>
           </a:p>
@@ -3351,7 +3351,7 @@
           <a:p>
             <a:fld id="{588505E2-0C4C-443F-8F57-41958F504CA2}" type="datetimeFigureOut">
               <a:rPr lang="fr-FR" smtClean="0"/>
-              <a:t>15/03/2026</a:t>
+              <a:t>24/03/2026</a:t>
             </a:fld>
             <a:endParaRPr lang="fr-FR"/>
           </a:p>
@@ -14628,10 +14628,10 @@
       </p:grpSpPr>
       <p:grpSp>
         <p:nvGrpSpPr>
-          <p:cNvPr id="3" name="Groupe 2">
+          <p:cNvPr id="8" name="Groupe 7">
             <a:extLst>
               <a:ext uri="{FF2B5EF4-FFF2-40B4-BE49-F238E27FC236}">
-                <a16:creationId xmlns:a16="http://schemas.microsoft.com/office/drawing/2014/main" id="{D67D9650-371E-617C-A11F-79C136028911}"/>
+                <a16:creationId xmlns:a16="http://schemas.microsoft.com/office/drawing/2014/main" id="{63F6BE4C-B607-9E16-D80D-E7E11B2AACDD}"/>
               </a:ext>
             </a:extLst>
           </p:cNvPr>
@@ -14781,68 +14781,6 @@
         </p:sp>
         <p:sp>
           <p:nvSpPr>
-            <p:cNvPr id="6" name="Cercle : creux 5">
-              <a:extLst>
-                <a:ext uri="{FF2B5EF4-FFF2-40B4-BE49-F238E27FC236}">
-                  <a16:creationId xmlns:a16="http://schemas.microsoft.com/office/drawing/2014/main" id="{DA183178-33D6-E4DB-46D9-1AE4D318C264}"/>
-                </a:ext>
-              </a:extLst>
-            </p:cNvPr>
-            <p:cNvSpPr/>
-            <p:nvPr/>
-          </p:nvSpPr>
-          <p:spPr>
-            <a:xfrm>
-              <a:off x="1439503" y="4602592"/>
-              <a:ext cx="360000" cy="360000"/>
-            </a:xfrm>
-            <a:prstGeom prst="donut">
-              <a:avLst>
-                <a:gd name="adj" fmla="val 15271"/>
-              </a:avLst>
-            </a:prstGeom>
-            <a:blipFill>
-              <a:blip r:embed="rId5"/>
-              <a:tile tx="0" ty="0" sx="100000" sy="100000" flip="none" algn="tl"/>
-            </a:blipFill>
-            <a:ln w="12700"/>
-          </p:spPr>
-          <p:style>
-            <a:lnRef idx="2">
-              <a:schemeClr val="dk1">
-                <a:shade val="15000"/>
-              </a:schemeClr>
-            </a:lnRef>
-            <a:fillRef idx="1">
-              <a:schemeClr val="dk1"/>
-            </a:fillRef>
-            <a:effectRef idx="0">
-              <a:schemeClr val="dk1"/>
-            </a:effectRef>
-            <a:fontRef idx="minor">
-              <a:schemeClr val="lt1"/>
-            </a:fontRef>
-          </p:style>
-          <p:txBody>
-            <a:bodyPr rtlCol="0" anchor="ctr"/>
-            <a:lstStyle/>
-            <a:p>
-              <a:pPr algn="ctr"/>
-              <a:r>
-                <a:rPr lang="fr-FR" b="1" dirty="0">
-                  <a:solidFill>
-                    <a:schemeClr val="bg1"/>
-                  </a:solidFill>
-                  <a:latin typeface="Segoe UI" panose="020B0502040204020203" pitchFamily="34" charset="0"/>
-                  <a:cs typeface="Segoe UI" panose="020B0502040204020203" pitchFamily="34" charset="0"/>
-                </a:rPr>
-                <a:t>3</a:t>
-              </a:r>
-            </a:p>
-          </p:txBody>
-        </p:sp>
-        <p:sp>
-          <p:nvSpPr>
             <p:cNvPr id="7" name="ZoneTexte 6">
               <a:extLst>
                 <a:ext uri="{FF2B5EF4-FFF2-40B4-BE49-F238E27FC236}">
@@ -14898,7 +14836,7 @@
           </p:nvCxnSpPr>
           <p:spPr>
             <a:xfrm>
-              <a:off x="2310363" y="3997378"/>
+              <a:off x="2291313" y="3940228"/>
               <a:ext cx="281448" cy="7387"/>
             </a:xfrm>
             <a:prstGeom prst="straightConnector1">
@@ -14940,18 +14878,18 @@
           </p:nvSpPr>
           <p:spPr>
             <a:xfrm rot="5400000">
-              <a:off x="2634030" y="3722459"/>
+              <a:off x="2614980" y="3665309"/>
               <a:ext cx="648000" cy="612000"/>
             </a:xfrm>
             <a:prstGeom prst="hexagon">
               <a:avLst/>
             </a:prstGeom>
             <a:blipFill>
-              <a:blip r:embed="rId6">
+              <a:blip r:embed="rId5">
                 <a:extLst>
                   <a:ext uri="{BEBA8EAE-BF5A-486C-A8C5-ECC9F3942E4B}">
                     <a14:imgProps xmlns:a14="http://schemas.microsoft.com/office/drawing/2010/main">
-                      <a14:imgLayer r:embed="rId7">
+                      <a14:imgLayer r:embed="rId6">
                         <a14:imgEffect>
                           <a14:brightnessContrast bright="-20000" contrast="-40000"/>
                         </a14:imgEffect>
@@ -15007,18 +14945,18 @@
           </p:nvSpPr>
           <p:spPr>
             <a:xfrm rot="5400000">
-              <a:off x="1578078" y="3702459"/>
+              <a:off x="1559028" y="3645309"/>
               <a:ext cx="648000" cy="612000"/>
             </a:xfrm>
             <a:prstGeom prst="hexagon">
               <a:avLst/>
             </a:prstGeom>
             <a:blipFill>
-              <a:blip r:embed="rId6">
+              <a:blip r:embed="rId5">
                 <a:extLst>
                   <a:ext uri="{BEBA8EAE-BF5A-486C-A8C5-ECC9F3942E4B}">
                     <a14:imgProps xmlns:a14="http://schemas.microsoft.com/office/drawing/2010/main">
-                      <a14:imgLayer r:embed="rId7">
+                      <a14:imgLayer r:embed="rId6">
                         <a14:imgEffect>
                           <a14:brightnessContrast bright="-20000" contrast="-40000"/>
                         </a14:imgEffect>
@@ -15074,14 +15012,14 @@
           </p:nvSpPr>
           <p:spPr>
             <a:xfrm>
-              <a:off x="1803854" y="3828459"/>
+              <a:off x="1784804" y="3771309"/>
               <a:ext cx="180000" cy="360000"/>
             </a:xfrm>
             <a:prstGeom prst="rect">
               <a:avLst/>
             </a:prstGeom>
             <a:blipFill>
-              <a:blip r:embed="rId8"/>
+              <a:blip r:embed="rId7"/>
               <a:tile tx="0" ty="0" sx="100000" sy="100000" flip="none" algn="tl"/>
             </a:blipFill>
             <a:ln w="12700">
@@ -15176,13 +15114,50 @@
             </a:p>
           </p:txBody>
         </p:sp>
+        <p:pic>
+          <p:nvPicPr>
+            <p:cNvPr id="37" name="Graphique 36" descr="Haute tension avec un remplissage uni">
+              <a:extLst>
+                <a:ext uri="{FF2B5EF4-FFF2-40B4-BE49-F238E27FC236}">
+                  <a16:creationId xmlns:a16="http://schemas.microsoft.com/office/drawing/2014/main" id="{77BBE848-3249-8AB2-A0C3-D7CAE941BF35}"/>
+                </a:ext>
+              </a:extLst>
+            </p:cNvPr>
+            <p:cNvPicPr>
+              <a:picLocks noChangeAspect="1"/>
+            </p:cNvPicPr>
+            <p:nvPr/>
+          </p:nvPicPr>
+          <p:blipFill>
+            <a:blip r:embed="rId8">
+              <a:extLst>
+                <a:ext uri="{96DAC541-7B7A-43D3-8B79-37D633B846F1}">
+                  <asvg:svgBlip xmlns:asvg="http://schemas.microsoft.com/office/drawing/2016/SVG/main" r:embed="rId9"/>
+                </a:ext>
+              </a:extLst>
+            </a:blip>
+            <a:stretch>
+              <a:fillRect/>
+            </a:stretch>
+          </p:blipFill>
+          <p:spPr>
+            <a:xfrm>
+              <a:off x="1465857" y="4503767"/>
+              <a:ext cx="504000" cy="504000"/>
+            </a:xfrm>
+            <a:prstGeom prst="rect">
+              <a:avLst/>
+            </a:prstGeom>
+            <a:effectLst/>
+          </p:spPr>
+        </p:pic>
       </p:grpSp>
       <p:grpSp>
         <p:nvGrpSpPr>
-          <p:cNvPr id="8" name="Groupe 7">
+          <p:cNvPr id="45" name="Groupe 44">
             <a:extLst>
               <a:ext uri="{FF2B5EF4-FFF2-40B4-BE49-F238E27FC236}">
-                <a16:creationId xmlns:a16="http://schemas.microsoft.com/office/drawing/2014/main" id="{2A355FF7-FE57-6782-7000-534B31A1C17A}"/>
+                <a16:creationId xmlns:a16="http://schemas.microsoft.com/office/drawing/2014/main" id="{341684A8-8634-1BCF-07ED-A776CA81C0FC}"/>
               </a:ext>
             </a:extLst>
           </p:cNvPr>
@@ -15246,7 +15221,7 @@
             <a:lstStyle/>
             <a:p>
               <a:pPr algn="ctr"/>
-              <a:endParaRPr lang="fr-FR"/>
+              <a:endParaRPr lang="fr-FR" dirty="0"/>
             </a:p>
           </p:txBody>
         </p:sp>
@@ -15330,68 +15305,6 @@
             </a:p>
           </p:txBody>
         </p:sp>
-        <p:sp>
-          <p:nvSpPr>
-            <p:cNvPr id="24" name="Cercle : creux 23">
-              <a:extLst>
-                <a:ext uri="{FF2B5EF4-FFF2-40B4-BE49-F238E27FC236}">
-                  <a16:creationId xmlns:a16="http://schemas.microsoft.com/office/drawing/2014/main" id="{9A9CC2B7-0F36-461B-4ACD-ACA96D110629}"/>
-                </a:ext>
-              </a:extLst>
-            </p:cNvPr>
-            <p:cNvSpPr/>
-            <p:nvPr/>
-          </p:nvSpPr>
-          <p:spPr>
-            <a:xfrm>
-              <a:off x="4686630" y="4558330"/>
-              <a:ext cx="360000" cy="360000"/>
-            </a:xfrm>
-            <a:prstGeom prst="donut">
-              <a:avLst>
-                <a:gd name="adj" fmla="val 15271"/>
-              </a:avLst>
-            </a:prstGeom>
-            <a:blipFill>
-              <a:blip r:embed="rId5"/>
-              <a:tile tx="0" ty="0" sx="100000" sy="100000" flip="none" algn="tl"/>
-            </a:blipFill>
-            <a:ln w="12700"/>
-          </p:spPr>
-          <p:style>
-            <a:lnRef idx="2">
-              <a:schemeClr val="dk1">
-                <a:shade val="15000"/>
-              </a:schemeClr>
-            </a:lnRef>
-            <a:fillRef idx="1">
-              <a:schemeClr val="dk1"/>
-            </a:fillRef>
-            <a:effectRef idx="0">
-              <a:schemeClr val="dk1"/>
-            </a:effectRef>
-            <a:fontRef idx="minor">
-              <a:schemeClr val="lt1"/>
-            </a:fontRef>
-          </p:style>
-          <p:txBody>
-            <a:bodyPr rtlCol="0" anchor="ctr"/>
-            <a:lstStyle/>
-            <a:p>
-              <a:pPr algn="ctr"/>
-              <a:r>
-                <a:rPr lang="fr-FR" b="1" dirty="0">
-                  <a:solidFill>
-                    <a:schemeClr val="bg1"/>
-                  </a:solidFill>
-                  <a:latin typeface="Segoe UI" panose="020B0502040204020203" pitchFamily="34" charset="0"/>
-                  <a:cs typeface="Segoe UI" panose="020B0502040204020203" pitchFamily="34" charset="0"/>
-                </a:rPr>
-                <a:t>3</a:t>
-              </a:r>
-            </a:p>
-          </p:txBody>
-        </p:sp>
         <p:cxnSp>
           <p:nvCxnSpPr>
             <p:cNvPr id="26" name="Connecteur droit avec flèche 25">
@@ -15408,7 +15321,7 @@
           </p:nvCxnSpPr>
           <p:spPr>
             <a:xfrm>
-              <a:off x="5551901" y="3975343"/>
+              <a:off x="5532851" y="3918193"/>
               <a:ext cx="281448" cy="7387"/>
             </a:xfrm>
             <a:prstGeom prst="straightConnector1">
@@ -15450,18 +15363,18 @@
           </p:nvSpPr>
           <p:spPr>
             <a:xfrm rot="5400000">
-              <a:off x="4832530" y="3699599"/>
+              <a:off x="4813480" y="3642449"/>
               <a:ext cx="648000" cy="612000"/>
             </a:xfrm>
             <a:prstGeom prst="hexagon">
               <a:avLst/>
             </a:prstGeom>
             <a:blipFill>
-              <a:blip r:embed="rId6">
+              <a:blip r:embed="rId5">
                 <a:extLst>
                   <a:ext uri="{BEBA8EAE-BF5A-486C-A8C5-ECC9F3942E4B}">
                     <a14:imgProps xmlns:a14="http://schemas.microsoft.com/office/drawing/2010/main">
-                      <a14:imgLayer r:embed="rId7">
+                      <a14:imgLayer r:embed="rId6">
                         <a14:imgEffect>
                           <a14:brightnessContrast bright="-20000" contrast="-40000"/>
                         </a14:imgEffect>
@@ -15517,14 +15430,14 @@
           </p:nvSpPr>
           <p:spPr>
             <a:xfrm>
-              <a:off x="5066530" y="3791237"/>
+              <a:off x="5047480" y="3734087"/>
               <a:ext cx="180000" cy="180000"/>
             </a:xfrm>
             <a:prstGeom prst="ellipse">
               <a:avLst/>
             </a:prstGeom>
             <a:blipFill>
-              <a:blip r:embed="rId8"/>
+              <a:blip r:embed="rId7"/>
               <a:tile tx="0" ty="0" sx="100000" sy="100000" flip="none" algn="tl"/>
             </a:blipFill>
             <a:ln w="12700">
@@ -15572,14 +15485,14 @@
           </p:nvSpPr>
           <p:spPr>
             <a:xfrm>
-              <a:off x="5205858" y="3998595"/>
+              <a:off x="5186808" y="3941445"/>
               <a:ext cx="180000" cy="180000"/>
             </a:xfrm>
             <a:prstGeom prst="ellipse">
               <a:avLst/>
             </a:prstGeom>
             <a:blipFill>
-              <a:blip r:embed="rId8"/>
+              <a:blip r:embed="rId7"/>
               <a:tile tx="0" ty="0" sx="100000" sy="100000" flip="none" algn="tl"/>
             </a:blipFill>
             <a:ln w="12700">
@@ -15627,14 +15540,14 @@
           </p:nvSpPr>
           <p:spPr>
             <a:xfrm>
-              <a:off x="4932695" y="3998595"/>
+              <a:off x="4913645" y="3941445"/>
               <a:ext cx="180000" cy="180000"/>
             </a:xfrm>
             <a:prstGeom prst="ellipse">
               <a:avLst/>
             </a:prstGeom>
             <a:blipFill>
-              <a:blip r:embed="rId8"/>
+              <a:blip r:embed="rId7"/>
               <a:tile tx="0" ty="0" sx="100000" sy="100000" flip="none" algn="tl"/>
             </a:blipFill>
             <a:ln w="12700">
@@ -15682,18 +15595,18 @@
           </p:nvSpPr>
           <p:spPr>
             <a:xfrm rot="5400000">
-              <a:off x="5866136" y="3697480"/>
+              <a:off x="5847086" y="3640330"/>
               <a:ext cx="648000" cy="612000"/>
             </a:xfrm>
             <a:prstGeom prst="hexagon">
               <a:avLst/>
             </a:prstGeom>
             <a:blipFill>
-              <a:blip r:embed="rId6">
+              <a:blip r:embed="rId5">
                 <a:extLst>
                   <a:ext uri="{BEBA8EAE-BF5A-486C-A8C5-ECC9F3942E4B}">
                     <a14:imgProps xmlns:a14="http://schemas.microsoft.com/office/drawing/2010/main">
-                      <a14:imgLayer r:embed="rId7">
+                      <a14:imgLayer r:embed="rId6">
                         <a14:imgEffect>
                           <a14:brightnessContrast bright="-20000" contrast="-40000"/>
                         </a14:imgEffect>
@@ -15851,7 +15764,7 @@
           </p:nvSpPr>
           <p:spPr>
             <a:xfrm>
-              <a:off x="5920136" y="3730714"/>
+              <a:off x="5901086" y="3673564"/>
               <a:ext cx="540000" cy="540000"/>
             </a:xfrm>
             <a:prstGeom prst="mathMultiply">
@@ -15888,13 +15801,50 @@
             </a:p>
           </p:txBody>
         </p:sp>
+        <p:pic>
+          <p:nvPicPr>
+            <p:cNvPr id="38" name="Graphique 37" descr="Haute tension avec un remplissage uni">
+              <a:extLst>
+                <a:ext uri="{FF2B5EF4-FFF2-40B4-BE49-F238E27FC236}">
+                  <a16:creationId xmlns:a16="http://schemas.microsoft.com/office/drawing/2014/main" id="{5EEA613E-C735-E486-12A1-2299249537C3}"/>
+                </a:ext>
+              </a:extLst>
+            </p:cNvPr>
+            <p:cNvPicPr>
+              <a:picLocks noChangeAspect="1"/>
+            </p:cNvPicPr>
+            <p:nvPr/>
+          </p:nvPicPr>
+          <p:blipFill>
+            <a:blip r:embed="rId8">
+              <a:extLst>
+                <a:ext uri="{96DAC541-7B7A-43D3-8B79-37D633B846F1}">
+                  <asvg:svgBlip xmlns:asvg="http://schemas.microsoft.com/office/drawing/2016/SVG/main" r:embed="rId9"/>
+                </a:ext>
+              </a:extLst>
+            </a:blip>
+            <a:stretch>
+              <a:fillRect/>
+            </a:stretch>
+          </p:blipFill>
+          <p:spPr>
+            <a:xfrm>
+              <a:off x="4682808" y="4508351"/>
+              <a:ext cx="504000" cy="504000"/>
+            </a:xfrm>
+            <a:prstGeom prst="rect">
+              <a:avLst/>
+            </a:prstGeom>
+            <a:effectLst/>
+          </p:spPr>
+        </p:pic>
       </p:grpSp>
       <p:grpSp>
         <p:nvGrpSpPr>
-          <p:cNvPr id="9" name="Groupe 8">
+          <p:cNvPr id="46" name="Groupe 45">
             <a:extLst>
               <a:ext uri="{FF2B5EF4-FFF2-40B4-BE49-F238E27FC236}">
-                <a16:creationId xmlns:a16="http://schemas.microsoft.com/office/drawing/2014/main" id="{82310C26-D48F-FFCA-4C77-42053D17DEC5}"/>
+                <a16:creationId xmlns:a16="http://schemas.microsoft.com/office/drawing/2014/main" id="{185E04A7-08A8-0BDA-1630-BEF7E928BDEF}"/>
               </a:ext>
             </a:extLst>
           </p:cNvPr>
@@ -16042,68 +15992,6 @@
             </a:p>
           </p:txBody>
         </p:sp>
-        <p:sp>
-          <p:nvSpPr>
-            <p:cNvPr id="57" name="Cercle : creux 56">
-              <a:extLst>
-                <a:ext uri="{FF2B5EF4-FFF2-40B4-BE49-F238E27FC236}">
-                  <a16:creationId xmlns:a16="http://schemas.microsoft.com/office/drawing/2014/main" id="{2EA42100-9CEF-6719-9948-2EE002C3B853}"/>
-                </a:ext>
-              </a:extLst>
-            </p:cNvPr>
-            <p:cNvSpPr/>
-            <p:nvPr/>
-          </p:nvSpPr>
-          <p:spPr>
-            <a:xfrm>
-              <a:off x="8094639" y="4581582"/>
-              <a:ext cx="360000" cy="360000"/>
-            </a:xfrm>
-            <a:prstGeom prst="donut">
-              <a:avLst>
-                <a:gd name="adj" fmla="val 15271"/>
-              </a:avLst>
-            </a:prstGeom>
-            <a:blipFill>
-              <a:blip r:embed="rId5"/>
-              <a:tile tx="0" ty="0" sx="100000" sy="100000" flip="none" algn="tl"/>
-            </a:blipFill>
-            <a:ln w="12700"/>
-          </p:spPr>
-          <p:style>
-            <a:lnRef idx="2">
-              <a:schemeClr val="dk1">
-                <a:shade val="15000"/>
-              </a:schemeClr>
-            </a:lnRef>
-            <a:fillRef idx="1">
-              <a:schemeClr val="dk1"/>
-            </a:fillRef>
-            <a:effectRef idx="0">
-              <a:schemeClr val="dk1"/>
-            </a:effectRef>
-            <a:fontRef idx="minor">
-              <a:schemeClr val="lt1"/>
-            </a:fontRef>
-          </p:style>
-          <p:txBody>
-            <a:bodyPr rtlCol="0" anchor="ctr"/>
-            <a:lstStyle/>
-            <a:p>
-              <a:pPr algn="ctr"/>
-              <a:r>
-                <a:rPr lang="fr-FR" b="1" dirty="0">
-                  <a:solidFill>
-                    <a:schemeClr val="bg1"/>
-                  </a:solidFill>
-                  <a:latin typeface="Segoe UI" panose="020B0502040204020203" pitchFamily="34" charset="0"/>
-                  <a:cs typeface="Segoe UI" panose="020B0502040204020203" pitchFamily="34" charset="0"/>
-                </a:rPr>
-                <a:t>3</a:t>
-              </a:r>
-            </a:p>
-          </p:txBody>
-        </p:sp>
         <p:cxnSp>
           <p:nvCxnSpPr>
             <p:cNvPr id="58" name="Connecteur droit avec flèche 57">
@@ -16120,7 +16008,7 @@
           </p:nvCxnSpPr>
           <p:spPr>
             <a:xfrm>
-              <a:off x="8937402" y="3976628"/>
+              <a:off x="8937402" y="3919478"/>
               <a:ext cx="281448" cy="7387"/>
             </a:xfrm>
             <a:prstGeom prst="straightConnector1">
@@ -16162,18 +16050,18 @@
           </p:nvSpPr>
           <p:spPr>
             <a:xfrm rot="5400000">
-              <a:off x="8218031" y="3700884"/>
+              <a:off x="8218031" y="3643734"/>
               <a:ext cx="648000" cy="612000"/>
             </a:xfrm>
             <a:prstGeom prst="hexagon">
               <a:avLst/>
             </a:prstGeom>
             <a:blipFill>
-              <a:blip r:embed="rId6">
+              <a:blip r:embed="rId5">
                 <a:extLst>
                   <a:ext uri="{BEBA8EAE-BF5A-486C-A8C5-ECC9F3942E4B}">
                     <a14:imgProps xmlns:a14="http://schemas.microsoft.com/office/drawing/2010/main">
-                      <a14:imgLayer r:embed="rId7">
+                      <a14:imgLayer r:embed="rId6">
                         <a14:imgEffect>
                           <a14:brightnessContrast bright="-20000" contrast="-40000"/>
                         </a14:imgEffect>
@@ -16229,14 +16117,14 @@
           </p:nvSpPr>
           <p:spPr>
             <a:xfrm>
-              <a:off x="8452031" y="3792522"/>
+              <a:off x="8452031" y="3735372"/>
               <a:ext cx="180000" cy="180000"/>
             </a:xfrm>
             <a:prstGeom prst="ellipse">
               <a:avLst/>
             </a:prstGeom>
             <a:blipFill>
-              <a:blip r:embed="rId8"/>
+              <a:blip r:embed="rId7"/>
               <a:tile tx="0" ty="0" sx="100000" sy="100000" flip="none" algn="tl"/>
             </a:blipFill>
             <a:ln w="12700">
@@ -16284,14 +16172,14 @@
           </p:nvSpPr>
           <p:spPr>
             <a:xfrm>
-              <a:off x="8591359" y="3999880"/>
+              <a:off x="8591359" y="3942730"/>
               <a:ext cx="180000" cy="180000"/>
             </a:xfrm>
             <a:prstGeom prst="ellipse">
               <a:avLst/>
             </a:prstGeom>
             <a:blipFill>
-              <a:blip r:embed="rId8"/>
+              <a:blip r:embed="rId7"/>
               <a:tile tx="0" ty="0" sx="100000" sy="100000" flip="none" algn="tl"/>
             </a:blipFill>
             <a:ln w="12700">
@@ -16339,14 +16227,14 @@
           </p:nvSpPr>
           <p:spPr>
             <a:xfrm>
-              <a:off x="8318196" y="3999880"/>
+              <a:off x="8318196" y="3942730"/>
               <a:ext cx="180000" cy="180000"/>
             </a:xfrm>
             <a:prstGeom prst="ellipse">
               <a:avLst/>
             </a:prstGeom>
             <a:blipFill>
-              <a:blip r:embed="rId8"/>
+              <a:blip r:embed="rId7"/>
               <a:tile tx="0" ty="0" sx="100000" sy="100000" flip="none" algn="tl"/>
             </a:blipFill>
             <a:ln w="12700">
@@ -16394,18 +16282,18 @@
           </p:nvSpPr>
           <p:spPr>
             <a:xfrm rot="5400000">
-              <a:off x="9251637" y="3698765"/>
+              <a:off x="9251637" y="3641615"/>
               <a:ext cx="648000" cy="612000"/>
             </a:xfrm>
             <a:prstGeom prst="hexagon">
               <a:avLst/>
             </a:prstGeom>
             <a:blipFill>
-              <a:blip r:embed="rId6">
+              <a:blip r:embed="rId5">
                 <a:extLst>
                   <a:ext uri="{BEBA8EAE-BF5A-486C-A8C5-ECC9F3942E4B}">
                     <a14:imgProps xmlns:a14="http://schemas.microsoft.com/office/drawing/2010/main">
-                      <a14:imgLayer r:embed="rId7">
+                      <a14:imgLayer r:embed="rId6">
                         <a14:imgEffect>
                           <a14:brightnessContrast bright="-20000" contrast="-40000"/>
                         </a14:imgEffect>
@@ -16563,7 +16451,7 @@
           </p:nvSpPr>
           <p:spPr>
             <a:xfrm rot="5400000">
-              <a:off x="9428884" y="3832652"/>
+              <a:off x="9428884" y="3775502"/>
               <a:ext cx="375114" cy="348464"/>
             </a:xfrm>
             <a:prstGeom prst="uturnArrow">
@@ -16613,6 +16501,43 @@
             </a:p>
           </p:txBody>
         </p:sp>
+        <p:pic>
+          <p:nvPicPr>
+            <p:cNvPr id="42" name="Graphique 41" descr="Haute tension avec un remplissage uni">
+              <a:extLst>
+                <a:ext uri="{FF2B5EF4-FFF2-40B4-BE49-F238E27FC236}">
+                  <a16:creationId xmlns:a16="http://schemas.microsoft.com/office/drawing/2014/main" id="{47E7DDEE-DC97-309E-B4B7-34692CA91029}"/>
+                </a:ext>
+              </a:extLst>
+            </p:cNvPr>
+            <p:cNvPicPr>
+              <a:picLocks noChangeAspect="1"/>
+            </p:cNvPicPr>
+            <p:nvPr/>
+          </p:nvPicPr>
+          <p:blipFill>
+            <a:blip r:embed="rId8">
+              <a:extLst>
+                <a:ext uri="{96DAC541-7B7A-43D3-8B79-37D633B846F1}">
+                  <asvg:svgBlip xmlns:asvg="http://schemas.microsoft.com/office/drawing/2016/SVG/main" r:embed="rId9"/>
+                </a:ext>
+              </a:extLst>
+            </a:blip>
+            <a:stretch>
+              <a:fillRect/>
+            </a:stretch>
+          </p:blipFill>
+          <p:spPr>
+            <a:xfrm>
+              <a:off x="8102346" y="4503767"/>
+              <a:ext cx="504000" cy="504000"/>
+            </a:xfrm>
+            <a:prstGeom prst="rect">
+              <a:avLst/>
+            </a:prstGeom>
+            <a:effectLst/>
+          </p:spPr>
+        </p:pic>
       </p:grpSp>
     </p:spTree>
     <p:extLst>

</xml_diff>

<commit_message>
Ajout icones soldat et tour sur les cartes vertes
</commit_message>
<xml_diff>
--- a/pictures/Cartes-Actions-et-Evenements/Design-Cartes.pptx
+++ b/pictures/Cartes-Actions-et-Evenements/Design-Cartes.pptx
@@ -203,7 +203,7 @@
           <a:p>
             <a:fld id="{263B0988-6DB9-4E3D-B7FD-EFF3BCABE954}" type="datetimeFigureOut">
               <a:rPr lang="fr-FR" smtClean="0"/>
-              <a:t>31/03/2026</a:t>
+              <a:t>01/04/2026</a:t>
             </a:fld>
             <a:endParaRPr lang="fr-FR"/>
           </a:p>
@@ -701,7 +701,7 @@
           <a:p>
             <a:fld id="{588505E2-0C4C-443F-8F57-41958F504CA2}" type="datetimeFigureOut">
               <a:rPr lang="fr-FR" smtClean="0"/>
-              <a:t>31/03/2026</a:t>
+              <a:t>01/04/2026</a:t>
             </a:fld>
             <a:endParaRPr lang="fr-FR"/>
           </a:p>
@@ -899,7 +899,7 @@
           <a:p>
             <a:fld id="{588505E2-0C4C-443F-8F57-41958F504CA2}" type="datetimeFigureOut">
               <a:rPr lang="fr-FR" smtClean="0"/>
-              <a:t>31/03/2026</a:t>
+              <a:t>01/04/2026</a:t>
             </a:fld>
             <a:endParaRPr lang="fr-FR"/>
           </a:p>
@@ -1107,7 +1107,7 @@
           <a:p>
             <a:fld id="{588505E2-0C4C-443F-8F57-41958F504CA2}" type="datetimeFigureOut">
               <a:rPr lang="fr-FR" smtClean="0"/>
-              <a:t>31/03/2026</a:t>
+              <a:t>01/04/2026</a:t>
             </a:fld>
             <a:endParaRPr lang="fr-FR"/>
           </a:p>
@@ -1305,7 +1305,7 @@
           <a:p>
             <a:fld id="{588505E2-0C4C-443F-8F57-41958F504CA2}" type="datetimeFigureOut">
               <a:rPr lang="fr-FR" smtClean="0"/>
-              <a:t>31/03/2026</a:t>
+              <a:t>01/04/2026</a:t>
             </a:fld>
             <a:endParaRPr lang="fr-FR"/>
           </a:p>
@@ -1580,7 +1580,7 @@
           <a:p>
             <a:fld id="{588505E2-0C4C-443F-8F57-41958F504CA2}" type="datetimeFigureOut">
               <a:rPr lang="fr-FR" smtClean="0"/>
-              <a:t>31/03/2026</a:t>
+              <a:t>01/04/2026</a:t>
             </a:fld>
             <a:endParaRPr lang="fr-FR"/>
           </a:p>
@@ -1845,7 +1845,7 @@
           <a:p>
             <a:fld id="{588505E2-0C4C-443F-8F57-41958F504CA2}" type="datetimeFigureOut">
               <a:rPr lang="fr-FR" smtClean="0"/>
-              <a:t>31/03/2026</a:t>
+              <a:t>01/04/2026</a:t>
             </a:fld>
             <a:endParaRPr lang="fr-FR"/>
           </a:p>
@@ -2257,7 +2257,7 @@
           <a:p>
             <a:fld id="{588505E2-0C4C-443F-8F57-41958F504CA2}" type="datetimeFigureOut">
               <a:rPr lang="fr-FR" smtClean="0"/>
-              <a:t>31/03/2026</a:t>
+              <a:t>01/04/2026</a:t>
             </a:fld>
             <a:endParaRPr lang="fr-FR"/>
           </a:p>
@@ -2398,7 +2398,7 @@
           <a:p>
             <a:fld id="{588505E2-0C4C-443F-8F57-41958F504CA2}" type="datetimeFigureOut">
               <a:rPr lang="fr-FR" smtClean="0"/>
-              <a:t>31/03/2026</a:t>
+              <a:t>01/04/2026</a:t>
             </a:fld>
             <a:endParaRPr lang="fr-FR"/>
           </a:p>
@@ -2511,7 +2511,7 @@
           <a:p>
             <a:fld id="{588505E2-0C4C-443F-8F57-41958F504CA2}" type="datetimeFigureOut">
               <a:rPr lang="fr-FR" smtClean="0"/>
-              <a:t>31/03/2026</a:t>
+              <a:t>01/04/2026</a:t>
             </a:fld>
             <a:endParaRPr lang="fr-FR"/>
           </a:p>
@@ -2822,7 +2822,7 @@
           <a:p>
             <a:fld id="{588505E2-0C4C-443F-8F57-41958F504CA2}" type="datetimeFigureOut">
               <a:rPr lang="fr-FR" smtClean="0"/>
-              <a:t>31/03/2026</a:t>
+              <a:t>01/04/2026</a:t>
             </a:fld>
             <a:endParaRPr lang="fr-FR"/>
           </a:p>
@@ -3110,7 +3110,7 @@
           <a:p>
             <a:fld id="{588505E2-0C4C-443F-8F57-41958F504CA2}" type="datetimeFigureOut">
               <a:rPr lang="fr-FR" smtClean="0"/>
-              <a:t>31/03/2026</a:t>
+              <a:t>01/04/2026</a:t>
             </a:fld>
             <a:endParaRPr lang="fr-FR"/>
           </a:p>
@@ -3351,7 +3351,7 @@
           <a:p>
             <a:fld id="{588505E2-0C4C-443F-8F57-41958F504CA2}" type="datetimeFigureOut">
               <a:rPr lang="fr-FR" smtClean="0"/>
-              <a:t>31/03/2026</a:t>
+              <a:t>01/04/2026</a:t>
             </a:fld>
             <a:endParaRPr lang="fr-FR"/>
           </a:p>
@@ -6865,10 +6865,10 @@
       </p:grpSpPr>
       <p:grpSp>
         <p:nvGrpSpPr>
-          <p:cNvPr id="13" name="Groupe 12">
+          <p:cNvPr id="17" name="Groupe 16">
             <a:extLst>
               <a:ext uri="{FF2B5EF4-FFF2-40B4-BE49-F238E27FC236}">
-                <a16:creationId xmlns:a16="http://schemas.microsoft.com/office/drawing/2014/main" id="{02EBE095-70BB-CFC8-F8C8-5ED92DF14190}"/>
+                <a16:creationId xmlns:a16="http://schemas.microsoft.com/office/drawing/2014/main" id="{7C74C304-0CA8-6A42-3C56-5C1BC3567F3E}"/>
               </a:ext>
             </a:extLst>
           </p:cNvPr>
@@ -7976,13 +7976,58 @@
             </a:p>
           </p:txBody>
         </p:sp>
+        <p:pic>
+          <p:nvPicPr>
+            <p:cNvPr id="3" name="Image 2">
+              <a:extLst>
+                <a:ext uri="{FF2B5EF4-FFF2-40B4-BE49-F238E27FC236}">
+                  <a16:creationId xmlns:a16="http://schemas.microsoft.com/office/drawing/2014/main" id="{C3307C20-48DC-2878-A1A3-21A62FB236D4}"/>
+                </a:ext>
+              </a:extLst>
+            </p:cNvPr>
+            <p:cNvPicPr>
+              <a:picLocks noChangeAspect="1"/>
+            </p:cNvPicPr>
+            <p:nvPr/>
+          </p:nvPicPr>
+          <p:blipFill>
+            <a:blip r:embed="rId10">
+              <a:extLst>
+                <a:ext uri="{BEBA8EAE-BF5A-486C-A8C5-ECC9F3942E4B}">
+                  <a14:imgProps xmlns:a14="http://schemas.microsoft.com/office/drawing/2010/main">
+                    <a14:imgLayer r:embed="rId11">
+                      <a14:imgEffect>
+                        <a14:brightnessContrast contrast="40000"/>
+                      </a14:imgEffect>
+                    </a14:imgLayer>
+                  </a14:imgProps>
+                </a:ext>
+                <a:ext uri="{28A0092B-C50C-407E-A947-70E740481C1C}">
+                  <a14:useLocalDpi xmlns:a14="http://schemas.microsoft.com/office/drawing/2010/main" val="0"/>
+                </a:ext>
+              </a:extLst>
+            </a:blip>
+            <a:stretch>
+              <a:fillRect/>
+            </a:stretch>
+          </p:blipFill>
+          <p:spPr>
+            <a:xfrm>
+              <a:off x="3353936" y="2768847"/>
+              <a:ext cx="540000" cy="540000"/>
+            </a:xfrm>
+            <a:prstGeom prst="rect">
+              <a:avLst/>
+            </a:prstGeom>
+          </p:spPr>
+        </p:pic>
       </p:grpSp>
       <p:grpSp>
         <p:nvGrpSpPr>
-          <p:cNvPr id="14" name="Groupe 13">
+          <p:cNvPr id="18" name="Groupe 17">
             <a:extLst>
               <a:ext uri="{FF2B5EF4-FFF2-40B4-BE49-F238E27FC236}">
-                <a16:creationId xmlns:a16="http://schemas.microsoft.com/office/drawing/2014/main" id="{BE57FBDE-4DD9-55EB-2AD6-F3F8E335D74C}"/>
+                <a16:creationId xmlns:a16="http://schemas.microsoft.com/office/drawing/2014/main" id="{69263384-E41E-D53A-AD4B-3A40FC4D059F}"/>
               </a:ext>
             </a:extLst>
           </p:cNvPr>
@@ -9077,13 +9122,58 @@
             </a:p>
           </p:txBody>
         </p:sp>
+        <p:pic>
+          <p:nvPicPr>
+            <p:cNvPr id="4" name="Image 3">
+              <a:extLst>
+                <a:ext uri="{FF2B5EF4-FFF2-40B4-BE49-F238E27FC236}">
+                  <a16:creationId xmlns:a16="http://schemas.microsoft.com/office/drawing/2014/main" id="{C8DF5F09-670C-BD26-1DE3-2563D8D9A6BD}"/>
+                </a:ext>
+              </a:extLst>
+            </p:cNvPr>
+            <p:cNvPicPr>
+              <a:picLocks noChangeAspect="1"/>
+            </p:cNvPicPr>
+            <p:nvPr/>
+          </p:nvPicPr>
+          <p:blipFill>
+            <a:blip r:embed="rId10">
+              <a:extLst>
+                <a:ext uri="{BEBA8EAE-BF5A-486C-A8C5-ECC9F3942E4B}">
+                  <a14:imgProps xmlns:a14="http://schemas.microsoft.com/office/drawing/2010/main">
+                    <a14:imgLayer r:embed="rId11">
+                      <a14:imgEffect>
+                        <a14:brightnessContrast contrast="40000"/>
+                      </a14:imgEffect>
+                    </a14:imgLayer>
+                  </a14:imgProps>
+                </a:ext>
+                <a:ext uri="{28A0092B-C50C-407E-A947-70E740481C1C}">
+                  <a14:useLocalDpi xmlns:a14="http://schemas.microsoft.com/office/drawing/2010/main" val="0"/>
+                </a:ext>
+              </a:extLst>
+            </a:blip>
+            <a:stretch>
+              <a:fillRect/>
+            </a:stretch>
+          </p:blipFill>
+          <p:spPr>
+            <a:xfrm>
+              <a:off x="5952454" y="2789636"/>
+              <a:ext cx="540000" cy="540000"/>
+            </a:xfrm>
+            <a:prstGeom prst="rect">
+              <a:avLst/>
+            </a:prstGeom>
+          </p:spPr>
+        </p:pic>
       </p:grpSp>
       <p:grpSp>
         <p:nvGrpSpPr>
-          <p:cNvPr id="15" name="Groupe 14">
+          <p:cNvPr id="19" name="Groupe 18">
             <a:extLst>
               <a:ext uri="{FF2B5EF4-FFF2-40B4-BE49-F238E27FC236}">
-                <a16:creationId xmlns:a16="http://schemas.microsoft.com/office/drawing/2014/main" id="{10899377-BB97-9370-3F46-7404CFE09AB3}"/>
+                <a16:creationId xmlns:a16="http://schemas.microsoft.com/office/drawing/2014/main" id="{DAD352C7-A8F0-3ED6-78A8-D0A5EBF24402}"/>
               </a:ext>
             </a:extLst>
           </p:cNvPr>
@@ -10123,6 +10213,51 @@
             </a:p>
           </p:txBody>
         </p:sp>
+        <p:pic>
+          <p:nvPicPr>
+            <p:cNvPr id="16" name="Image 15">
+              <a:extLst>
+                <a:ext uri="{FF2B5EF4-FFF2-40B4-BE49-F238E27FC236}">
+                  <a16:creationId xmlns:a16="http://schemas.microsoft.com/office/drawing/2014/main" id="{C847F9CC-315B-83F8-B39E-140A000B4B05}"/>
+                </a:ext>
+              </a:extLst>
+            </p:cNvPr>
+            <p:cNvPicPr>
+              <a:picLocks noChangeAspect="1"/>
+            </p:cNvPicPr>
+            <p:nvPr/>
+          </p:nvPicPr>
+          <p:blipFill>
+            <a:blip r:embed="rId10">
+              <a:extLst>
+                <a:ext uri="{BEBA8EAE-BF5A-486C-A8C5-ECC9F3942E4B}">
+                  <a14:imgProps xmlns:a14="http://schemas.microsoft.com/office/drawing/2010/main">
+                    <a14:imgLayer r:embed="rId11">
+                      <a14:imgEffect>
+                        <a14:brightnessContrast contrast="40000"/>
+                      </a14:imgEffect>
+                    </a14:imgLayer>
+                  </a14:imgProps>
+                </a:ext>
+                <a:ext uri="{28A0092B-C50C-407E-A947-70E740481C1C}">
+                  <a14:useLocalDpi xmlns:a14="http://schemas.microsoft.com/office/drawing/2010/main" val="0"/>
+                </a:ext>
+              </a:extLst>
+            </a:blip>
+            <a:stretch>
+              <a:fillRect/>
+            </a:stretch>
+          </p:blipFill>
+          <p:spPr>
+            <a:xfrm>
+              <a:off x="8604042" y="2754722"/>
+              <a:ext cx="540000" cy="540000"/>
+            </a:xfrm>
+            <a:prstGeom prst="rect">
+              <a:avLst/>
+            </a:prstGeom>
+          </p:spPr>
+        </p:pic>
       </p:grpSp>
     </p:spTree>
     <p:extLst>
@@ -10162,1142 +10297,10 @@
       </p:grpSpPr>
       <p:grpSp>
         <p:nvGrpSpPr>
-          <p:cNvPr id="24" name="Groupe 23">
+          <p:cNvPr id="13" name="Groupe 12">
             <a:extLst>
               <a:ext uri="{FF2B5EF4-FFF2-40B4-BE49-F238E27FC236}">
-                <a16:creationId xmlns:a16="http://schemas.microsoft.com/office/drawing/2014/main" id="{B00975F0-9394-EE4E-816D-BACBB04EEA93}"/>
-              </a:ext>
-            </a:extLst>
-          </p:cNvPr>
-          <p:cNvGrpSpPr/>
-          <p:nvPr/>
-        </p:nvGrpSpPr>
-        <p:grpSpPr>
-          <a:xfrm>
-            <a:off x="1537763" y="1464756"/>
-            <a:ext cx="2124887" cy="3312766"/>
-            <a:chOff x="1537763" y="1464756"/>
-            <a:chExt cx="2124887" cy="3312766"/>
-          </a:xfrm>
-        </p:grpSpPr>
-        <p:sp>
-          <p:nvSpPr>
-            <p:cNvPr id="86" name="Rectangle 85">
-              <a:extLst>
-                <a:ext uri="{FF2B5EF4-FFF2-40B4-BE49-F238E27FC236}">
-                  <a16:creationId xmlns:a16="http://schemas.microsoft.com/office/drawing/2014/main" id="{04E5B47C-2EF9-89AC-F731-DD6CB8B619DF}"/>
-                </a:ext>
-              </a:extLst>
-            </p:cNvPr>
-            <p:cNvSpPr/>
-            <p:nvPr/>
-          </p:nvSpPr>
-          <p:spPr>
-            <a:xfrm>
-              <a:off x="1537763" y="1465522"/>
-              <a:ext cx="2124000" cy="3312000"/>
-            </a:xfrm>
-            <a:prstGeom prst="rect">
-              <a:avLst/>
-            </a:prstGeom>
-            <a:blipFill dpi="0" rotWithShape="1">
-              <a:blip r:embed="rId2">
-                <a:alphaModFix amt="75000"/>
-              </a:blip>
-              <a:srcRect/>
-              <a:tile tx="0" ty="0" sx="100000" sy="100000" flip="none" algn="tl"/>
-            </a:blipFill>
-          </p:spPr>
-          <p:style>
-            <a:lnRef idx="2">
-              <a:schemeClr val="accent1">
-                <a:shade val="15000"/>
-              </a:schemeClr>
-            </a:lnRef>
-            <a:fillRef idx="1">
-              <a:schemeClr val="accent1"/>
-            </a:fillRef>
-            <a:effectRef idx="0">
-              <a:schemeClr val="accent1"/>
-            </a:effectRef>
-            <a:fontRef idx="minor">
-              <a:schemeClr val="lt1"/>
-            </a:fontRef>
-          </p:style>
-          <p:txBody>
-            <a:bodyPr rtlCol="0" anchor="ctr"/>
-            <a:lstStyle/>
-            <a:p>
-              <a:pPr algn="ctr"/>
-              <a:endParaRPr lang="fr-FR"/>
-            </a:p>
-          </p:txBody>
-        </p:sp>
-        <p:sp>
-          <p:nvSpPr>
-            <p:cNvPr id="87" name="Rectangle 86">
-              <a:extLst>
-                <a:ext uri="{FF2B5EF4-FFF2-40B4-BE49-F238E27FC236}">
-                  <a16:creationId xmlns:a16="http://schemas.microsoft.com/office/drawing/2014/main" id="{371948D6-45CF-6980-CCC9-79FC16314AE7}"/>
-                </a:ext>
-              </a:extLst>
-            </p:cNvPr>
-            <p:cNvSpPr/>
-            <p:nvPr/>
-          </p:nvSpPr>
-          <p:spPr>
-            <a:xfrm>
-              <a:off x="1969764" y="1464756"/>
-              <a:ext cx="1259999" cy="432000"/>
-            </a:xfrm>
-            <a:prstGeom prst="rect">
-              <a:avLst/>
-            </a:prstGeom>
-            <a:blipFill dpi="0" rotWithShape="1">
-              <a:blip r:embed="rId3">
-                <a:alphaModFix amt="50000"/>
-                <a:extLst>
-                  <a:ext uri="{BEBA8EAE-BF5A-486C-A8C5-ECC9F3942E4B}">
-                    <a14:imgProps xmlns:a14="http://schemas.microsoft.com/office/drawing/2010/main">
-                      <a14:imgLayer r:embed="rId4">
-                        <a14:imgEffect>
-                          <a14:artisticWatercolorSponge/>
-                        </a14:imgEffect>
-                        <a14:imgEffect>
-                          <a14:brightnessContrast bright="-40000" contrast="20000"/>
-                        </a14:imgEffect>
-                      </a14:imgLayer>
-                    </a14:imgProps>
-                  </a:ext>
-                </a:extLst>
-              </a:blip>
-              <a:srcRect/>
-              <a:tile tx="0" ty="0" sx="100000" sy="100000" flip="none" algn="tl"/>
-            </a:blipFill>
-            <a:ln>
-              <a:solidFill>
-                <a:schemeClr val="tx1"/>
-              </a:solidFill>
-            </a:ln>
-          </p:spPr>
-          <p:style>
-            <a:lnRef idx="2">
-              <a:schemeClr val="accent1">
-                <a:shade val="15000"/>
-              </a:schemeClr>
-            </a:lnRef>
-            <a:fillRef idx="1">
-              <a:schemeClr val="accent1"/>
-            </a:fillRef>
-            <a:effectRef idx="0">
-              <a:schemeClr val="accent1"/>
-            </a:effectRef>
-            <a:fontRef idx="minor">
-              <a:schemeClr val="lt1"/>
-            </a:fontRef>
-          </p:style>
-          <p:txBody>
-            <a:bodyPr rtlCol="0" anchor="ctr"/>
-            <a:lstStyle/>
-            <a:p>
-              <a:pPr algn="ctr"/>
-              <a:r>
-                <a:rPr lang="fr-FR" sz="1200" b="1" dirty="0">
-                  <a:solidFill>
-                    <a:schemeClr val="bg1"/>
-                  </a:solidFill>
-                  <a:latin typeface="Segoe UI" panose="020B0502040204020203" pitchFamily="34" charset="0"/>
-                  <a:cs typeface="Segoe UI" panose="020B0502040204020203" pitchFamily="34" charset="0"/>
-                </a:rPr>
-                <a:t>Construire donjon</a:t>
-              </a:r>
-            </a:p>
-          </p:txBody>
-        </p:sp>
-        <p:sp>
-          <p:nvSpPr>
-            <p:cNvPr id="88" name="Cercle : creux 87">
-              <a:extLst>
-                <a:ext uri="{FF2B5EF4-FFF2-40B4-BE49-F238E27FC236}">
-                  <a16:creationId xmlns:a16="http://schemas.microsoft.com/office/drawing/2014/main" id="{083AAB54-2D50-7886-D049-84B2430A33A2}"/>
-                </a:ext>
-              </a:extLst>
-            </p:cNvPr>
-            <p:cNvSpPr/>
-            <p:nvPr/>
-          </p:nvSpPr>
-          <p:spPr>
-            <a:xfrm>
-              <a:off x="1640654" y="4297549"/>
-              <a:ext cx="360000" cy="360000"/>
-            </a:xfrm>
-            <a:prstGeom prst="donut">
-              <a:avLst>
-                <a:gd name="adj" fmla="val 15271"/>
-              </a:avLst>
-            </a:prstGeom>
-            <a:blipFill>
-              <a:blip r:embed="rId5"/>
-              <a:tile tx="0" ty="0" sx="100000" sy="100000" flip="none" algn="tl"/>
-            </a:blipFill>
-            <a:ln w="12700"/>
-          </p:spPr>
-          <p:style>
-            <a:lnRef idx="2">
-              <a:schemeClr val="dk1">
-                <a:shade val="15000"/>
-              </a:schemeClr>
-            </a:lnRef>
-            <a:fillRef idx="1">
-              <a:schemeClr val="dk1"/>
-            </a:fillRef>
-            <a:effectRef idx="0">
-              <a:schemeClr val="dk1"/>
-            </a:effectRef>
-            <a:fontRef idx="minor">
-              <a:schemeClr val="lt1"/>
-            </a:fontRef>
-          </p:style>
-          <p:txBody>
-            <a:bodyPr rtlCol="0" anchor="ctr"/>
-            <a:lstStyle/>
-            <a:p>
-              <a:pPr algn="ctr"/>
-              <a:r>
-                <a:rPr lang="fr-FR" b="1" dirty="0">
-                  <a:solidFill>
-                    <a:schemeClr val="bg1"/>
-                  </a:solidFill>
-                  <a:latin typeface="Segoe UI" panose="020B0502040204020203" pitchFamily="34" charset="0"/>
-                  <a:cs typeface="Segoe UI" panose="020B0502040204020203" pitchFamily="34" charset="0"/>
-                </a:rPr>
-                <a:t>3</a:t>
-              </a:r>
-            </a:p>
-          </p:txBody>
-        </p:sp>
-        <p:sp>
-          <p:nvSpPr>
-            <p:cNvPr id="89" name="Hexagone 88">
-              <a:extLst>
-                <a:ext uri="{FF2B5EF4-FFF2-40B4-BE49-F238E27FC236}">
-                  <a16:creationId xmlns:a16="http://schemas.microsoft.com/office/drawing/2014/main" id="{64DD3239-986E-50CD-B1CF-21E5A6A8394C}"/>
-                </a:ext>
-              </a:extLst>
-            </p:cNvPr>
-            <p:cNvSpPr/>
-            <p:nvPr/>
-          </p:nvSpPr>
-          <p:spPr>
-            <a:xfrm rot="5400000">
-              <a:off x="1755725" y="3320523"/>
-              <a:ext cx="648000" cy="612000"/>
-            </a:xfrm>
-            <a:prstGeom prst="hexagon">
-              <a:avLst/>
-            </a:prstGeom>
-            <a:solidFill>
-              <a:schemeClr val="bg1"/>
-            </a:solidFill>
-            <a:ln w="12700">
-              <a:solidFill>
-                <a:schemeClr val="tx1"/>
-              </a:solidFill>
-            </a:ln>
-          </p:spPr>
-          <p:style>
-            <a:lnRef idx="2">
-              <a:schemeClr val="accent1">
-                <a:shade val="15000"/>
-              </a:schemeClr>
-            </a:lnRef>
-            <a:fillRef idx="1">
-              <a:schemeClr val="accent1"/>
-            </a:fillRef>
-            <a:effectRef idx="0">
-              <a:schemeClr val="accent1"/>
-            </a:effectRef>
-            <a:fontRef idx="minor">
-              <a:schemeClr val="lt1"/>
-            </a:fontRef>
-          </p:style>
-          <p:txBody>
-            <a:bodyPr rtlCol="0" anchor="ctr"/>
-            <a:lstStyle/>
-            <a:p>
-              <a:pPr algn="ctr"/>
-              <a:endParaRPr lang="fr-FR"/>
-            </a:p>
-          </p:txBody>
-        </p:sp>
-        <p:sp>
-          <p:nvSpPr>
-            <p:cNvPr id="90" name="Ellipse 89">
-              <a:extLst>
-                <a:ext uri="{FF2B5EF4-FFF2-40B4-BE49-F238E27FC236}">
-                  <a16:creationId xmlns:a16="http://schemas.microsoft.com/office/drawing/2014/main" id="{92AD6DEC-A3F1-4FA6-CA5A-2E9C8BCBFBE3}"/>
-                </a:ext>
-              </a:extLst>
-            </p:cNvPr>
-            <p:cNvSpPr/>
-            <p:nvPr/>
-          </p:nvSpPr>
-          <p:spPr>
-            <a:xfrm>
-              <a:off x="1989725" y="3391444"/>
-              <a:ext cx="180000" cy="180000"/>
-            </a:xfrm>
-            <a:prstGeom prst="ellipse">
-              <a:avLst/>
-            </a:prstGeom>
-            <a:blipFill>
-              <a:blip r:embed="rId6"/>
-              <a:tile tx="0" ty="0" sx="100000" sy="100000" flip="none" algn="tl"/>
-            </a:blipFill>
-            <a:ln w="12700">
-              <a:solidFill>
-                <a:schemeClr val="tx1"/>
-              </a:solidFill>
-            </a:ln>
-          </p:spPr>
-          <p:style>
-            <a:lnRef idx="2">
-              <a:schemeClr val="dk1">
-                <a:shade val="15000"/>
-              </a:schemeClr>
-            </a:lnRef>
-            <a:fillRef idx="1">
-              <a:schemeClr val="dk1"/>
-            </a:fillRef>
-            <a:effectRef idx="0">
-              <a:schemeClr val="dk1"/>
-            </a:effectRef>
-            <a:fontRef idx="minor">
-              <a:schemeClr val="lt1"/>
-            </a:fontRef>
-          </p:style>
-          <p:txBody>
-            <a:bodyPr rtlCol="0" anchor="ctr"/>
-            <a:lstStyle/>
-            <a:p>
-              <a:pPr algn="ctr"/>
-              <a:endParaRPr lang="fr-FR"/>
-            </a:p>
-          </p:txBody>
-        </p:sp>
-        <p:sp>
-          <p:nvSpPr>
-            <p:cNvPr id="91" name="Ellipse 90">
-              <a:extLst>
-                <a:ext uri="{FF2B5EF4-FFF2-40B4-BE49-F238E27FC236}">
-                  <a16:creationId xmlns:a16="http://schemas.microsoft.com/office/drawing/2014/main" id="{5C68161E-7F59-9AC8-44AA-374BE2A11AEF}"/>
-                </a:ext>
-              </a:extLst>
-            </p:cNvPr>
-            <p:cNvSpPr/>
-            <p:nvPr/>
-          </p:nvSpPr>
-          <p:spPr>
-            <a:xfrm>
-              <a:off x="2119242" y="3610970"/>
-              <a:ext cx="180000" cy="180000"/>
-            </a:xfrm>
-            <a:prstGeom prst="ellipse">
-              <a:avLst/>
-            </a:prstGeom>
-            <a:blipFill>
-              <a:blip r:embed="rId6"/>
-              <a:tile tx="0" ty="0" sx="100000" sy="100000" flip="none" algn="tl"/>
-            </a:blipFill>
-            <a:ln w="12700">
-              <a:solidFill>
-                <a:schemeClr val="tx1"/>
-              </a:solidFill>
-            </a:ln>
-          </p:spPr>
-          <p:style>
-            <a:lnRef idx="2">
-              <a:schemeClr val="dk1">
-                <a:shade val="15000"/>
-              </a:schemeClr>
-            </a:lnRef>
-            <a:fillRef idx="1">
-              <a:schemeClr val="dk1"/>
-            </a:fillRef>
-            <a:effectRef idx="0">
-              <a:schemeClr val="dk1"/>
-            </a:effectRef>
-            <a:fontRef idx="minor">
-              <a:schemeClr val="lt1"/>
-            </a:fontRef>
-          </p:style>
-          <p:txBody>
-            <a:bodyPr rtlCol="0" anchor="ctr"/>
-            <a:lstStyle/>
-            <a:p>
-              <a:pPr algn="ctr"/>
-              <a:endParaRPr lang="fr-FR"/>
-            </a:p>
-          </p:txBody>
-        </p:sp>
-        <p:sp>
-          <p:nvSpPr>
-            <p:cNvPr id="92" name="Ellipse 91">
-              <a:extLst>
-                <a:ext uri="{FF2B5EF4-FFF2-40B4-BE49-F238E27FC236}">
-                  <a16:creationId xmlns:a16="http://schemas.microsoft.com/office/drawing/2014/main" id="{A4E33891-1EE5-37D8-B485-109AA56F6B98}"/>
-                </a:ext>
-              </a:extLst>
-            </p:cNvPr>
-            <p:cNvSpPr/>
-            <p:nvPr/>
-          </p:nvSpPr>
-          <p:spPr>
-            <a:xfrm>
-              <a:off x="1848595" y="3605466"/>
-              <a:ext cx="180000" cy="180000"/>
-            </a:xfrm>
-            <a:prstGeom prst="ellipse">
-              <a:avLst/>
-            </a:prstGeom>
-            <a:blipFill>
-              <a:blip r:embed="rId6"/>
-              <a:tile tx="0" ty="0" sx="100000" sy="100000" flip="none" algn="tl"/>
-            </a:blipFill>
-            <a:ln w="12700">
-              <a:solidFill>
-                <a:schemeClr val="tx1"/>
-              </a:solidFill>
-            </a:ln>
-          </p:spPr>
-          <p:style>
-            <a:lnRef idx="2">
-              <a:schemeClr val="dk1">
-                <a:shade val="15000"/>
-              </a:schemeClr>
-            </a:lnRef>
-            <a:fillRef idx="1">
-              <a:schemeClr val="dk1"/>
-            </a:fillRef>
-            <a:effectRef idx="0">
-              <a:schemeClr val="dk1"/>
-            </a:effectRef>
-            <a:fontRef idx="minor">
-              <a:schemeClr val="lt1"/>
-            </a:fontRef>
-          </p:style>
-          <p:txBody>
-            <a:bodyPr rtlCol="0" anchor="ctr"/>
-            <a:lstStyle/>
-            <a:p>
-              <a:pPr algn="ctr"/>
-              <a:endParaRPr lang="fr-FR"/>
-            </a:p>
-          </p:txBody>
-        </p:sp>
-        <p:sp>
-          <p:nvSpPr>
-            <p:cNvPr id="93" name="Hexagone 92">
-              <a:extLst>
-                <a:ext uri="{FF2B5EF4-FFF2-40B4-BE49-F238E27FC236}">
-                  <a16:creationId xmlns:a16="http://schemas.microsoft.com/office/drawing/2014/main" id="{919BB814-7094-E3A0-B787-C9F98EFC1CCB}"/>
-                </a:ext>
-              </a:extLst>
-            </p:cNvPr>
-            <p:cNvSpPr/>
-            <p:nvPr/>
-          </p:nvSpPr>
-          <p:spPr>
-            <a:xfrm rot="5400000">
-              <a:off x="2814838" y="3321356"/>
-              <a:ext cx="648000" cy="612000"/>
-            </a:xfrm>
-            <a:prstGeom prst="hexagon">
-              <a:avLst/>
-            </a:prstGeom>
-            <a:solidFill>
-              <a:schemeClr val="bg1"/>
-            </a:solidFill>
-            <a:ln w="12700">
-              <a:solidFill>
-                <a:schemeClr val="tx1"/>
-              </a:solidFill>
-            </a:ln>
-          </p:spPr>
-          <p:style>
-            <a:lnRef idx="2">
-              <a:schemeClr val="accent1">
-                <a:shade val="15000"/>
-              </a:schemeClr>
-            </a:lnRef>
-            <a:fillRef idx="1">
-              <a:schemeClr val="accent1"/>
-            </a:fillRef>
-            <a:effectRef idx="0">
-              <a:schemeClr val="accent1"/>
-            </a:effectRef>
-            <a:fontRef idx="minor">
-              <a:schemeClr val="lt1"/>
-            </a:fontRef>
-          </p:style>
-          <p:txBody>
-            <a:bodyPr rtlCol="0" anchor="ctr"/>
-            <a:lstStyle/>
-            <a:p>
-              <a:pPr algn="ctr"/>
-              <a:endParaRPr lang="fr-FR"/>
-            </a:p>
-          </p:txBody>
-        </p:sp>
-        <p:sp>
-          <p:nvSpPr>
-            <p:cNvPr id="94" name="Rectangle 93">
-              <a:extLst>
-                <a:ext uri="{FF2B5EF4-FFF2-40B4-BE49-F238E27FC236}">
-                  <a16:creationId xmlns:a16="http://schemas.microsoft.com/office/drawing/2014/main" id="{63D6D6F8-EDD7-5FBF-5A28-7D7A39D31B49}"/>
-                </a:ext>
-              </a:extLst>
-            </p:cNvPr>
-            <p:cNvSpPr/>
-            <p:nvPr/>
-          </p:nvSpPr>
-          <p:spPr>
-            <a:xfrm>
-              <a:off x="3059451" y="3433495"/>
-              <a:ext cx="180000" cy="360000"/>
-            </a:xfrm>
-            <a:prstGeom prst="rect">
-              <a:avLst/>
-            </a:prstGeom>
-            <a:blipFill>
-              <a:blip r:embed="rId6"/>
-              <a:tile tx="0" ty="0" sx="100000" sy="100000" flip="none" algn="tl"/>
-            </a:blipFill>
-            <a:ln w="12700">
-              <a:solidFill>
-                <a:schemeClr val="tx1"/>
-              </a:solidFill>
-            </a:ln>
-          </p:spPr>
-          <p:style>
-            <a:lnRef idx="2">
-              <a:schemeClr val="accent1">
-                <a:shade val="15000"/>
-              </a:schemeClr>
-            </a:lnRef>
-            <a:fillRef idx="1">
-              <a:schemeClr val="accent1"/>
-            </a:fillRef>
-            <a:effectRef idx="0">
-              <a:schemeClr val="accent1"/>
-            </a:effectRef>
-            <a:fontRef idx="minor">
-              <a:schemeClr val="lt1"/>
-            </a:fontRef>
-          </p:style>
-          <p:txBody>
-            <a:bodyPr rtlCol="0" anchor="ctr"/>
-            <a:lstStyle/>
-            <a:p>
-              <a:pPr algn="ctr"/>
-              <a:endParaRPr lang="fr-FR"/>
-            </a:p>
-          </p:txBody>
-        </p:sp>
-        <p:sp>
-          <p:nvSpPr>
-            <p:cNvPr id="95" name="ZoneTexte 94">
-              <a:extLst>
-                <a:ext uri="{FF2B5EF4-FFF2-40B4-BE49-F238E27FC236}">
-                  <a16:creationId xmlns:a16="http://schemas.microsoft.com/office/drawing/2014/main" id="{AA03724E-9EEB-1F4F-5B83-18D8579C4464}"/>
-                </a:ext>
-              </a:extLst>
-            </p:cNvPr>
-            <p:cNvSpPr txBox="1"/>
-            <p:nvPr/>
-          </p:nvSpPr>
-          <p:spPr>
-            <a:xfrm>
-              <a:off x="1689611" y="2020111"/>
-              <a:ext cx="1716417" cy="1015663"/>
-            </a:xfrm>
-            <a:prstGeom prst="rect">
-              <a:avLst/>
-            </a:prstGeom>
-            <a:noFill/>
-          </p:spPr>
-          <p:txBody>
-            <a:bodyPr wrap="square" rtlCol="0">
-              <a:spAutoFit/>
-            </a:bodyPr>
-            <a:lstStyle/>
-            <a:p>
-              <a:r>
-                <a:rPr lang="fr-FR" sz="1200" b="1" dirty="0">
-                  <a:solidFill>
-                    <a:schemeClr val="bg1"/>
-                  </a:solidFill>
-                  <a:latin typeface="Segoe UI" panose="020B0502040204020203" pitchFamily="34" charset="0"/>
-                  <a:cs typeface="Segoe UI" panose="020B0502040204020203" pitchFamily="34" charset="0"/>
-                </a:rPr>
-                <a:t>Défausser 3 troupes de la tuile de commandement pour construire un donjon</a:t>
-              </a:r>
-            </a:p>
-          </p:txBody>
-        </p:sp>
-        <p:cxnSp>
-          <p:nvCxnSpPr>
-            <p:cNvPr id="96" name="Connecteur droit avec flèche 95">
-              <a:extLst>
-                <a:ext uri="{FF2B5EF4-FFF2-40B4-BE49-F238E27FC236}">
-                  <a16:creationId xmlns:a16="http://schemas.microsoft.com/office/drawing/2014/main" id="{BC19A915-4C84-F4C5-79D2-DA15D82A8611}"/>
-                </a:ext>
-              </a:extLst>
-            </p:cNvPr>
-            <p:cNvCxnSpPr>
-              <a:cxnSpLocks/>
-            </p:cNvCxnSpPr>
-            <p:nvPr/>
-          </p:nvCxnSpPr>
-          <p:spPr>
-            <a:xfrm>
-              <a:off x="2476114" y="3616275"/>
-              <a:ext cx="281448" cy="7387"/>
-            </a:xfrm>
-            <a:prstGeom prst="straightConnector1">
-              <a:avLst/>
-            </a:prstGeom>
-            <a:ln w="57150">
-              <a:solidFill>
-                <a:schemeClr val="bg1"/>
-              </a:solidFill>
-              <a:tailEnd type="triangle"/>
-            </a:ln>
-          </p:spPr>
-          <p:style>
-            <a:lnRef idx="2">
-              <a:schemeClr val="dk1"/>
-            </a:lnRef>
-            <a:fillRef idx="0">
-              <a:schemeClr val="dk1"/>
-            </a:fillRef>
-            <a:effectRef idx="1">
-              <a:schemeClr val="dk1"/>
-            </a:effectRef>
-            <a:fontRef idx="minor">
-              <a:schemeClr val="tx1"/>
-            </a:fontRef>
-          </p:style>
-        </p:cxnSp>
-        <p:grpSp>
-          <p:nvGrpSpPr>
-            <p:cNvPr id="25" name="Groupe 24">
-              <a:extLst>
-                <a:ext uri="{FF2B5EF4-FFF2-40B4-BE49-F238E27FC236}">
-                  <a16:creationId xmlns:a16="http://schemas.microsoft.com/office/drawing/2014/main" id="{6E12C2E4-77D4-9711-8D51-68795AEAD8DA}"/>
-                </a:ext>
-              </a:extLst>
-            </p:cNvPr>
-            <p:cNvGrpSpPr/>
-            <p:nvPr/>
-          </p:nvGrpSpPr>
-          <p:grpSpPr>
-            <a:xfrm>
-              <a:off x="2103545" y="4286511"/>
-              <a:ext cx="368869" cy="390567"/>
-              <a:chOff x="1576316" y="4917631"/>
-              <a:chExt cx="722925" cy="765450"/>
-            </a:xfrm>
-          </p:grpSpPr>
-          <p:sp>
-            <p:nvSpPr>
-              <p:cNvPr id="26" name="Hexagone 25">
-                <a:extLst>
-                  <a:ext uri="{FF2B5EF4-FFF2-40B4-BE49-F238E27FC236}">
-                    <a16:creationId xmlns:a16="http://schemas.microsoft.com/office/drawing/2014/main" id="{BEE7A43E-DF8C-67CD-23BF-397C38BE7D71}"/>
-                  </a:ext>
-                </a:extLst>
-              </p:cNvPr>
-              <p:cNvSpPr/>
-              <p:nvPr/>
-            </p:nvSpPr>
-            <p:spPr>
-              <a:xfrm rot="5400000">
-                <a:off x="1555054" y="4938893"/>
-                <a:ext cx="765450" cy="722925"/>
-              </a:xfrm>
-              <a:prstGeom prst="hexagon">
-                <a:avLst/>
-              </a:prstGeom>
-              <a:blipFill>
-                <a:blip r:embed="rId7">
-                  <a:extLst>
-                    <a:ext uri="{BEBA8EAE-BF5A-486C-A8C5-ECC9F3942E4B}">
-                      <a14:imgProps xmlns:a14="http://schemas.microsoft.com/office/drawing/2010/main">
-                        <a14:imgLayer r:embed="rId8">
-                          <a14:imgEffect>
-                            <a14:artisticGlass/>
-                          </a14:imgEffect>
-                        </a14:imgLayer>
-                      </a14:imgProps>
-                    </a:ext>
-                  </a:extLst>
-                </a:blip>
-                <a:tile tx="0" ty="0" sx="100000" sy="100000" flip="none" algn="tl"/>
-              </a:blipFill>
-              <a:ln w="12700">
-                <a:solidFill>
-                  <a:schemeClr val="tx1"/>
-                </a:solidFill>
-              </a:ln>
-            </p:spPr>
-            <p:style>
-              <a:lnRef idx="2">
-                <a:schemeClr val="accent1">
-                  <a:shade val="15000"/>
-                </a:schemeClr>
-              </a:lnRef>
-              <a:fillRef idx="1">
-                <a:schemeClr val="accent1"/>
-              </a:fillRef>
-              <a:effectRef idx="0">
-                <a:schemeClr val="accent1"/>
-              </a:effectRef>
-              <a:fontRef idx="minor">
-                <a:schemeClr val="lt1"/>
-              </a:fontRef>
-            </p:style>
-            <p:txBody>
-              <a:bodyPr rtlCol="0" anchor="ctr"/>
-              <a:lstStyle/>
-              <a:p>
-                <a:pPr algn="ctr"/>
-                <a:endParaRPr lang="fr-FR"/>
-              </a:p>
-            </p:txBody>
-          </p:sp>
-          <p:sp>
-            <p:nvSpPr>
-              <p:cNvPr id="27" name="Rectangle 26">
-                <a:extLst>
-                  <a:ext uri="{FF2B5EF4-FFF2-40B4-BE49-F238E27FC236}">
-                    <a16:creationId xmlns:a16="http://schemas.microsoft.com/office/drawing/2014/main" id="{31B0FF7F-8BD8-7B6E-110F-87D4BEE35245}"/>
-                  </a:ext>
-                </a:extLst>
-              </p:cNvPr>
-              <p:cNvSpPr/>
-              <p:nvPr/>
-            </p:nvSpPr>
-            <p:spPr>
-              <a:xfrm>
-                <a:off x="1848595" y="5261590"/>
-                <a:ext cx="180000" cy="244946"/>
-              </a:xfrm>
-              <a:prstGeom prst="rect">
-                <a:avLst/>
-              </a:prstGeom>
-              <a:solidFill>
-                <a:schemeClr val="bg1"/>
-              </a:solidFill>
-              <a:ln w="12700">
-                <a:solidFill>
-                  <a:schemeClr val="tx1"/>
-                </a:solidFill>
-              </a:ln>
-            </p:spPr>
-            <p:style>
-              <a:lnRef idx="2">
-                <a:schemeClr val="accent1">
-                  <a:shade val="15000"/>
-                </a:schemeClr>
-              </a:lnRef>
-              <a:fillRef idx="1">
-                <a:schemeClr val="accent1"/>
-              </a:fillRef>
-              <a:effectRef idx="0">
-                <a:schemeClr val="accent1"/>
-              </a:effectRef>
-              <a:fontRef idx="minor">
-                <a:schemeClr val="lt1"/>
-              </a:fontRef>
-            </p:style>
-            <p:txBody>
-              <a:bodyPr rtlCol="0" anchor="ctr"/>
-              <a:lstStyle/>
-              <a:p>
-                <a:pPr algn="ctr"/>
-                <a:endParaRPr lang="fr-FR"/>
-              </a:p>
-            </p:txBody>
-          </p:sp>
-          <p:sp>
-            <p:nvSpPr>
-              <p:cNvPr id="28" name="Ellipse 27">
-                <a:extLst>
-                  <a:ext uri="{FF2B5EF4-FFF2-40B4-BE49-F238E27FC236}">
-                    <a16:creationId xmlns:a16="http://schemas.microsoft.com/office/drawing/2014/main" id="{3F470448-C8CC-0973-726C-7FE5B9ECB8F4}"/>
-                  </a:ext>
-                </a:extLst>
-              </p:cNvPr>
-              <p:cNvSpPr/>
-              <p:nvPr/>
-            </p:nvSpPr>
-            <p:spPr>
-              <a:xfrm>
-                <a:off x="1844594" y="5078163"/>
-                <a:ext cx="180000" cy="180000"/>
-              </a:xfrm>
-              <a:prstGeom prst="ellipse">
-                <a:avLst/>
-              </a:prstGeom>
-              <a:solidFill>
-                <a:schemeClr val="bg1"/>
-              </a:solidFill>
-              <a:ln w="12700">
-                <a:solidFill>
-                  <a:schemeClr val="tx1"/>
-                </a:solidFill>
-              </a:ln>
-            </p:spPr>
-            <p:style>
-              <a:lnRef idx="2">
-                <a:schemeClr val="dk1">
-                  <a:shade val="15000"/>
-                </a:schemeClr>
-              </a:lnRef>
-              <a:fillRef idx="1">
-                <a:schemeClr val="dk1"/>
-              </a:fillRef>
-              <a:effectRef idx="0">
-                <a:schemeClr val="dk1"/>
-              </a:effectRef>
-              <a:fontRef idx="minor">
-                <a:schemeClr val="lt1"/>
-              </a:fontRef>
-            </p:style>
-            <p:txBody>
-              <a:bodyPr rtlCol="0" anchor="ctr"/>
-              <a:lstStyle/>
-              <a:p>
-                <a:pPr algn="ctr"/>
-                <a:endParaRPr lang="fr-FR"/>
-              </a:p>
-            </p:txBody>
-          </p:sp>
-        </p:grpSp>
-        <p:grpSp>
-          <p:nvGrpSpPr>
-            <p:cNvPr id="17" name="Groupe 16">
-              <a:extLst>
-                <a:ext uri="{FF2B5EF4-FFF2-40B4-BE49-F238E27FC236}">
-                  <a16:creationId xmlns:a16="http://schemas.microsoft.com/office/drawing/2014/main" id="{4F21B922-00A9-E5E8-8082-BA01DE083221}"/>
-                </a:ext>
-              </a:extLst>
-            </p:cNvPr>
-            <p:cNvGrpSpPr/>
-            <p:nvPr/>
-          </p:nvGrpSpPr>
-          <p:grpSpPr>
-            <a:xfrm>
-              <a:off x="1537763" y="1467957"/>
-              <a:ext cx="432000" cy="432000"/>
-              <a:chOff x="4767699" y="706251"/>
-              <a:chExt cx="432000" cy="432000"/>
-            </a:xfrm>
-          </p:grpSpPr>
-          <p:sp>
-            <p:nvSpPr>
-              <p:cNvPr id="8" name="Rectangle 7">
-                <a:extLst>
-                  <a:ext uri="{FF2B5EF4-FFF2-40B4-BE49-F238E27FC236}">
-                    <a16:creationId xmlns:a16="http://schemas.microsoft.com/office/drawing/2014/main" id="{CCF13C88-23D0-B025-E00D-0918033799D3}"/>
-                  </a:ext>
-                </a:extLst>
-              </p:cNvPr>
-              <p:cNvSpPr/>
-              <p:nvPr/>
-            </p:nvSpPr>
-            <p:spPr>
-              <a:xfrm>
-                <a:off x="4767699" y="706251"/>
-                <a:ext cx="432000" cy="432000"/>
-              </a:xfrm>
-              <a:prstGeom prst="rect">
-                <a:avLst/>
-              </a:prstGeom>
-              <a:blipFill dpi="0" rotWithShape="1">
-                <a:blip r:embed="rId3">
-                  <a:alphaModFix amt="50000"/>
-                  <a:extLst>
-                    <a:ext uri="{BEBA8EAE-BF5A-486C-A8C5-ECC9F3942E4B}">
-                      <a14:imgProps xmlns:a14="http://schemas.microsoft.com/office/drawing/2010/main">
-                        <a14:imgLayer r:embed="rId4">
-                          <a14:imgEffect>
-                            <a14:artisticWatercolorSponge/>
-                          </a14:imgEffect>
-                          <a14:imgEffect>
-                            <a14:brightnessContrast bright="-40000" contrast="20000"/>
-                          </a14:imgEffect>
-                        </a14:imgLayer>
-                      </a14:imgProps>
-                    </a:ext>
-                  </a:extLst>
-                </a:blip>
-                <a:srcRect/>
-                <a:tile tx="0" ty="0" sx="100000" sy="100000" flip="none" algn="tl"/>
-              </a:blipFill>
-              <a:ln>
-                <a:solidFill>
-                  <a:schemeClr val="tx1"/>
-                </a:solidFill>
-              </a:ln>
-            </p:spPr>
-            <p:style>
-              <a:lnRef idx="2">
-                <a:schemeClr val="accent1">
-                  <a:shade val="15000"/>
-                </a:schemeClr>
-              </a:lnRef>
-              <a:fillRef idx="1">
-                <a:schemeClr val="accent1"/>
-              </a:fillRef>
-              <a:effectRef idx="0">
-                <a:schemeClr val="accent1"/>
-              </a:effectRef>
-              <a:fontRef idx="minor">
-                <a:schemeClr val="lt1"/>
-              </a:fontRef>
-            </p:style>
-            <p:txBody>
-              <a:bodyPr lIns="0" tIns="0" rIns="0" bIns="0" rtlCol="0" anchor="ctr"/>
-              <a:lstStyle/>
-              <a:p>
-                <a:pPr algn="ctr"/>
-                <a:endParaRPr lang="fr-FR" sz="1600" b="1" dirty="0">
-                  <a:solidFill>
-                    <a:schemeClr val="bg1"/>
-                  </a:solidFill>
-                  <a:latin typeface="Segoe UI" panose="020B0502040204020203" pitchFamily="34" charset="0"/>
-                  <a:cs typeface="Segoe UI" panose="020B0502040204020203" pitchFamily="34" charset="0"/>
-                </a:endParaRPr>
-              </a:p>
-            </p:txBody>
-          </p:sp>
-          <p:sp>
-            <p:nvSpPr>
-              <p:cNvPr id="15" name="Rectangle 14">
-                <a:extLst>
-                  <a:ext uri="{FF2B5EF4-FFF2-40B4-BE49-F238E27FC236}">
-                    <a16:creationId xmlns:a16="http://schemas.microsoft.com/office/drawing/2014/main" id="{AF4DABCD-652C-070F-AA41-FD10465ED510}"/>
-                  </a:ext>
-                </a:extLst>
-              </p:cNvPr>
-              <p:cNvSpPr/>
-              <p:nvPr/>
-            </p:nvSpPr>
-            <p:spPr>
-              <a:xfrm>
-                <a:off x="4906909" y="799386"/>
-                <a:ext cx="153581" cy="245730"/>
-              </a:xfrm>
-              <a:prstGeom prst="rect">
-                <a:avLst/>
-              </a:prstGeom>
-              <a:solidFill>
-                <a:schemeClr val="bg1"/>
-              </a:solidFill>
-              <a:ln w="12700">
-                <a:solidFill>
-                  <a:schemeClr val="tx1"/>
-                </a:solidFill>
-              </a:ln>
-            </p:spPr>
-            <p:style>
-              <a:lnRef idx="2">
-                <a:schemeClr val="accent1">
-                  <a:shade val="15000"/>
-                </a:schemeClr>
-              </a:lnRef>
-              <a:fillRef idx="1">
-                <a:schemeClr val="accent1"/>
-              </a:fillRef>
-              <a:effectRef idx="0">
-                <a:schemeClr val="accent1"/>
-              </a:effectRef>
-              <a:fontRef idx="minor">
-                <a:schemeClr val="lt1"/>
-              </a:fontRef>
-            </p:style>
-            <p:txBody>
-              <a:bodyPr rtlCol="0" anchor="ctr"/>
-              <a:lstStyle/>
-              <a:p>
-                <a:pPr algn="ctr"/>
-                <a:endParaRPr lang="fr-FR"/>
-              </a:p>
-            </p:txBody>
-          </p:sp>
-        </p:grpSp>
-        <p:grpSp>
-          <p:nvGrpSpPr>
-            <p:cNvPr id="18" name="Groupe 17">
-              <a:extLst>
-                <a:ext uri="{FF2B5EF4-FFF2-40B4-BE49-F238E27FC236}">
-                  <a16:creationId xmlns:a16="http://schemas.microsoft.com/office/drawing/2014/main" id="{1B4E9ACA-649F-3EAA-4744-9CA2FA09C4C3}"/>
-                </a:ext>
-              </a:extLst>
-            </p:cNvPr>
-            <p:cNvGrpSpPr/>
-            <p:nvPr/>
-          </p:nvGrpSpPr>
-          <p:grpSpPr>
-            <a:xfrm>
-              <a:off x="3230650" y="1465522"/>
-              <a:ext cx="432000" cy="432000"/>
-              <a:chOff x="4767699" y="706251"/>
-              <a:chExt cx="432000" cy="432000"/>
-            </a:xfrm>
-          </p:grpSpPr>
-          <p:sp>
-            <p:nvSpPr>
-              <p:cNvPr id="19" name="Rectangle 18">
-                <a:extLst>
-                  <a:ext uri="{FF2B5EF4-FFF2-40B4-BE49-F238E27FC236}">
-                    <a16:creationId xmlns:a16="http://schemas.microsoft.com/office/drawing/2014/main" id="{DAC1549E-A4DE-ECB0-F43D-4DAE3A06BEA9}"/>
-                  </a:ext>
-                </a:extLst>
-              </p:cNvPr>
-              <p:cNvSpPr/>
-              <p:nvPr/>
-            </p:nvSpPr>
-            <p:spPr>
-              <a:xfrm>
-                <a:off x="4767699" y="706251"/>
-                <a:ext cx="432000" cy="432000"/>
-              </a:xfrm>
-              <a:prstGeom prst="rect">
-                <a:avLst/>
-              </a:prstGeom>
-              <a:blipFill dpi="0" rotWithShape="1">
-                <a:blip r:embed="rId3">
-                  <a:alphaModFix amt="50000"/>
-                  <a:extLst>
-                    <a:ext uri="{BEBA8EAE-BF5A-486C-A8C5-ECC9F3942E4B}">
-                      <a14:imgProps xmlns:a14="http://schemas.microsoft.com/office/drawing/2010/main">
-                        <a14:imgLayer r:embed="rId4">
-                          <a14:imgEffect>
-                            <a14:artisticWatercolorSponge/>
-                          </a14:imgEffect>
-                          <a14:imgEffect>
-                            <a14:brightnessContrast bright="-40000" contrast="20000"/>
-                          </a14:imgEffect>
-                        </a14:imgLayer>
-                      </a14:imgProps>
-                    </a:ext>
-                  </a:extLst>
-                </a:blip>
-                <a:srcRect/>
-                <a:tile tx="0" ty="0" sx="100000" sy="100000" flip="none" algn="tl"/>
-              </a:blipFill>
-              <a:ln>
-                <a:solidFill>
-                  <a:schemeClr val="tx1"/>
-                </a:solidFill>
-              </a:ln>
-            </p:spPr>
-            <p:style>
-              <a:lnRef idx="2">
-                <a:schemeClr val="accent1">
-                  <a:shade val="15000"/>
-                </a:schemeClr>
-              </a:lnRef>
-              <a:fillRef idx="1">
-                <a:schemeClr val="accent1"/>
-              </a:fillRef>
-              <a:effectRef idx="0">
-                <a:schemeClr val="accent1"/>
-              </a:effectRef>
-              <a:fontRef idx="minor">
-                <a:schemeClr val="lt1"/>
-              </a:fontRef>
-            </p:style>
-            <p:txBody>
-              <a:bodyPr lIns="0" tIns="0" rIns="0" bIns="0" rtlCol="0" anchor="ctr"/>
-              <a:lstStyle/>
-              <a:p>
-                <a:pPr algn="ctr"/>
-                <a:endParaRPr lang="fr-FR" sz="1600" b="1" dirty="0">
-                  <a:solidFill>
-                    <a:schemeClr val="bg1"/>
-                  </a:solidFill>
-                  <a:latin typeface="Segoe UI" panose="020B0502040204020203" pitchFamily="34" charset="0"/>
-                  <a:cs typeface="Segoe UI" panose="020B0502040204020203" pitchFamily="34" charset="0"/>
-                </a:endParaRPr>
-              </a:p>
-            </p:txBody>
-          </p:sp>
-          <p:sp>
-            <p:nvSpPr>
-              <p:cNvPr id="20" name="Rectangle 19">
-                <a:extLst>
-                  <a:ext uri="{FF2B5EF4-FFF2-40B4-BE49-F238E27FC236}">
-                    <a16:creationId xmlns:a16="http://schemas.microsoft.com/office/drawing/2014/main" id="{2A5F6F79-317F-D0DA-0B02-6804F02BF9F0}"/>
-                  </a:ext>
-                </a:extLst>
-              </p:cNvPr>
-              <p:cNvSpPr/>
-              <p:nvPr/>
-            </p:nvSpPr>
-            <p:spPr>
-              <a:xfrm>
-                <a:off x="4906909" y="799386"/>
-                <a:ext cx="153581" cy="245730"/>
-              </a:xfrm>
-              <a:prstGeom prst="rect">
-                <a:avLst/>
-              </a:prstGeom>
-              <a:solidFill>
-                <a:schemeClr val="bg1"/>
-              </a:solidFill>
-              <a:ln w="12700">
-                <a:solidFill>
-                  <a:schemeClr val="tx1"/>
-                </a:solidFill>
-              </a:ln>
-            </p:spPr>
-            <p:style>
-              <a:lnRef idx="2">
-                <a:schemeClr val="accent1">
-                  <a:shade val="15000"/>
-                </a:schemeClr>
-              </a:lnRef>
-              <a:fillRef idx="1">
-                <a:schemeClr val="accent1"/>
-              </a:fillRef>
-              <a:effectRef idx="0">
-                <a:schemeClr val="accent1"/>
-              </a:effectRef>
-              <a:fontRef idx="minor">
-                <a:schemeClr val="lt1"/>
-              </a:fontRef>
-            </p:style>
-            <p:txBody>
-              <a:bodyPr rtlCol="0" anchor="ctr"/>
-              <a:lstStyle/>
-              <a:p>
-                <a:pPr algn="ctr"/>
-                <a:endParaRPr lang="fr-FR"/>
-              </a:p>
-            </p:txBody>
-          </p:sp>
-        </p:grpSp>
-      </p:grpSp>
-      <p:grpSp>
-        <p:nvGrpSpPr>
-          <p:cNvPr id="29" name="Groupe 28">
-            <a:extLst>
-              <a:ext uri="{FF2B5EF4-FFF2-40B4-BE49-F238E27FC236}">
-                <a16:creationId xmlns:a16="http://schemas.microsoft.com/office/drawing/2014/main" id="{1BE4318C-E81A-8D37-833E-F6C792720F7A}"/>
+                <a16:creationId xmlns:a16="http://schemas.microsoft.com/office/drawing/2014/main" id="{2C9D8A01-883F-0032-5DA6-6552F6560293}"/>
               </a:ext>
             </a:extLst>
           </p:cNvPr>
@@ -11570,11 +10573,11 @@
               <a:avLst/>
             </a:prstGeom>
             <a:blipFill>
-              <a:blip r:embed="rId9">
+              <a:blip r:embed="rId6">
                 <a:extLst>
                   <a:ext uri="{BEBA8EAE-BF5A-486C-A8C5-ECC9F3942E4B}">
                     <a14:imgProps xmlns:a14="http://schemas.microsoft.com/office/drawing/2010/main">
-                      <a14:imgLayer r:embed="rId10">
+                      <a14:imgLayer r:embed="rId7">
                         <a14:imgEffect>
                           <a14:brightnessContrast bright="-20000" contrast="-40000"/>
                         </a14:imgEffect>
@@ -11637,11 +10640,11 @@
               <a:avLst/>
             </a:prstGeom>
             <a:blipFill>
-              <a:blip r:embed="rId9">
+              <a:blip r:embed="rId6">
                 <a:extLst>
                   <a:ext uri="{BEBA8EAE-BF5A-486C-A8C5-ECC9F3942E4B}">
                     <a14:imgProps xmlns:a14="http://schemas.microsoft.com/office/drawing/2010/main">
-                      <a14:imgLayer r:embed="rId10">
+                      <a14:imgLayer r:embed="rId7">
                         <a14:imgEffect>
                           <a14:brightnessContrast bright="-20000" contrast="-40000"/>
                         </a14:imgEffect>
@@ -11704,11 +10707,11 @@
               <a:avLst/>
             </a:prstGeom>
             <a:blipFill>
-              <a:blip r:embed="rId9">
+              <a:blip r:embed="rId6">
                 <a:extLst>
                   <a:ext uri="{BEBA8EAE-BF5A-486C-A8C5-ECC9F3942E4B}">
                     <a14:imgProps xmlns:a14="http://schemas.microsoft.com/office/drawing/2010/main">
-                      <a14:imgLayer r:embed="rId10">
+                      <a14:imgLayer r:embed="rId7">
                         <a14:imgEffect>
                           <a14:brightnessContrast bright="-20000" contrast="-40000"/>
                         </a14:imgEffect>
@@ -11948,7 +10951,7 @@
               <a:avLst/>
             </a:prstGeom>
             <a:blipFill>
-              <a:blip r:embed="rId6"/>
+              <a:blip r:embed="rId8"/>
               <a:tile tx="0" ty="0" sx="100000" sy="100000" flip="none" algn="tl"/>
             </a:blipFill>
             <a:ln w="12700">
@@ -12044,11 +11047,11 @@
               <a:avLst/>
             </a:prstGeom>
             <a:blipFill>
-              <a:blip r:embed="rId7">
+              <a:blip r:embed="rId9">
                 <a:extLst>
                   <a:ext uri="{BEBA8EAE-BF5A-486C-A8C5-ECC9F3942E4B}">
                     <a14:imgProps xmlns:a14="http://schemas.microsoft.com/office/drawing/2010/main">
-                      <a14:imgLayer r:embed="rId8">
+                      <a14:imgLayer r:embed="rId10">
                         <a14:imgEffect>
                           <a14:artisticGlass/>
                         </a14:imgEffect>
@@ -12239,11 +11242,11 @@
                 <a:avLst/>
               </a:prstGeom>
               <a:blipFill>
-                <a:blip r:embed="rId7">
+                <a:blip r:embed="rId9">
                   <a:extLst>
                     <a:ext uri="{BEBA8EAE-BF5A-486C-A8C5-ECC9F3942E4B}">
                       <a14:imgProps xmlns:a14="http://schemas.microsoft.com/office/drawing/2010/main">
-                        <a14:imgLayer r:embed="rId8">
+                        <a14:imgLayer r:embed="rId10">
                           <a14:imgEffect>
                             <a14:artisticGlass/>
                           </a14:imgEffect>
@@ -12361,11 +11364,11 @@
               <a:avLst/>
             </a:prstGeom>
             <a:blipFill>
-              <a:blip r:embed="rId7">
+              <a:blip r:embed="rId9">
                 <a:extLst>
                   <a:ext uri="{BEBA8EAE-BF5A-486C-A8C5-ECC9F3942E4B}">
                     <a14:imgProps xmlns:a14="http://schemas.microsoft.com/office/drawing/2010/main">
-                      <a14:imgLayer r:embed="rId8">
+                      <a14:imgLayer r:embed="rId10">
                         <a14:imgEffect>
                           <a14:artisticGlass/>
                         </a14:imgEffect>
@@ -12660,13 +11663,58 @@
             </a:p>
           </p:txBody>
         </p:sp>
+        <p:pic>
+          <p:nvPicPr>
+            <p:cNvPr id="2" name="Image 1">
+              <a:extLst>
+                <a:ext uri="{FF2B5EF4-FFF2-40B4-BE49-F238E27FC236}">
+                  <a16:creationId xmlns:a16="http://schemas.microsoft.com/office/drawing/2014/main" id="{DB7CB790-A06D-1B7A-B2B7-D32D6EA61BE6}"/>
+                </a:ext>
+              </a:extLst>
+            </p:cNvPr>
+            <p:cNvPicPr>
+              <a:picLocks noChangeAspect="1"/>
+            </p:cNvPicPr>
+            <p:nvPr/>
+          </p:nvPicPr>
+          <p:blipFill>
+            <a:blip r:embed="rId12">
+              <a:extLst>
+                <a:ext uri="{BEBA8EAE-BF5A-486C-A8C5-ECC9F3942E4B}">
+                  <a14:imgProps xmlns:a14="http://schemas.microsoft.com/office/drawing/2010/main">
+                    <a14:imgLayer r:embed="rId13">
+                      <a14:imgEffect>
+                        <a14:brightnessContrast contrast="40000"/>
+                      </a14:imgEffect>
+                    </a14:imgLayer>
+                  </a14:imgProps>
+                </a:ext>
+                <a:ext uri="{28A0092B-C50C-407E-A947-70E740481C1C}">
+                  <a14:useLocalDpi xmlns:a14="http://schemas.microsoft.com/office/drawing/2010/main" val="0"/>
+                </a:ext>
+              </a:extLst>
+            </a:blip>
+            <a:stretch>
+              <a:fillRect/>
+            </a:stretch>
+          </p:blipFill>
+          <p:spPr>
+            <a:xfrm>
+              <a:off x="5826000" y="2601711"/>
+              <a:ext cx="540000" cy="540000"/>
+            </a:xfrm>
+            <a:prstGeom prst="rect">
+              <a:avLst/>
+            </a:prstGeom>
+          </p:spPr>
+        </p:pic>
       </p:grpSp>
       <p:grpSp>
         <p:nvGrpSpPr>
-          <p:cNvPr id="33" name="Groupe 32">
+          <p:cNvPr id="14" name="Groupe 13">
             <a:extLst>
               <a:ext uri="{FF2B5EF4-FFF2-40B4-BE49-F238E27FC236}">
-                <a16:creationId xmlns:a16="http://schemas.microsoft.com/office/drawing/2014/main" id="{78022EFA-2762-8C03-0292-C78C8E62D721}"/>
+                <a16:creationId xmlns:a16="http://schemas.microsoft.com/office/drawing/2014/main" id="{BC67B85F-CA29-AB7E-BAE1-948AC1198E38}"/>
               </a:ext>
             </a:extLst>
           </p:cNvPr>
@@ -12898,11 +11946,11 @@
               <a:avLst/>
             </a:prstGeom>
             <a:blipFill>
-              <a:blip r:embed="rId9">
+              <a:blip r:embed="rId6">
                 <a:extLst>
                   <a:ext uri="{BEBA8EAE-BF5A-486C-A8C5-ECC9F3942E4B}">
                     <a14:imgProps xmlns:a14="http://schemas.microsoft.com/office/drawing/2010/main">
-                      <a14:imgLayer r:embed="rId10">
+                      <a14:imgLayer r:embed="rId7">
                         <a14:imgEffect>
                           <a14:brightnessContrast bright="-20000" contrast="-40000"/>
                         </a14:imgEffect>
@@ -12965,11 +12013,11 @@
               <a:avLst/>
             </a:prstGeom>
             <a:blipFill>
-              <a:blip r:embed="rId9">
+              <a:blip r:embed="rId6">
                 <a:extLst>
                   <a:ext uri="{BEBA8EAE-BF5A-486C-A8C5-ECC9F3942E4B}">
                     <a14:imgProps xmlns:a14="http://schemas.microsoft.com/office/drawing/2010/main">
-                      <a14:imgLayer r:embed="rId10">
+                      <a14:imgLayer r:embed="rId7">
                         <a14:imgEffect>
                           <a14:brightnessContrast bright="-20000" contrast="-40000"/>
                         </a14:imgEffect>
@@ -13032,11 +12080,11 @@
               <a:avLst/>
             </a:prstGeom>
             <a:blipFill>
-              <a:blip r:embed="rId9">
+              <a:blip r:embed="rId6">
                 <a:extLst>
                   <a:ext uri="{BEBA8EAE-BF5A-486C-A8C5-ECC9F3942E4B}">
                     <a14:imgProps xmlns:a14="http://schemas.microsoft.com/office/drawing/2010/main">
-                      <a14:imgLayer r:embed="rId10">
+                      <a14:imgLayer r:embed="rId7">
                         <a14:imgEffect>
                           <a14:brightnessContrast bright="-20000" contrast="-40000"/>
                         </a14:imgEffect>
@@ -13194,7 +12242,7 @@
               <a:avLst/>
             </a:prstGeom>
             <a:blipFill>
-              <a:blip r:embed="rId6"/>
+              <a:blip r:embed="rId8"/>
               <a:tile tx="0" ty="0" sx="100000" sy="100000" flip="none" algn="tl"/>
             </a:blipFill>
             <a:ln w="12700">
@@ -13249,7 +12297,7 @@
               <a:avLst/>
             </a:prstGeom>
             <a:blipFill>
-              <a:blip r:embed="rId6"/>
+              <a:blip r:embed="rId8"/>
               <a:tile tx="0" ty="0" sx="100000" sy="100000" flip="none" algn="tl"/>
             </a:blipFill>
             <a:ln w="12700">
@@ -13304,7 +12352,7 @@
               <a:avLst/>
             </a:prstGeom>
             <a:blipFill>
-              <a:blip r:embed="rId6"/>
+              <a:blip r:embed="rId8"/>
               <a:tile tx="0" ty="0" sx="100000" sy="100000" flip="none" algn="tl"/>
             </a:blipFill>
             <a:ln w="12700">
@@ -13461,11 +12509,11 @@
                 <a:avLst/>
               </a:prstGeom>
               <a:blipFill>
-                <a:blip r:embed="rId7">
+                <a:blip r:embed="rId9">
                   <a:extLst>
                     <a:ext uri="{BEBA8EAE-BF5A-486C-A8C5-ECC9F3942E4B}">
                       <a14:imgProps xmlns:a14="http://schemas.microsoft.com/office/drawing/2010/main">
-                        <a14:imgLayer r:embed="rId8">
+                        <a14:imgLayer r:embed="rId10">
                           <a14:imgEffect>
                             <a14:artisticGlass/>
                           </a14:imgEffect>
@@ -13657,11 +12705,11 @@
                 <a:avLst/>
               </a:prstGeom>
               <a:blipFill>
-                <a:blip r:embed="rId7">
+                <a:blip r:embed="rId9">
                   <a:extLst>
                     <a:ext uri="{BEBA8EAE-BF5A-486C-A8C5-ECC9F3942E4B}">
                       <a14:imgProps xmlns:a14="http://schemas.microsoft.com/office/drawing/2010/main">
-                        <a14:imgLayer r:embed="rId8">
+                        <a14:imgLayer r:embed="rId10">
                           <a14:imgEffect>
                             <a14:artisticGlass/>
                           </a14:imgEffect>
@@ -13799,11 +12847,11 @@
                 <a:avLst/>
               </a:prstGeom>
               <a:blipFill>
-                <a:blip r:embed="rId7">
+                <a:blip r:embed="rId9">
                   <a:extLst>
                     <a:ext uri="{BEBA8EAE-BF5A-486C-A8C5-ECC9F3942E4B}">
                       <a14:imgProps xmlns:a14="http://schemas.microsoft.com/office/drawing/2010/main">
-                        <a14:imgLayer r:embed="rId8">
+                        <a14:imgLayer r:embed="rId10">
                           <a14:imgEffect>
                             <a14:artisticGlass/>
                           </a14:imgEffect>
@@ -14099,6 +13147,1176 @@
             </a:p>
           </p:txBody>
         </p:sp>
+        <p:pic>
+          <p:nvPicPr>
+            <p:cNvPr id="6" name="Image 5">
+              <a:extLst>
+                <a:ext uri="{FF2B5EF4-FFF2-40B4-BE49-F238E27FC236}">
+                  <a16:creationId xmlns:a16="http://schemas.microsoft.com/office/drawing/2014/main" id="{3344278A-54FC-6AFF-E07E-49030D4ED02A}"/>
+                </a:ext>
+              </a:extLst>
+            </p:cNvPr>
+            <p:cNvPicPr>
+              <a:picLocks noChangeAspect="1"/>
+            </p:cNvPicPr>
+            <p:nvPr/>
+          </p:nvPicPr>
+          <p:blipFill>
+            <a:blip r:embed="rId12">
+              <a:extLst>
+                <a:ext uri="{BEBA8EAE-BF5A-486C-A8C5-ECC9F3942E4B}">
+                  <a14:imgProps xmlns:a14="http://schemas.microsoft.com/office/drawing/2010/main">
+                    <a14:imgLayer r:embed="rId13">
+                      <a14:imgEffect>
+                        <a14:brightnessContrast contrast="40000"/>
+                      </a14:imgEffect>
+                    </a14:imgLayer>
+                  </a14:imgProps>
+                </a:ext>
+                <a:ext uri="{28A0092B-C50C-407E-A947-70E740481C1C}">
+                  <a14:useLocalDpi xmlns:a14="http://schemas.microsoft.com/office/drawing/2010/main" val="0"/>
+                </a:ext>
+              </a:extLst>
+            </a:blip>
+            <a:stretch>
+              <a:fillRect/>
+            </a:stretch>
+          </p:blipFill>
+          <p:spPr>
+            <a:xfrm>
+              <a:off x="8689028" y="2573361"/>
+              <a:ext cx="540000" cy="540000"/>
+            </a:xfrm>
+            <a:prstGeom prst="rect">
+              <a:avLst/>
+            </a:prstGeom>
+          </p:spPr>
+        </p:pic>
+      </p:grpSp>
+      <p:grpSp>
+        <p:nvGrpSpPr>
+          <p:cNvPr id="12" name="Groupe 11">
+            <a:extLst>
+              <a:ext uri="{FF2B5EF4-FFF2-40B4-BE49-F238E27FC236}">
+                <a16:creationId xmlns:a16="http://schemas.microsoft.com/office/drawing/2014/main" id="{621A0E50-51D0-10A6-9B45-E9366FE3269F}"/>
+              </a:ext>
+            </a:extLst>
+          </p:cNvPr>
+          <p:cNvGrpSpPr/>
+          <p:nvPr/>
+        </p:nvGrpSpPr>
+        <p:grpSpPr>
+          <a:xfrm>
+            <a:off x="1537763" y="1464756"/>
+            <a:ext cx="2124887" cy="3312766"/>
+            <a:chOff x="1537763" y="1464756"/>
+            <a:chExt cx="2124887" cy="3312766"/>
+          </a:xfrm>
+        </p:grpSpPr>
+        <p:sp>
+          <p:nvSpPr>
+            <p:cNvPr id="86" name="Rectangle 85">
+              <a:extLst>
+                <a:ext uri="{FF2B5EF4-FFF2-40B4-BE49-F238E27FC236}">
+                  <a16:creationId xmlns:a16="http://schemas.microsoft.com/office/drawing/2014/main" id="{04E5B47C-2EF9-89AC-F731-DD6CB8B619DF}"/>
+                </a:ext>
+              </a:extLst>
+            </p:cNvPr>
+            <p:cNvSpPr/>
+            <p:nvPr/>
+          </p:nvSpPr>
+          <p:spPr>
+            <a:xfrm>
+              <a:off x="1537763" y="1465522"/>
+              <a:ext cx="2124000" cy="3312000"/>
+            </a:xfrm>
+            <a:prstGeom prst="rect">
+              <a:avLst/>
+            </a:prstGeom>
+            <a:blipFill dpi="0" rotWithShape="1">
+              <a:blip r:embed="rId2">
+                <a:alphaModFix amt="75000"/>
+              </a:blip>
+              <a:srcRect/>
+              <a:tile tx="0" ty="0" sx="100000" sy="100000" flip="none" algn="tl"/>
+            </a:blipFill>
+          </p:spPr>
+          <p:style>
+            <a:lnRef idx="2">
+              <a:schemeClr val="accent1">
+                <a:shade val="15000"/>
+              </a:schemeClr>
+            </a:lnRef>
+            <a:fillRef idx="1">
+              <a:schemeClr val="accent1"/>
+            </a:fillRef>
+            <a:effectRef idx="0">
+              <a:schemeClr val="accent1"/>
+            </a:effectRef>
+            <a:fontRef idx="minor">
+              <a:schemeClr val="lt1"/>
+            </a:fontRef>
+          </p:style>
+          <p:txBody>
+            <a:bodyPr rtlCol="0" anchor="ctr"/>
+            <a:lstStyle/>
+            <a:p>
+              <a:pPr algn="ctr"/>
+              <a:endParaRPr lang="fr-FR"/>
+            </a:p>
+          </p:txBody>
+        </p:sp>
+        <p:sp>
+          <p:nvSpPr>
+            <p:cNvPr id="87" name="Rectangle 86">
+              <a:extLst>
+                <a:ext uri="{FF2B5EF4-FFF2-40B4-BE49-F238E27FC236}">
+                  <a16:creationId xmlns:a16="http://schemas.microsoft.com/office/drawing/2014/main" id="{371948D6-45CF-6980-CCC9-79FC16314AE7}"/>
+                </a:ext>
+              </a:extLst>
+            </p:cNvPr>
+            <p:cNvSpPr/>
+            <p:nvPr/>
+          </p:nvSpPr>
+          <p:spPr>
+            <a:xfrm>
+              <a:off x="1969764" y="1464756"/>
+              <a:ext cx="1259999" cy="432000"/>
+            </a:xfrm>
+            <a:prstGeom prst="rect">
+              <a:avLst/>
+            </a:prstGeom>
+            <a:blipFill dpi="0" rotWithShape="1">
+              <a:blip r:embed="rId3">
+                <a:alphaModFix amt="50000"/>
+                <a:extLst>
+                  <a:ext uri="{BEBA8EAE-BF5A-486C-A8C5-ECC9F3942E4B}">
+                    <a14:imgProps xmlns:a14="http://schemas.microsoft.com/office/drawing/2010/main">
+                      <a14:imgLayer r:embed="rId4">
+                        <a14:imgEffect>
+                          <a14:artisticWatercolorSponge/>
+                        </a14:imgEffect>
+                        <a14:imgEffect>
+                          <a14:brightnessContrast bright="-40000" contrast="20000"/>
+                        </a14:imgEffect>
+                      </a14:imgLayer>
+                    </a14:imgProps>
+                  </a:ext>
+                </a:extLst>
+              </a:blip>
+              <a:srcRect/>
+              <a:tile tx="0" ty="0" sx="100000" sy="100000" flip="none" algn="tl"/>
+            </a:blipFill>
+            <a:ln>
+              <a:solidFill>
+                <a:schemeClr val="tx1"/>
+              </a:solidFill>
+            </a:ln>
+          </p:spPr>
+          <p:style>
+            <a:lnRef idx="2">
+              <a:schemeClr val="accent1">
+                <a:shade val="15000"/>
+              </a:schemeClr>
+            </a:lnRef>
+            <a:fillRef idx="1">
+              <a:schemeClr val="accent1"/>
+            </a:fillRef>
+            <a:effectRef idx="0">
+              <a:schemeClr val="accent1"/>
+            </a:effectRef>
+            <a:fontRef idx="minor">
+              <a:schemeClr val="lt1"/>
+            </a:fontRef>
+          </p:style>
+          <p:txBody>
+            <a:bodyPr rtlCol="0" anchor="ctr"/>
+            <a:lstStyle/>
+            <a:p>
+              <a:pPr algn="ctr"/>
+              <a:r>
+                <a:rPr lang="fr-FR" sz="1200" b="1" dirty="0">
+                  <a:solidFill>
+                    <a:schemeClr val="bg1"/>
+                  </a:solidFill>
+                  <a:latin typeface="Segoe UI" panose="020B0502040204020203" pitchFamily="34" charset="0"/>
+                  <a:cs typeface="Segoe UI" panose="020B0502040204020203" pitchFamily="34" charset="0"/>
+                </a:rPr>
+                <a:t>Construire donjon</a:t>
+              </a:r>
+            </a:p>
+          </p:txBody>
+        </p:sp>
+        <p:sp>
+          <p:nvSpPr>
+            <p:cNvPr id="88" name="Cercle : creux 87">
+              <a:extLst>
+                <a:ext uri="{FF2B5EF4-FFF2-40B4-BE49-F238E27FC236}">
+                  <a16:creationId xmlns:a16="http://schemas.microsoft.com/office/drawing/2014/main" id="{083AAB54-2D50-7886-D049-84B2430A33A2}"/>
+                </a:ext>
+              </a:extLst>
+            </p:cNvPr>
+            <p:cNvSpPr/>
+            <p:nvPr/>
+          </p:nvSpPr>
+          <p:spPr>
+            <a:xfrm>
+              <a:off x="1640654" y="4297549"/>
+              <a:ext cx="360000" cy="360000"/>
+            </a:xfrm>
+            <a:prstGeom prst="donut">
+              <a:avLst>
+                <a:gd name="adj" fmla="val 15271"/>
+              </a:avLst>
+            </a:prstGeom>
+            <a:blipFill>
+              <a:blip r:embed="rId5"/>
+              <a:tile tx="0" ty="0" sx="100000" sy="100000" flip="none" algn="tl"/>
+            </a:blipFill>
+            <a:ln w="12700"/>
+          </p:spPr>
+          <p:style>
+            <a:lnRef idx="2">
+              <a:schemeClr val="dk1">
+                <a:shade val="15000"/>
+              </a:schemeClr>
+            </a:lnRef>
+            <a:fillRef idx="1">
+              <a:schemeClr val="dk1"/>
+            </a:fillRef>
+            <a:effectRef idx="0">
+              <a:schemeClr val="dk1"/>
+            </a:effectRef>
+            <a:fontRef idx="minor">
+              <a:schemeClr val="lt1"/>
+            </a:fontRef>
+          </p:style>
+          <p:txBody>
+            <a:bodyPr rtlCol="0" anchor="ctr"/>
+            <a:lstStyle/>
+            <a:p>
+              <a:pPr algn="ctr"/>
+              <a:r>
+                <a:rPr lang="fr-FR" b="1" dirty="0">
+                  <a:solidFill>
+                    <a:schemeClr val="bg1"/>
+                  </a:solidFill>
+                  <a:latin typeface="Segoe UI" panose="020B0502040204020203" pitchFamily="34" charset="0"/>
+                  <a:cs typeface="Segoe UI" panose="020B0502040204020203" pitchFamily="34" charset="0"/>
+                </a:rPr>
+                <a:t>3</a:t>
+              </a:r>
+            </a:p>
+          </p:txBody>
+        </p:sp>
+        <p:sp>
+          <p:nvSpPr>
+            <p:cNvPr id="89" name="Hexagone 88">
+              <a:extLst>
+                <a:ext uri="{FF2B5EF4-FFF2-40B4-BE49-F238E27FC236}">
+                  <a16:creationId xmlns:a16="http://schemas.microsoft.com/office/drawing/2014/main" id="{64DD3239-986E-50CD-B1CF-21E5A6A8394C}"/>
+                </a:ext>
+              </a:extLst>
+            </p:cNvPr>
+            <p:cNvSpPr/>
+            <p:nvPr/>
+          </p:nvSpPr>
+          <p:spPr>
+            <a:xfrm rot="5400000">
+              <a:off x="1755725" y="3320523"/>
+              <a:ext cx="648000" cy="612000"/>
+            </a:xfrm>
+            <a:prstGeom prst="hexagon">
+              <a:avLst/>
+            </a:prstGeom>
+            <a:solidFill>
+              <a:schemeClr val="bg1"/>
+            </a:solidFill>
+            <a:ln w="12700">
+              <a:solidFill>
+                <a:schemeClr val="tx1"/>
+              </a:solidFill>
+            </a:ln>
+          </p:spPr>
+          <p:style>
+            <a:lnRef idx="2">
+              <a:schemeClr val="accent1">
+                <a:shade val="15000"/>
+              </a:schemeClr>
+            </a:lnRef>
+            <a:fillRef idx="1">
+              <a:schemeClr val="accent1"/>
+            </a:fillRef>
+            <a:effectRef idx="0">
+              <a:schemeClr val="accent1"/>
+            </a:effectRef>
+            <a:fontRef idx="minor">
+              <a:schemeClr val="lt1"/>
+            </a:fontRef>
+          </p:style>
+          <p:txBody>
+            <a:bodyPr rtlCol="0" anchor="ctr"/>
+            <a:lstStyle/>
+            <a:p>
+              <a:pPr algn="ctr"/>
+              <a:endParaRPr lang="fr-FR"/>
+            </a:p>
+          </p:txBody>
+        </p:sp>
+        <p:sp>
+          <p:nvSpPr>
+            <p:cNvPr id="90" name="Ellipse 89">
+              <a:extLst>
+                <a:ext uri="{FF2B5EF4-FFF2-40B4-BE49-F238E27FC236}">
+                  <a16:creationId xmlns:a16="http://schemas.microsoft.com/office/drawing/2014/main" id="{92AD6DEC-A3F1-4FA6-CA5A-2E9C8BCBFBE3}"/>
+                </a:ext>
+              </a:extLst>
+            </p:cNvPr>
+            <p:cNvSpPr/>
+            <p:nvPr/>
+          </p:nvSpPr>
+          <p:spPr>
+            <a:xfrm>
+              <a:off x="1989725" y="3391444"/>
+              <a:ext cx="180000" cy="180000"/>
+            </a:xfrm>
+            <a:prstGeom prst="ellipse">
+              <a:avLst/>
+            </a:prstGeom>
+            <a:blipFill>
+              <a:blip r:embed="rId8"/>
+              <a:tile tx="0" ty="0" sx="100000" sy="100000" flip="none" algn="tl"/>
+            </a:blipFill>
+            <a:ln w="12700">
+              <a:solidFill>
+                <a:schemeClr val="tx1"/>
+              </a:solidFill>
+            </a:ln>
+          </p:spPr>
+          <p:style>
+            <a:lnRef idx="2">
+              <a:schemeClr val="dk1">
+                <a:shade val="15000"/>
+              </a:schemeClr>
+            </a:lnRef>
+            <a:fillRef idx="1">
+              <a:schemeClr val="dk1"/>
+            </a:fillRef>
+            <a:effectRef idx="0">
+              <a:schemeClr val="dk1"/>
+            </a:effectRef>
+            <a:fontRef idx="minor">
+              <a:schemeClr val="lt1"/>
+            </a:fontRef>
+          </p:style>
+          <p:txBody>
+            <a:bodyPr rtlCol="0" anchor="ctr"/>
+            <a:lstStyle/>
+            <a:p>
+              <a:pPr algn="ctr"/>
+              <a:endParaRPr lang="fr-FR"/>
+            </a:p>
+          </p:txBody>
+        </p:sp>
+        <p:sp>
+          <p:nvSpPr>
+            <p:cNvPr id="91" name="Ellipse 90">
+              <a:extLst>
+                <a:ext uri="{FF2B5EF4-FFF2-40B4-BE49-F238E27FC236}">
+                  <a16:creationId xmlns:a16="http://schemas.microsoft.com/office/drawing/2014/main" id="{5C68161E-7F59-9AC8-44AA-374BE2A11AEF}"/>
+                </a:ext>
+              </a:extLst>
+            </p:cNvPr>
+            <p:cNvSpPr/>
+            <p:nvPr/>
+          </p:nvSpPr>
+          <p:spPr>
+            <a:xfrm>
+              <a:off x="2119242" y="3610970"/>
+              <a:ext cx="180000" cy="180000"/>
+            </a:xfrm>
+            <a:prstGeom prst="ellipse">
+              <a:avLst/>
+            </a:prstGeom>
+            <a:blipFill>
+              <a:blip r:embed="rId8"/>
+              <a:tile tx="0" ty="0" sx="100000" sy="100000" flip="none" algn="tl"/>
+            </a:blipFill>
+            <a:ln w="12700">
+              <a:solidFill>
+                <a:schemeClr val="tx1"/>
+              </a:solidFill>
+            </a:ln>
+          </p:spPr>
+          <p:style>
+            <a:lnRef idx="2">
+              <a:schemeClr val="dk1">
+                <a:shade val="15000"/>
+              </a:schemeClr>
+            </a:lnRef>
+            <a:fillRef idx="1">
+              <a:schemeClr val="dk1"/>
+            </a:fillRef>
+            <a:effectRef idx="0">
+              <a:schemeClr val="dk1"/>
+            </a:effectRef>
+            <a:fontRef idx="minor">
+              <a:schemeClr val="lt1"/>
+            </a:fontRef>
+          </p:style>
+          <p:txBody>
+            <a:bodyPr rtlCol="0" anchor="ctr"/>
+            <a:lstStyle/>
+            <a:p>
+              <a:pPr algn="ctr"/>
+              <a:endParaRPr lang="fr-FR"/>
+            </a:p>
+          </p:txBody>
+        </p:sp>
+        <p:sp>
+          <p:nvSpPr>
+            <p:cNvPr id="92" name="Ellipse 91">
+              <a:extLst>
+                <a:ext uri="{FF2B5EF4-FFF2-40B4-BE49-F238E27FC236}">
+                  <a16:creationId xmlns:a16="http://schemas.microsoft.com/office/drawing/2014/main" id="{A4E33891-1EE5-37D8-B485-109AA56F6B98}"/>
+                </a:ext>
+              </a:extLst>
+            </p:cNvPr>
+            <p:cNvSpPr/>
+            <p:nvPr/>
+          </p:nvSpPr>
+          <p:spPr>
+            <a:xfrm>
+              <a:off x="1848595" y="3605466"/>
+              <a:ext cx="180000" cy="180000"/>
+            </a:xfrm>
+            <a:prstGeom prst="ellipse">
+              <a:avLst/>
+            </a:prstGeom>
+            <a:blipFill>
+              <a:blip r:embed="rId8"/>
+              <a:tile tx="0" ty="0" sx="100000" sy="100000" flip="none" algn="tl"/>
+            </a:blipFill>
+            <a:ln w="12700">
+              <a:solidFill>
+                <a:schemeClr val="tx1"/>
+              </a:solidFill>
+            </a:ln>
+          </p:spPr>
+          <p:style>
+            <a:lnRef idx="2">
+              <a:schemeClr val="dk1">
+                <a:shade val="15000"/>
+              </a:schemeClr>
+            </a:lnRef>
+            <a:fillRef idx="1">
+              <a:schemeClr val="dk1"/>
+            </a:fillRef>
+            <a:effectRef idx="0">
+              <a:schemeClr val="dk1"/>
+            </a:effectRef>
+            <a:fontRef idx="minor">
+              <a:schemeClr val="lt1"/>
+            </a:fontRef>
+          </p:style>
+          <p:txBody>
+            <a:bodyPr rtlCol="0" anchor="ctr"/>
+            <a:lstStyle/>
+            <a:p>
+              <a:pPr algn="ctr"/>
+              <a:endParaRPr lang="fr-FR"/>
+            </a:p>
+          </p:txBody>
+        </p:sp>
+        <p:sp>
+          <p:nvSpPr>
+            <p:cNvPr id="93" name="Hexagone 92">
+              <a:extLst>
+                <a:ext uri="{FF2B5EF4-FFF2-40B4-BE49-F238E27FC236}">
+                  <a16:creationId xmlns:a16="http://schemas.microsoft.com/office/drawing/2014/main" id="{919BB814-7094-E3A0-B787-C9F98EFC1CCB}"/>
+                </a:ext>
+              </a:extLst>
+            </p:cNvPr>
+            <p:cNvSpPr/>
+            <p:nvPr/>
+          </p:nvSpPr>
+          <p:spPr>
+            <a:xfrm rot="5400000">
+              <a:off x="2814838" y="3321356"/>
+              <a:ext cx="648000" cy="612000"/>
+            </a:xfrm>
+            <a:prstGeom prst="hexagon">
+              <a:avLst/>
+            </a:prstGeom>
+            <a:solidFill>
+              <a:schemeClr val="bg1"/>
+            </a:solidFill>
+            <a:ln w="12700">
+              <a:solidFill>
+                <a:schemeClr val="tx1"/>
+              </a:solidFill>
+            </a:ln>
+          </p:spPr>
+          <p:style>
+            <a:lnRef idx="2">
+              <a:schemeClr val="accent1">
+                <a:shade val="15000"/>
+              </a:schemeClr>
+            </a:lnRef>
+            <a:fillRef idx="1">
+              <a:schemeClr val="accent1"/>
+            </a:fillRef>
+            <a:effectRef idx="0">
+              <a:schemeClr val="accent1"/>
+            </a:effectRef>
+            <a:fontRef idx="minor">
+              <a:schemeClr val="lt1"/>
+            </a:fontRef>
+          </p:style>
+          <p:txBody>
+            <a:bodyPr rtlCol="0" anchor="ctr"/>
+            <a:lstStyle/>
+            <a:p>
+              <a:pPr algn="ctr"/>
+              <a:endParaRPr lang="fr-FR"/>
+            </a:p>
+          </p:txBody>
+        </p:sp>
+        <p:sp>
+          <p:nvSpPr>
+            <p:cNvPr id="94" name="Rectangle 93">
+              <a:extLst>
+                <a:ext uri="{FF2B5EF4-FFF2-40B4-BE49-F238E27FC236}">
+                  <a16:creationId xmlns:a16="http://schemas.microsoft.com/office/drawing/2014/main" id="{63D6D6F8-EDD7-5FBF-5A28-7D7A39D31B49}"/>
+                </a:ext>
+              </a:extLst>
+            </p:cNvPr>
+            <p:cNvSpPr/>
+            <p:nvPr/>
+          </p:nvSpPr>
+          <p:spPr>
+            <a:xfrm>
+              <a:off x="3059451" y="3433495"/>
+              <a:ext cx="180000" cy="360000"/>
+            </a:xfrm>
+            <a:prstGeom prst="rect">
+              <a:avLst/>
+            </a:prstGeom>
+            <a:blipFill>
+              <a:blip r:embed="rId8"/>
+              <a:tile tx="0" ty="0" sx="100000" sy="100000" flip="none" algn="tl"/>
+            </a:blipFill>
+            <a:ln w="12700">
+              <a:solidFill>
+                <a:schemeClr val="tx1"/>
+              </a:solidFill>
+            </a:ln>
+          </p:spPr>
+          <p:style>
+            <a:lnRef idx="2">
+              <a:schemeClr val="accent1">
+                <a:shade val="15000"/>
+              </a:schemeClr>
+            </a:lnRef>
+            <a:fillRef idx="1">
+              <a:schemeClr val="accent1"/>
+            </a:fillRef>
+            <a:effectRef idx="0">
+              <a:schemeClr val="accent1"/>
+            </a:effectRef>
+            <a:fontRef idx="minor">
+              <a:schemeClr val="lt1"/>
+            </a:fontRef>
+          </p:style>
+          <p:txBody>
+            <a:bodyPr rtlCol="0" anchor="ctr"/>
+            <a:lstStyle/>
+            <a:p>
+              <a:pPr algn="ctr"/>
+              <a:endParaRPr lang="fr-FR"/>
+            </a:p>
+          </p:txBody>
+        </p:sp>
+        <p:sp>
+          <p:nvSpPr>
+            <p:cNvPr id="95" name="ZoneTexte 94">
+              <a:extLst>
+                <a:ext uri="{FF2B5EF4-FFF2-40B4-BE49-F238E27FC236}">
+                  <a16:creationId xmlns:a16="http://schemas.microsoft.com/office/drawing/2014/main" id="{AA03724E-9EEB-1F4F-5B83-18D8579C4464}"/>
+                </a:ext>
+              </a:extLst>
+            </p:cNvPr>
+            <p:cNvSpPr txBox="1"/>
+            <p:nvPr/>
+          </p:nvSpPr>
+          <p:spPr>
+            <a:xfrm>
+              <a:off x="1607355" y="1968526"/>
+              <a:ext cx="1612957" cy="1015663"/>
+            </a:xfrm>
+            <a:prstGeom prst="rect">
+              <a:avLst/>
+            </a:prstGeom>
+            <a:noFill/>
+          </p:spPr>
+          <p:txBody>
+            <a:bodyPr wrap="square" rtlCol="0">
+              <a:spAutoFit/>
+            </a:bodyPr>
+            <a:lstStyle/>
+            <a:p>
+              <a:r>
+                <a:rPr lang="fr-FR" sz="1200" b="1" dirty="0">
+                  <a:solidFill>
+                    <a:schemeClr val="bg1"/>
+                  </a:solidFill>
+                  <a:latin typeface="Segoe UI" panose="020B0502040204020203" pitchFamily="34" charset="0"/>
+                  <a:cs typeface="Segoe UI" panose="020B0502040204020203" pitchFamily="34" charset="0"/>
+                </a:rPr>
+                <a:t>Défausser 3 troupes de la tuile de commandement pour construire</a:t>
+              </a:r>
+              <a:br>
+                <a:rPr lang="fr-FR" sz="1200" b="1" dirty="0">
+                  <a:solidFill>
+                    <a:schemeClr val="bg1"/>
+                  </a:solidFill>
+                  <a:latin typeface="Segoe UI" panose="020B0502040204020203" pitchFamily="34" charset="0"/>
+                  <a:cs typeface="Segoe UI" panose="020B0502040204020203" pitchFamily="34" charset="0"/>
+                </a:rPr>
+              </a:br>
+              <a:r>
+                <a:rPr lang="fr-FR" sz="1200" b="1" dirty="0">
+                  <a:solidFill>
+                    <a:schemeClr val="bg1"/>
+                  </a:solidFill>
+                  <a:latin typeface="Segoe UI" panose="020B0502040204020203" pitchFamily="34" charset="0"/>
+                  <a:cs typeface="Segoe UI" panose="020B0502040204020203" pitchFamily="34" charset="0"/>
+                </a:rPr>
+                <a:t>un donjon</a:t>
+              </a:r>
+            </a:p>
+          </p:txBody>
+        </p:sp>
+        <p:cxnSp>
+          <p:nvCxnSpPr>
+            <p:cNvPr id="96" name="Connecteur droit avec flèche 95">
+              <a:extLst>
+                <a:ext uri="{FF2B5EF4-FFF2-40B4-BE49-F238E27FC236}">
+                  <a16:creationId xmlns:a16="http://schemas.microsoft.com/office/drawing/2014/main" id="{BC19A915-4C84-F4C5-79D2-DA15D82A8611}"/>
+                </a:ext>
+              </a:extLst>
+            </p:cNvPr>
+            <p:cNvCxnSpPr>
+              <a:cxnSpLocks/>
+            </p:cNvCxnSpPr>
+            <p:nvPr/>
+          </p:nvCxnSpPr>
+          <p:spPr>
+            <a:xfrm>
+              <a:off x="2476114" y="3616275"/>
+              <a:ext cx="281448" cy="7387"/>
+            </a:xfrm>
+            <a:prstGeom prst="straightConnector1">
+              <a:avLst/>
+            </a:prstGeom>
+            <a:ln w="57150">
+              <a:solidFill>
+                <a:schemeClr val="bg1"/>
+              </a:solidFill>
+              <a:tailEnd type="triangle"/>
+            </a:ln>
+          </p:spPr>
+          <p:style>
+            <a:lnRef idx="2">
+              <a:schemeClr val="dk1"/>
+            </a:lnRef>
+            <a:fillRef idx="0">
+              <a:schemeClr val="dk1"/>
+            </a:fillRef>
+            <a:effectRef idx="1">
+              <a:schemeClr val="dk1"/>
+            </a:effectRef>
+            <a:fontRef idx="minor">
+              <a:schemeClr val="tx1"/>
+            </a:fontRef>
+          </p:style>
+        </p:cxnSp>
+        <p:sp>
+          <p:nvSpPr>
+            <p:cNvPr id="26" name="Hexagone 25">
+              <a:extLst>
+                <a:ext uri="{FF2B5EF4-FFF2-40B4-BE49-F238E27FC236}">
+                  <a16:creationId xmlns:a16="http://schemas.microsoft.com/office/drawing/2014/main" id="{BEE7A43E-DF8C-67CD-23BF-397C38BE7D71}"/>
+                </a:ext>
+              </a:extLst>
+            </p:cNvPr>
+            <p:cNvSpPr/>
+            <p:nvPr/>
+          </p:nvSpPr>
+          <p:spPr>
+            <a:xfrm rot="5400000">
+              <a:off x="2092696" y="4297360"/>
+              <a:ext cx="390567" cy="368869"/>
+            </a:xfrm>
+            <a:prstGeom prst="hexagon">
+              <a:avLst/>
+            </a:prstGeom>
+            <a:blipFill>
+              <a:blip r:embed="rId9">
+                <a:extLst>
+                  <a:ext uri="{BEBA8EAE-BF5A-486C-A8C5-ECC9F3942E4B}">
+                    <a14:imgProps xmlns:a14="http://schemas.microsoft.com/office/drawing/2010/main">
+                      <a14:imgLayer r:embed="rId10">
+                        <a14:imgEffect>
+                          <a14:artisticGlass/>
+                        </a14:imgEffect>
+                      </a14:imgLayer>
+                    </a14:imgProps>
+                  </a:ext>
+                </a:extLst>
+              </a:blip>
+              <a:tile tx="0" ty="0" sx="100000" sy="100000" flip="none" algn="tl"/>
+            </a:blipFill>
+            <a:ln w="12700">
+              <a:solidFill>
+                <a:schemeClr val="tx1"/>
+              </a:solidFill>
+            </a:ln>
+          </p:spPr>
+          <p:style>
+            <a:lnRef idx="2">
+              <a:schemeClr val="accent1">
+                <a:shade val="15000"/>
+              </a:schemeClr>
+            </a:lnRef>
+            <a:fillRef idx="1">
+              <a:schemeClr val="accent1"/>
+            </a:fillRef>
+            <a:effectRef idx="0">
+              <a:schemeClr val="accent1"/>
+            </a:effectRef>
+            <a:fontRef idx="minor">
+              <a:schemeClr val="lt1"/>
+            </a:fontRef>
+          </p:style>
+          <p:txBody>
+            <a:bodyPr rtlCol="0" anchor="ctr"/>
+            <a:lstStyle/>
+            <a:p>
+              <a:pPr algn="ctr"/>
+              <a:endParaRPr lang="fr-FR"/>
+            </a:p>
+          </p:txBody>
+        </p:sp>
+        <p:sp>
+          <p:nvSpPr>
+            <p:cNvPr id="27" name="Rectangle 26">
+              <a:extLst>
+                <a:ext uri="{FF2B5EF4-FFF2-40B4-BE49-F238E27FC236}">
+                  <a16:creationId xmlns:a16="http://schemas.microsoft.com/office/drawing/2014/main" id="{31B0FF7F-8BD8-7B6E-110F-87D4BEE35245}"/>
+                </a:ext>
+              </a:extLst>
+            </p:cNvPr>
+            <p:cNvSpPr/>
+            <p:nvPr/>
+          </p:nvSpPr>
+          <p:spPr>
+            <a:xfrm>
+              <a:off x="2242474" y="4462014"/>
+              <a:ext cx="91844" cy="124982"/>
+            </a:xfrm>
+            <a:prstGeom prst="rect">
+              <a:avLst/>
+            </a:prstGeom>
+            <a:solidFill>
+              <a:schemeClr val="bg1"/>
+            </a:solidFill>
+            <a:ln w="12700">
+              <a:solidFill>
+                <a:schemeClr val="tx1"/>
+              </a:solidFill>
+            </a:ln>
+          </p:spPr>
+          <p:style>
+            <a:lnRef idx="2">
+              <a:schemeClr val="accent1">
+                <a:shade val="15000"/>
+              </a:schemeClr>
+            </a:lnRef>
+            <a:fillRef idx="1">
+              <a:schemeClr val="accent1"/>
+            </a:fillRef>
+            <a:effectRef idx="0">
+              <a:schemeClr val="accent1"/>
+            </a:effectRef>
+            <a:fontRef idx="minor">
+              <a:schemeClr val="lt1"/>
+            </a:fontRef>
+          </p:style>
+          <p:txBody>
+            <a:bodyPr rtlCol="0" anchor="ctr"/>
+            <a:lstStyle/>
+            <a:p>
+              <a:pPr algn="ctr"/>
+              <a:endParaRPr lang="fr-FR"/>
+            </a:p>
+          </p:txBody>
+        </p:sp>
+        <p:sp>
+          <p:nvSpPr>
+            <p:cNvPr id="28" name="Ellipse 27">
+              <a:extLst>
+                <a:ext uri="{FF2B5EF4-FFF2-40B4-BE49-F238E27FC236}">
+                  <a16:creationId xmlns:a16="http://schemas.microsoft.com/office/drawing/2014/main" id="{3F470448-C8CC-0973-726C-7FE5B9ECB8F4}"/>
+                </a:ext>
+              </a:extLst>
+            </p:cNvPr>
+            <p:cNvSpPr/>
+            <p:nvPr/>
+          </p:nvSpPr>
+          <p:spPr>
+            <a:xfrm>
+              <a:off x="2240433" y="4368422"/>
+              <a:ext cx="91844" cy="91844"/>
+            </a:xfrm>
+            <a:prstGeom prst="ellipse">
+              <a:avLst/>
+            </a:prstGeom>
+            <a:solidFill>
+              <a:schemeClr val="bg1"/>
+            </a:solidFill>
+            <a:ln w="12700">
+              <a:solidFill>
+                <a:schemeClr val="tx1"/>
+              </a:solidFill>
+            </a:ln>
+          </p:spPr>
+          <p:style>
+            <a:lnRef idx="2">
+              <a:schemeClr val="dk1">
+                <a:shade val="15000"/>
+              </a:schemeClr>
+            </a:lnRef>
+            <a:fillRef idx="1">
+              <a:schemeClr val="dk1"/>
+            </a:fillRef>
+            <a:effectRef idx="0">
+              <a:schemeClr val="dk1"/>
+            </a:effectRef>
+            <a:fontRef idx="minor">
+              <a:schemeClr val="lt1"/>
+            </a:fontRef>
+          </p:style>
+          <p:txBody>
+            <a:bodyPr rtlCol="0" anchor="ctr"/>
+            <a:lstStyle/>
+            <a:p>
+              <a:pPr algn="ctr"/>
+              <a:endParaRPr lang="fr-FR"/>
+            </a:p>
+          </p:txBody>
+        </p:sp>
+        <p:sp>
+          <p:nvSpPr>
+            <p:cNvPr id="8" name="Rectangle 7">
+              <a:extLst>
+                <a:ext uri="{FF2B5EF4-FFF2-40B4-BE49-F238E27FC236}">
+                  <a16:creationId xmlns:a16="http://schemas.microsoft.com/office/drawing/2014/main" id="{CCF13C88-23D0-B025-E00D-0918033799D3}"/>
+                </a:ext>
+              </a:extLst>
+            </p:cNvPr>
+            <p:cNvSpPr/>
+            <p:nvPr/>
+          </p:nvSpPr>
+          <p:spPr>
+            <a:xfrm>
+              <a:off x="1537763" y="1467957"/>
+              <a:ext cx="432000" cy="432000"/>
+            </a:xfrm>
+            <a:prstGeom prst="rect">
+              <a:avLst/>
+            </a:prstGeom>
+            <a:blipFill dpi="0" rotWithShape="1">
+              <a:blip r:embed="rId3">
+                <a:alphaModFix amt="50000"/>
+                <a:extLst>
+                  <a:ext uri="{BEBA8EAE-BF5A-486C-A8C5-ECC9F3942E4B}">
+                    <a14:imgProps xmlns:a14="http://schemas.microsoft.com/office/drawing/2010/main">
+                      <a14:imgLayer r:embed="rId4">
+                        <a14:imgEffect>
+                          <a14:artisticWatercolorSponge/>
+                        </a14:imgEffect>
+                        <a14:imgEffect>
+                          <a14:brightnessContrast bright="-40000" contrast="20000"/>
+                        </a14:imgEffect>
+                      </a14:imgLayer>
+                    </a14:imgProps>
+                  </a:ext>
+                </a:extLst>
+              </a:blip>
+              <a:srcRect/>
+              <a:tile tx="0" ty="0" sx="100000" sy="100000" flip="none" algn="tl"/>
+            </a:blipFill>
+            <a:ln>
+              <a:solidFill>
+                <a:schemeClr val="tx1"/>
+              </a:solidFill>
+            </a:ln>
+          </p:spPr>
+          <p:style>
+            <a:lnRef idx="2">
+              <a:schemeClr val="accent1">
+                <a:shade val="15000"/>
+              </a:schemeClr>
+            </a:lnRef>
+            <a:fillRef idx="1">
+              <a:schemeClr val="accent1"/>
+            </a:fillRef>
+            <a:effectRef idx="0">
+              <a:schemeClr val="accent1"/>
+            </a:effectRef>
+            <a:fontRef idx="minor">
+              <a:schemeClr val="lt1"/>
+            </a:fontRef>
+          </p:style>
+          <p:txBody>
+            <a:bodyPr lIns="0" tIns="0" rIns="0" bIns="0" rtlCol="0" anchor="ctr"/>
+            <a:lstStyle/>
+            <a:p>
+              <a:pPr algn="ctr"/>
+              <a:endParaRPr lang="fr-FR" sz="1600" b="1" dirty="0">
+                <a:solidFill>
+                  <a:schemeClr val="bg1"/>
+                </a:solidFill>
+                <a:latin typeface="Segoe UI" panose="020B0502040204020203" pitchFamily="34" charset="0"/>
+                <a:cs typeface="Segoe UI" panose="020B0502040204020203" pitchFamily="34" charset="0"/>
+              </a:endParaRPr>
+            </a:p>
+          </p:txBody>
+        </p:sp>
+        <p:sp>
+          <p:nvSpPr>
+            <p:cNvPr id="15" name="Rectangle 14">
+              <a:extLst>
+                <a:ext uri="{FF2B5EF4-FFF2-40B4-BE49-F238E27FC236}">
+                  <a16:creationId xmlns:a16="http://schemas.microsoft.com/office/drawing/2014/main" id="{AF4DABCD-652C-070F-AA41-FD10465ED510}"/>
+                </a:ext>
+              </a:extLst>
+            </p:cNvPr>
+            <p:cNvSpPr/>
+            <p:nvPr/>
+          </p:nvSpPr>
+          <p:spPr>
+            <a:xfrm>
+              <a:off x="1676973" y="1561092"/>
+              <a:ext cx="153581" cy="245730"/>
+            </a:xfrm>
+            <a:prstGeom prst="rect">
+              <a:avLst/>
+            </a:prstGeom>
+            <a:solidFill>
+              <a:schemeClr val="bg1"/>
+            </a:solidFill>
+            <a:ln w="12700">
+              <a:solidFill>
+                <a:schemeClr val="tx1"/>
+              </a:solidFill>
+            </a:ln>
+          </p:spPr>
+          <p:style>
+            <a:lnRef idx="2">
+              <a:schemeClr val="accent1">
+                <a:shade val="15000"/>
+              </a:schemeClr>
+            </a:lnRef>
+            <a:fillRef idx="1">
+              <a:schemeClr val="accent1"/>
+            </a:fillRef>
+            <a:effectRef idx="0">
+              <a:schemeClr val="accent1"/>
+            </a:effectRef>
+            <a:fontRef idx="minor">
+              <a:schemeClr val="lt1"/>
+            </a:fontRef>
+          </p:style>
+          <p:txBody>
+            <a:bodyPr rtlCol="0" anchor="ctr"/>
+            <a:lstStyle/>
+            <a:p>
+              <a:pPr algn="ctr"/>
+              <a:endParaRPr lang="fr-FR"/>
+            </a:p>
+          </p:txBody>
+        </p:sp>
+        <p:sp>
+          <p:nvSpPr>
+            <p:cNvPr id="19" name="Rectangle 18">
+              <a:extLst>
+                <a:ext uri="{FF2B5EF4-FFF2-40B4-BE49-F238E27FC236}">
+                  <a16:creationId xmlns:a16="http://schemas.microsoft.com/office/drawing/2014/main" id="{DAC1549E-A4DE-ECB0-F43D-4DAE3A06BEA9}"/>
+                </a:ext>
+              </a:extLst>
+            </p:cNvPr>
+            <p:cNvSpPr/>
+            <p:nvPr/>
+          </p:nvSpPr>
+          <p:spPr>
+            <a:xfrm>
+              <a:off x="3230650" y="1465522"/>
+              <a:ext cx="432000" cy="432000"/>
+            </a:xfrm>
+            <a:prstGeom prst="rect">
+              <a:avLst/>
+            </a:prstGeom>
+            <a:blipFill dpi="0" rotWithShape="1">
+              <a:blip r:embed="rId3">
+                <a:alphaModFix amt="50000"/>
+                <a:extLst>
+                  <a:ext uri="{BEBA8EAE-BF5A-486C-A8C5-ECC9F3942E4B}">
+                    <a14:imgProps xmlns:a14="http://schemas.microsoft.com/office/drawing/2010/main">
+                      <a14:imgLayer r:embed="rId4">
+                        <a14:imgEffect>
+                          <a14:artisticWatercolorSponge/>
+                        </a14:imgEffect>
+                        <a14:imgEffect>
+                          <a14:brightnessContrast bright="-40000" contrast="20000"/>
+                        </a14:imgEffect>
+                      </a14:imgLayer>
+                    </a14:imgProps>
+                  </a:ext>
+                </a:extLst>
+              </a:blip>
+              <a:srcRect/>
+              <a:tile tx="0" ty="0" sx="100000" sy="100000" flip="none" algn="tl"/>
+            </a:blipFill>
+            <a:ln>
+              <a:solidFill>
+                <a:schemeClr val="tx1"/>
+              </a:solidFill>
+            </a:ln>
+          </p:spPr>
+          <p:style>
+            <a:lnRef idx="2">
+              <a:schemeClr val="accent1">
+                <a:shade val="15000"/>
+              </a:schemeClr>
+            </a:lnRef>
+            <a:fillRef idx="1">
+              <a:schemeClr val="accent1"/>
+            </a:fillRef>
+            <a:effectRef idx="0">
+              <a:schemeClr val="accent1"/>
+            </a:effectRef>
+            <a:fontRef idx="minor">
+              <a:schemeClr val="lt1"/>
+            </a:fontRef>
+          </p:style>
+          <p:txBody>
+            <a:bodyPr lIns="0" tIns="0" rIns="0" bIns="0" rtlCol="0" anchor="ctr"/>
+            <a:lstStyle/>
+            <a:p>
+              <a:pPr algn="ctr"/>
+              <a:endParaRPr lang="fr-FR" sz="1600" b="1" dirty="0">
+                <a:solidFill>
+                  <a:schemeClr val="bg1"/>
+                </a:solidFill>
+                <a:latin typeface="Segoe UI" panose="020B0502040204020203" pitchFamily="34" charset="0"/>
+                <a:cs typeface="Segoe UI" panose="020B0502040204020203" pitchFamily="34" charset="0"/>
+              </a:endParaRPr>
+            </a:p>
+          </p:txBody>
+        </p:sp>
+        <p:sp>
+          <p:nvSpPr>
+            <p:cNvPr id="20" name="Rectangle 19">
+              <a:extLst>
+                <a:ext uri="{FF2B5EF4-FFF2-40B4-BE49-F238E27FC236}">
+                  <a16:creationId xmlns:a16="http://schemas.microsoft.com/office/drawing/2014/main" id="{2A5F6F79-317F-D0DA-0B02-6804F02BF9F0}"/>
+                </a:ext>
+              </a:extLst>
+            </p:cNvPr>
+            <p:cNvSpPr/>
+            <p:nvPr/>
+          </p:nvSpPr>
+          <p:spPr>
+            <a:xfrm>
+              <a:off x="3369860" y="1558657"/>
+              <a:ext cx="153581" cy="245730"/>
+            </a:xfrm>
+            <a:prstGeom prst="rect">
+              <a:avLst/>
+            </a:prstGeom>
+            <a:solidFill>
+              <a:schemeClr val="bg1"/>
+            </a:solidFill>
+            <a:ln w="12700">
+              <a:solidFill>
+                <a:schemeClr val="tx1"/>
+              </a:solidFill>
+            </a:ln>
+          </p:spPr>
+          <p:style>
+            <a:lnRef idx="2">
+              <a:schemeClr val="accent1">
+                <a:shade val="15000"/>
+              </a:schemeClr>
+            </a:lnRef>
+            <a:fillRef idx="1">
+              <a:schemeClr val="accent1"/>
+            </a:fillRef>
+            <a:effectRef idx="0">
+              <a:schemeClr val="accent1"/>
+            </a:effectRef>
+            <a:fontRef idx="minor">
+              <a:schemeClr val="lt1"/>
+            </a:fontRef>
+          </p:style>
+          <p:txBody>
+            <a:bodyPr rtlCol="0" anchor="ctr"/>
+            <a:lstStyle/>
+            <a:p>
+              <a:pPr algn="ctr"/>
+              <a:endParaRPr lang="fr-FR"/>
+            </a:p>
+          </p:txBody>
+        </p:sp>
+        <p:pic>
+          <p:nvPicPr>
+            <p:cNvPr id="11" name="Graphique 10" descr="Tour médiévale avec un remplissage uni">
+              <a:extLst>
+                <a:ext uri="{FF2B5EF4-FFF2-40B4-BE49-F238E27FC236}">
+                  <a16:creationId xmlns:a16="http://schemas.microsoft.com/office/drawing/2014/main" id="{97EEF5D4-69A4-050B-551A-1FB83D514C6B}"/>
+                </a:ext>
+              </a:extLst>
+            </p:cNvPr>
+            <p:cNvPicPr>
+              <a:picLocks noChangeAspect="1"/>
+            </p:cNvPicPr>
+            <p:nvPr/>
+          </p:nvPicPr>
+          <p:blipFill>
+            <a:blip>
+              <a:extLst>
+                <a:ext uri="{96DAC541-7B7A-43D3-8B79-37D633B846F1}">
+                  <asvg:svgBlip xmlns:asvg="http://schemas.microsoft.com/office/drawing/2016/SVG/main" r:embed="rId14"/>
+                </a:ext>
+              </a:extLst>
+            </a:blip>
+            <a:srcRect l="24636" r="26487"/>
+            <a:stretch>
+              <a:fillRect/>
+            </a:stretch>
+          </p:blipFill>
+          <p:spPr>
+            <a:xfrm>
+              <a:off x="3172545" y="2080248"/>
+              <a:ext cx="375375" cy="837672"/>
+            </a:xfrm>
+            <a:prstGeom prst="rect">
+              <a:avLst/>
+            </a:prstGeom>
+          </p:spPr>
+        </p:pic>
       </p:grpSp>
     </p:spTree>
     <p:extLst>

</xml_diff>

<commit_message>
Amélioration du design des cartes ; extraction PNG ; première page d'impression
</commit_message>
<xml_diff>
--- a/pictures/Cartes-Actions-et-Evenements/Design-Cartes.pptx
+++ b/pictures/Cartes-Actions-et-Evenements/Design-Cartes.pptx
@@ -203,7 +203,7 @@
           <a:p>
             <a:fld id="{263B0988-6DB9-4E3D-B7FD-EFF3BCABE954}" type="datetimeFigureOut">
               <a:rPr lang="fr-FR" smtClean="0"/>
-              <a:t>01/04/2026</a:t>
+              <a:t>03/04/2026</a:t>
             </a:fld>
             <a:endParaRPr lang="fr-FR"/>
           </a:p>
@@ -701,7 +701,7 @@
           <a:p>
             <a:fld id="{588505E2-0C4C-443F-8F57-41958F504CA2}" type="datetimeFigureOut">
               <a:rPr lang="fr-FR" smtClean="0"/>
-              <a:t>01/04/2026</a:t>
+              <a:t>03/04/2026</a:t>
             </a:fld>
             <a:endParaRPr lang="fr-FR"/>
           </a:p>
@@ -899,7 +899,7 @@
           <a:p>
             <a:fld id="{588505E2-0C4C-443F-8F57-41958F504CA2}" type="datetimeFigureOut">
               <a:rPr lang="fr-FR" smtClean="0"/>
-              <a:t>01/04/2026</a:t>
+              <a:t>03/04/2026</a:t>
             </a:fld>
             <a:endParaRPr lang="fr-FR"/>
           </a:p>
@@ -1107,7 +1107,7 @@
           <a:p>
             <a:fld id="{588505E2-0C4C-443F-8F57-41958F504CA2}" type="datetimeFigureOut">
               <a:rPr lang="fr-FR" smtClean="0"/>
-              <a:t>01/04/2026</a:t>
+              <a:t>03/04/2026</a:t>
             </a:fld>
             <a:endParaRPr lang="fr-FR"/>
           </a:p>
@@ -1305,7 +1305,7 @@
           <a:p>
             <a:fld id="{588505E2-0C4C-443F-8F57-41958F504CA2}" type="datetimeFigureOut">
               <a:rPr lang="fr-FR" smtClean="0"/>
-              <a:t>01/04/2026</a:t>
+              <a:t>03/04/2026</a:t>
             </a:fld>
             <a:endParaRPr lang="fr-FR"/>
           </a:p>
@@ -1580,7 +1580,7 @@
           <a:p>
             <a:fld id="{588505E2-0C4C-443F-8F57-41958F504CA2}" type="datetimeFigureOut">
               <a:rPr lang="fr-FR" smtClean="0"/>
-              <a:t>01/04/2026</a:t>
+              <a:t>03/04/2026</a:t>
             </a:fld>
             <a:endParaRPr lang="fr-FR"/>
           </a:p>
@@ -1845,7 +1845,7 @@
           <a:p>
             <a:fld id="{588505E2-0C4C-443F-8F57-41958F504CA2}" type="datetimeFigureOut">
               <a:rPr lang="fr-FR" smtClean="0"/>
-              <a:t>01/04/2026</a:t>
+              <a:t>03/04/2026</a:t>
             </a:fld>
             <a:endParaRPr lang="fr-FR"/>
           </a:p>
@@ -2257,7 +2257,7 @@
           <a:p>
             <a:fld id="{588505E2-0C4C-443F-8F57-41958F504CA2}" type="datetimeFigureOut">
               <a:rPr lang="fr-FR" smtClean="0"/>
-              <a:t>01/04/2026</a:t>
+              <a:t>03/04/2026</a:t>
             </a:fld>
             <a:endParaRPr lang="fr-FR"/>
           </a:p>
@@ -2398,7 +2398,7 @@
           <a:p>
             <a:fld id="{588505E2-0C4C-443F-8F57-41958F504CA2}" type="datetimeFigureOut">
               <a:rPr lang="fr-FR" smtClean="0"/>
-              <a:t>01/04/2026</a:t>
+              <a:t>03/04/2026</a:t>
             </a:fld>
             <a:endParaRPr lang="fr-FR"/>
           </a:p>
@@ -2511,7 +2511,7 @@
           <a:p>
             <a:fld id="{588505E2-0C4C-443F-8F57-41958F504CA2}" type="datetimeFigureOut">
               <a:rPr lang="fr-FR" smtClean="0"/>
-              <a:t>01/04/2026</a:t>
+              <a:t>03/04/2026</a:t>
             </a:fld>
             <a:endParaRPr lang="fr-FR"/>
           </a:p>
@@ -2822,7 +2822,7 @@
           <a:p>
             <a:fld id="{588505E2-0C4C-443F-8F57-41958F504CA2}" type="datetimeFigureOut">
               <a:rPr lang="fr-FR" smtClean="0"/>
-              <a:t>01/04/2026</a:t>
+              <a:t>03/04/2026</a:t>
             </a:fld>
             <a:endParaRPr lang="fr-FR"/>
           </a:p>
@@ -3110,7 +3110,7 @@
           <a:p>
             <a:fld id="{588505E2-0C4C-443F-8F57-41958F504CA2}" type="datetimeFigureOut">
               <a:rPr lang="fr-FR" smtClean="0"/>
-              <a:t>01/04/2026</a:t>
+              <a:t>03/04/2026</a:t>
             </a:fld>
             <a:endParaRPr lang="fr-FR"/>
           </a:p>
@@ -3351,7 +3351,7 @@
           <a:p>
             <a:fld id="{588505E2-0C4C-443F-8F57-41958F504CA2}" type="datetimeFigureOut">
               <a:rPr lang="fr-FR" smtClean="0"/>
-              <a:t>01/04/2026</a:t>
+              <a:t>03/04/2026</a:t>
             </a:fld>
             <a:endParaRPr lang="fr-FR"/>
           </a:p>
@@ -4364,10 +4364,10 @@
       </p:grpSpPr>
       <p:grpSp>
         <p:nvGrpSpPr>
-          <p:cNvPr id="15" name="Groupe 14">
+          <p:cNvPr id="12" name="Groupe 11">
             <a:extLst>
               <a:ext uri="{FF2B5EF4-FFF2-40B4-BE49-F238E27FC236}">
-                <a16:creationId xmlns:a16="http://schemas.microsoft.com/office/drawing/2014/main" id="{2985DEEF-0E33-B004-2AC4-F0D7BC543A4B}"/>
+                <a16:creationId xmlns:a16="http://schemas.microsoft.com/office/drawing/2014/main" id="{8750ED07-E860-B188-9520-BF4EC262CCE3}"/>
               </a:ext>
             </a:extLst>
           </p:cNvPr>
@@ -10297,10 +10297,10 @@
       </p:grpSpPr>
       <p:grpSp>
         <p:nvGrpSpPr>
-          <p:cNvPr id="13" name="Groupe 12">
+          <p:cNvPr id="25" name="Groupe 24">
             <a:extLst>
               <a:ext uri="{FF2B5EF4-FFF2-40B4-BE49-F238E27FC236}">
-                <a16:creationId xmlns:a16="http://schemas.microsoft.com/office/drawing/2014/main" id="{2C9D8A01-883F-0032-5DA6-6552F6560293}"/>
+                <a16:creationId xmlns:a16="http://schemas.microsoft.com/office/drawing/2014/main" id="{26CB4421-58FE-89FB-402F-73CEAFF27C61}"/>
               </a:ext>
             </a:extLst>
           </p:cNvPr>

</xml_diff>

<commit_message>
Mise à jour des cartes Malédiction Noire sur le terme cimetière
</commit_message>
<xml_diff>
--- a/pictures/Cartes-Actions-et-Evenements/Design-Cartes.pptx
+++ b/pictures/Cartes-Actions-et-Evenements/Design-Cartes.pptx
@@ -203,7 +203,7 @@
           <a:p>
             <a:fld id="{263B0988-6DB9-4E3D-B7FD-EFF3BCABE954}" type="datetimeFigureOut">
               <a:rPr lang="fr-FR" smtClean="0"/>
-              <a:t>03/04/2026</a:t>
+              <a:t>12/04/2026</a:t>
             </a:fld>
             <a:endParaRPr lang="fr-FR"/>
           </a:p>
@@ -701,7 +701,7 @@
           <a:p>
             <a:fld id="{588505E2-0C4C-443F-8F57-41958F504CA2}" type="datetimeFigureOut">
               <a:rPr lang="fr-FR" smtClean="0"/>
-              <a:t>03/04/2026</a:t>
+              <a:t>12/04/2026</a:t>
             </a:fld>
             <a:endParaRPr lang="fr-FR"/>
           </a:p>
@@ -899,7 +899,7 @@
           <a:p>
             <a:fld id="{588505E2-0C4C-443F-8F57-41958F504CA2}" type="datetimeFigureOut">
               <a:rPr lang="fr-FR" smtClean="0"/>
-              <a:t>03/04/2026</a:t>
+              <a:t>12/04/2026</a:t>
             </a:fld>
             <a:endParaRPr lang="fr-FR"/>
           </a:p>
@@ -1107,7 +1107,7 @@
           <a:p>
             <a:fld id="{588505E2-0C4C-443F-8F57-41958F504CA2}" type="datetimeFigureOut">
               <a:rPr lang="fr-FR" smtClean="0"/>
-              <a:t>03/04/2026</a:t>
+              <a:t>12/04/2026</a:t>
             </a:fld>
             <a:endParaRPr lang="fr-FR"/>
           </a:p>
@@ -1305,7 +1305,7 @@
           <a:p>
             <a:fld id="{588505E2-0C4C-443F-8F57-41958F504CA2}" type="datetimeFigureOut">
               <a:rPr lang="fr-FR" smtClean="0"/>
-              <a:t>03/04/2026</a:t>
+              <a:t>12/04/2026</a:t>
             </a:fld>
             <a:endParaRPr lang="fr-FR"/>
           </a:p>
@@ -1580,7 +1580,7 @@
           <a:p>
             <a:fld id="{588505E2-0C4C-443F-8F57-41958F504CA2}" type="datetimeFigureOut">
               <a:rPr lang="fr-FR" smtClean="0"/>
-              <a:t>03/04/2026</a:t>
+              <a:t>12/04/2026</a:t>
             </a:fld>
             <a:endParaRPr lang="fr-FR"/>
           </a:p>
@@ -1845,7 +1845,7 @@
           <a:p>
             <a:fld id="{588505E2-0C4C-443F-8F57-41958F504CA2}" type="datetimeFigureOut">
               <a:rPr lang="fr-FR" smtClean="0"/>
-              <a:t>03/04/2026</a:t>
+              <a:t>12/04/2026</a:t>
             </a:fld>
             <a:endParaRPr lang="fr-FR"/>
           </a:p>
@@ -2257,7 +2257,7 @@
           <a:p>
             <a:fld id="{588505E2-0C4C-443F-8F57-41958F504CA2}" type="datetimeFigureOut">
               <a:rPr lang="fr-FR" smtClean="0"/>
-              <a:t>03/04/2026</a:t>
+              <a:t>12/04/2026</a:t>
             </a:fld>
             <a:endParaRPr lang="fr-FR"/>
           </a:p>
@@ -2398,7 +2398,7 @@
           <a:p>
             <a:fld id="{588505E2-0C4C-443F-8F57-41958F504CA2}" type="datetimeFigureOut">
               <a:rPr lang="fr-FR" smtClean="0"/>
-              <a:t>03/04/2026</a:t>
+              <a:t>12/04/2026</a:t>
             </a:fld>
             <a:endParaRPr lang="fr-FR"/>
           </a:p>
@@ -2511,7 +2511,7 @@
           <a:p>
             <a:fld id="{588505E2-0C4C-443F-8F57-41958F504CA2}" type="datetimeFigureOut">
               <a:rPr lang="fr-FR" smtClean="0"/>
-              <a:t>03/04/2026</a:t>
+              <a:t>12/04/2026</a:t>
             </a:fld>
             <a:endParaRPr lang="fr-FR"/>
           </a:p>
@@ -2822,7 +2822,7 @@
           <a:p>
             <a:fld id="{588505E2-0C4C-443F-8F57-41958F504CA2}" type="datetimeFigureOut">
               <a:rPr lang="fr-FR" smtClean="0"/>
-              <a:t>03/04/2026</a:t>
+              <a:t>12/04/2026</a:t>
             </a:fld>
             <a:endParaRPr lang="fr-FR"/>
           </a:p>
@@ -3110,7 +3110,7 @@
           <a:p>
             <a:fld id="{588505E2-0C4C-443F-8F57-41958F504CA2}" type="datetimeFigureOut">
               <a:rPr lang="fr-FR" smtClean="0"/>
-              <a:t>03/04/2026</a:t>
+              <a:t>12/04/2026</a:t>
             </a:fld>
             <a:endParaRPr lang="fr-FR"/>
           </a:p>
@@ -3351,7 +3351,7 @@
           <a:p>
             <a:fld id="{588505E2-0C4C-443F-8F57-41958F504CA2}" type="datetimeFigureOut">
               <a:rPr lang="fr-FR" smtClean="0"/>
-              <a:t>03/04/2026</a:t>
+              <a:t>12/04/2026</a:t>
             </a:fld>
             <a:endParaRPr lang="fr-FR"/>
           </a:p>
@@ -18151,7 +18151,7 @@
                   <a:latin typeface="Segoe UI" panose="020B0502040204020203" pitchFamily="34" charset="0"/>
                   <a:cs typeface="Segoe UI" panose="020B0502040204020203" pitchFamily="34" charset="0"/>
                 </a:rPr>
-                <a:t>A ces positions, envoyer en </a:t>
+                <a:t>A ces positions, envoyer au </a:t>
               </a:r>
               <a:r>
                 <a:rPr lang="fr-FR" sz="1200" b="1" dirty="0">
@@ -18161,7 +18161,7 @@
                   <a:latin typeface="Segoe UI" panose="020B0502040204020203" pitchFamily="34" charset="0"/>
                   <a:cs typeface="Segoe UI" panose="020B0502040204020203" pitchFamily="34" charset="0"/>
                 </a:rPr>
-                <a:t>défausse</a:t>
+                <a:t>cimetière</a:t>
               </a:r>
               <a:r>
                 <a:rPr lang="fr-FR" sz="1200" b="1" dirty="0">

</xml_diff>

<commit_message>
Essai d'une carte déplacer troupes mixant disperser et concentrer
</commit_message>
<xml_diff>
--- a/pictures/Cartes-Actions-et-Evenements/Design-Cartes.pptx
+++ b/pictures/Cartes-Actions-et-Evenements/Design-Cartes.pptx
@@ -10309,7 +10309,7 @@
         </p:nvGrpSpPr>
         <p:grpSpPr>
           <a:xfrm>
-            <a:off x="4362394" y="1431551"/>
+            <a:off x="8284080" y="1428694"/>
             <a:ext cx="2124000" cy="3312600"/>
             <a:chOff x="4362394" y="1431551"/>
             <a:chExt cx="2124000" cy="3312600"/>
@@ -11711,10 +11711,10 @@
       </p:grpSp>
       <p:grpSp>
         <p:nvGrpSpPr>
-          <p:cNvPr id="14" name="Groupe 13">
+          <p:cNvPr id="114" name="Groupe 113">
             <a:extLst>
               <a:ext uri="{FF2B5EF4-FFF2-40B4-BE49-F238E27FC236}">
-                <a16:creationId xmlns:a16="http://schemas.microsoft.com/office/drawing/2014/main" id="{BC67B85F-CA29-AB7E-BAE1-948AC1198E38}"/>
+                <a16:creationId xmlns:a16="http://schemas.microsoft.com/office/drawing/2014/main" id="{00830897-E65E-2748-86FD-61EECF9763D9}"/>
               </a:ext>
             </a:extLst>
           </p:cNvPr>
@@ -11723,9 +11723,9 @@
         </p:nvGrpSpPr>
         <p:grpSpPr>
           <a:xfrm>
-            <a:off x="7235162" y="1431508"/>
+            <a:off x="5725584" y="1428972"/>
             <a:ext cx="2124000" cy="3312643"/>
-            <a:chOff x="7235162" y="1431508"/>
+            <a:chOff x="5724348" y="1377054"/>
             <a:chExt cx="2124000" cy="3312643"/>
           </a:xfrm>
         </p:grpSpPr>
@@ -11743,7 +11743,7 @@
           </p:nvSpPr>
           <p:spPr>
             <a:xfrm>
-              <a:off x="7235162" y="1432151"/>
+              <a:off x="5724348" y="1377697"/>
               <a:ext cx="2124000" cy="3312000"/>
             </a:xfrm>
             <a:prstGeom prst="rect">
@@ -11796,7 +11796,7 @@
           </p:nvSpPr>
           <p:spPr>
             <a:xfrm>
-              <a:off x="7667162" y="1431508"/>
+              <a:off x="6156348" y="1377054"/>
               <a:ext cx="1260000" cy="432000"/>
             </a:xfrm>
             <a:prstGeom prst="rect">
@@ -11877,7 +11877,7 @@
           </p:nvSpPr>
           <p:spPr>
             <a:xfrm>
-              <a:off x="7327463" y="4210719"/>
+              <a:off x="5816649" y="4156265"/>
               <a:ext cx="360000" cy="360000"/>
             </a:xfrm>
             <a:prstGeom prst="donut">
@@ -11939,7 +11939,7 @@
           </p:nvSpPr>
           <p:spPr>
             <a:xfrm rot="5400000">
-              <a:off x="8677011" y="3448348"/>
+              <a:off x="7166197" y="3393894"/>
               <a:ext cx="396000" cy="360000"/>
             </a:xfrm>
             <a:prstGeom prst="hexagon">
@@ -12006,7 +12006,7 @@
           </p:nvSpPr>
           <p:spPr>
             <a:xfrm rot="5400000">
-              <a:off x="8267736" y="3448348"/>
+              <a:off x="6756922" y="3393894"/>
               <a:ext cx="396000" cy="360000"/>
             </a:xfrm>
             <a:prstGeom prst="hexagon">
@@ -12073,7 +12073,7 @@
           </p:nvSpPr>
           <p:spPr>
             <a:xfrm rot="5400000">
-              <a:off x="7858461" y="3458281"/>
+              <a:off x="6347647" y="3403827"/>
               <a:ext cx="396000" cy="360000"/>
             </a:xfrm>
             <a:prstGeom prst="hexagon">
@@ -12140,7 +12140,7 @@
           </p:nvSpPr>
           <p:spPr>
             <a:xfrm rot="5400000">
-              <a:off x="7444958" y="3458281"/>
+              <a:off x="5934144" y="3403827"/>
               <a:ext cx="396000" cy="360000"/>
             </a:xfrm>
             <a:prstGeom prst="hexagon">
@@ -12196,7 +12196,7 @@
           </p:nvCxnSpPr>
           <p:spPr>
             <a:xfrm flipH="1">
-              <a:off x="7562286" y="3632322"/>
+              <a:off x="6051472" y="3577868"/>
               <a:ext cx="1303580" cy="0"/>
             </a:xfrm>
             <a:prstGeom prst="straightConnector1">
@@ -12235,7 +12235,7 @@
           </p:nvSpPr>
           <p:spPr>
             <a:xfrm>
-              <a:off x="7966461" y="3548281"/>
+              <a:off x="6455647" y="3493827"/>
               <a:ext cx="180000" cy="180000"/>
             </a:xfrm>
             <a:prstGeom prst="ellipse">
@@ -12290,7 +12290,7 @@
           </p:nvSpPr>
           <p:spPr>
             <a:xfrm>
-              <a:off x="8375347" y="3548281"/>
+              <a:off x="6864533" y="3493827"/>
               <a:ext cx="180000" cy="180000"/>
             </a:xfrm>
             <a:prstGeom prst="ellipse">
@@ -12345,7 +12345,7 @@
           </p:nvSpPr>
           <p:spPr>
             <a:xfrm>
-              <a:off x="8784828" y="3538348"/>
+              <a:off x="7274014" y="3483894"/>
               <a:ext cx="180000" cy="180000"/>
             </a:xfrm>
             <a:prstGeom prst="ellipse">
@@ -12400,7 +12400,7 @@
           </p:nvSpPr>
           <p:spPr>
             <a:xfrm>
-              <a:off x="7380513" y="1934249"/>
+              <a:off x="5869699" y="1879795"/>
               <a:ext cx="1846986" cy="830997"/>
             </a:xfrm>
             <a:prstGeom prst="rect">
@@ -12441,7 +12441,7 @@
           </p:nvSpPr>
           <p:spPr>
             <a:xfrm>
-              <a:off x="7380513" y="2802244"/>
+              <a:off x="5869699" y="2747790"/>
               <a:ext cx="1260513" cy="461665"/>
             </a:xfrm>
             <a:prstGeom prst="rect">
@@ -12482,7 +12482,7 @@
           </p:nvGrpSpPr>
           <p:grpSpPr>
             <a:xfrm>
-              <a:off x="7775361" y="4195110"/>
+              <a:off x="6264547" y="4140656"/>
               <a:ext cx="368869" cy="390567"/>
               <a:chOff x="7775361" y="4195110"/>
               <a:chExt cx="368869" cy="390567"/>
@@ -12678,7 +12678,7 @@
           </p:nvGrpSpPr>
           <p:grpSpPr>
             <a:xfrm>
-              <a:off x="8227792" y="4197381"/>
+              <a:off x="6716978" y="4142927"/>
               <a:ext cx="373999" cy="396000"/>
               <a:chOff x="8227792" y="4197381"/>
               <a:chExt cx="373999" cy="396000"/>
@@ -12820,7 +12820,7 @@
           </p:nvGrpSpPr>
           <p:grpSpPr>
             <a:xfrm>
-              <a:off x="8680737" y="4200356"/>
+              <a:off x="7169923" y="4145902"/>
               <a:ext cx="374000" cy="396000"/>
               <a:chOff x="8680737" y="4200356"/>
               <a:chExt cx="374000" cy="396000"/>
@@ -12999,7 +12999,7 @@
           </p:nvSpPr>
           <p:spPr>
             <a:xfrm>
-              <a:off x="7235162" y="1432742"/>
+              <a:off x="5724348" y="1378288"/>
               <a:ext cx="432000" cy="432000"/>
             </a:xfrm>
             <a:prstGeom prst="rect">
@@ -13080,7 +13080,7 @@
           </p:nvSpPr>
           <p:spPr>
             <a:xfrm>
-              <a:off x="8927162" y="1431508"/>
+              <a:off x="7416348" y="1377054"/>
               <a:ext cx="432000" cy="432000"/>
             </a:xfrm>
             <a:prstGeom prst="rect">
@@ -13184,7 +13184,7 @@
           </p:blipFill>
           <p:spPr>
             <a:xfrm>
-              <a:off x="8689028" y="2573361"/>
+              <a:off x="7178214" y="2518907"/>
               <a:ext cx="540000" cy="540000"/>
             </a:xfrm>
             <a:prstGeom prst="rect">
@@ -13207,7 +13207,7 @@
         </p:nvGrpSpPr>
         <p:grpSpPr>
           <a:xfrm>
-            <a:off x="1537763" y="1464756"/>
+            <a:off x="583316" y="1428694"/>
             <a:ext cx="2124887" cy="3312766"/>
             <a:chOff x="1537763" y="1464756"/>
             <a:chExt cx="2124887" cy="3312766"/>
@@ -14317,6 +14317,2031 @@
             </a:prstGeom>
           </p:spPr>
         </p:pic>
+      </p:grpSp>
+      <p:grpSp>
+        <p:nvGrpSpPr>
+          <p:cNvPr id="113" name="Groupe 112">
+            <a:extLst>
+              <a:ext uri="{FF2B5EF4-FFF2-40B4-BE49-F238E27FC236}">
+                <a16:creationId xmlns:a16="http://schemas.microsoft.com/office/drawing/2014/main" id="{76305CE6-BD74-EED8-6B91-ECFB588D84AE}"/>
+              </a:ext>
+            </a:extLst>
+          </p:cNvPr>
+          <p:cNvGrpSpPr/>
+          <p:nvPr/>
+        </p:nvGrpSpPr>
+        <p:grpSpPr>
+          <a:xfrm>
+            <a:off x="3168983" y="1428994"/>
+            <a:ext cx="2124000" cy="3312600"/>
+            <a:chOff x="3152197" y="1377054"/>
+            <a:chExt cx="2124000" cy="3312600"/>
+          </a:xfrm>
+        </p:grpSpPr>
+        <p:sp>
+          <p:nvSpPr>
+            <p:cNvPr id="13" name="Rectangle 12">
+              <a:extLst>
+                <a:ext uri="{FF2B5EF4-FFF2-40B4-BE49-F238E27FC236}">
+                  <a16:creationId xmlns:a16="http://schemas.microsoft.com/office/drawing/2014/main" id="{52A96650-6338-C965-A822-5029031CC6DC}"/>
+                </a:ext>
+              </a:extLst>
+            </p:cNvPr>
+            <p:cNvSpPr/>
+            <p:nvPr/>
+          </p:nvSpPr>
+          <p:spPr>
+            <a:xfrm>
+              <a:off x="3152197" y="1377654"/>
+              <a:ext cx="2124000" cy="3312000"/>
+            </a:xfrm>
+            <a:prstGeom prst="rect">
+              <a:avLst/>
+            </a:prstGeom>
+            <a:blipFill dpi="0" rotWithShape="1">
+              <a:blip r:embed="rId2">
+                <a:alphaModFix amt="75000"/>
+              </a:blip>
+              <a:srcRect/>
+              <a:tile tx="0" ty="0" sx="100000" sy="100000" flip="none" algn="tl"/>
+            </a:blipFill>
+          </p:spPr>
+          <p:style>
+            <a:lnRef idx="2">
+              <a:schemeClr val="accent1">
+                <a:shade val="15000"/>
+              </a:schemeClr>
+            </a:lnRef>
+            <a:fillRef idx="1">
+              <a:schemeClr val="accent1"/>
+            </a:fillRef>
+            <a:effectRef idx="0">
+              <a:schemeClr val="accent1"/>
+            </a:effectRef>
+            <a:fontRef idx="minor">
+              <a:schemeClr val="lt1"/>
+            </a:fontRef>
+          </p:style>
+          <p:txBody>
+            <a:bodyPr rtlCol="0" anchor="ctr"/>
+            <a:lstStyle/>
+            <a:p>
+              <a:pPr algn="ctr"/>
+              <a:endParaRPr lang="fr-FR"/>
+            </a:p>
+          </p:txBody>
+        </p:sp>
+        <p:sp>
+          <p:nvSpPr>
+            <p:cNvPr id="16" name="Rectangle 15">
+              <a:extLst>
+                <a:ext uri="{FF2B5EF4-FFF2-40B4-BE49-F238E27FC236}">
+                  <a16:creationId xmlns:a16="http://schemas.microsoft.com/office/drawing/2014/main" id="{506753A5-C82D-B253-9945-D200D8D25323}"/>
+                </a:ext>
+              </a:extLst>
+            </p:cNvPr>
+            <p:cNvSpPr/>
+            <p:nvPr/>
+          </p:nvSpPr>
+          <p:spPr>
+            <a:xfrm>
+              <a:off x="3584197" y="1377272"/>
+              <a:ext cx="1260000" cy="432000"/>
+            </a:xfrm>
+            <a:prstGeom prst="rect">
+              <a:avLst/>
+            </a:prstGeom>
+            <a:blipFill dpi="0" rotWithShape="1">
+              <a:blip r:embed="rId3">
+                <a:alphaModFix amt="50000"/>
+                <a:extLst>
+                  <a:ext uri="{BEBA8EAE-BF5A-486C-A8C5-ECC9F3942E4B}">
+                    <a14:imgProps xmlns:a14="http://schemas.microsoft.com/office/drawing/2010/main">
+                      <a14:imgLayer r:embed="rId4">
+                        <a14:imgEffect>
+                          <a14:artisticWatercolorSponge/>
+                        </a14:imgEffect>
+                        <a14:imgEffect>
+                          <a14:brightnessContrast bright="-40000" contrast="20000"/>
+                        </a14:imgEffect>
+                      </a14:imgLayer>
+                    </a14:imgProps>
+                  </a:ext>
+                </a:extLst>
+              </a:blip>
+              <a:srcRect/>
+              <a:tile tx="0" ty="0" sx="100000" sy="100000" flip="none" algn="tl"/>
+            </a:blipFill>
+            <a:ln>
+              <a:solidFill>
+                <a:schemeClr val="tx1"/>
+              </a:solidFill>
+            </a:ln>
+          </p:spPr>
+          <p:style>
+            <a:lnRef idx="2">
+              <a:schemeClr val="accent1">
+                <a:shade val="15000"/>
+              </a:schemeClr>
+            </a:lnRef>
+            <a:fillRef idx="1">
+              <a:schemeClr val="accent1"/>
+            </a:fillRef>
+            <a:effectRef idx="0">
+              <a:schemeClr val="accent1"/>
+            </a:effectRef>
+            <a:fontRef idx="minor">
+              <a:schemeClr val="lt1"/>
+            </a:fontRef>
+          </p:style>
+          <p:txBody>
+            <a:bodyPr rtlCol="0" anchor="ctr"/>
+            <a:lstStyle/>
+            <a:p>
+              <a:pPr algn="ctr"/>
+              <a:r>
+                <a:rPr lang="fr-FR" sz="1200" b="1" dirty="0">
+                  <a:solidFill>
+                    <a:schemeClr val="bg1"/>
+                  </a:solidFill>
+                  <a:latin typeface="Segoe UI" panose="020B0502040204020203" pitchFamily="34" charset="0"/>
+                  <a:cs typeface="Segoe UI" panose="020B0502040204020203" pitchFamily="34" charset="0"/>
+                </a:rPr>
+                <a:t>Déplacer Troupes</a:t>
+              </a:r>
+            </a:p>
+          </p:txBody>
+        </p:sp>
+        <p:sp>
+          <p:nvSpPr>
+            <p:cNvPr id="17" name="ZoneTexte 16">
+              <a:extLst>
+                <a:ext uri="{FF2B5EF4-FFF2-40B4-BE49-F238E27FC236}">
+                  <a16:creationId xmlns:a16="http://schemas.microsoft.com/office/drawing/2014/main" id="{C6637799-A5F0-47C8-A229-54D6E170AF4C}"/>
+                </a:ext>
+              </a:extLst>
+            </p:cNvPr>
+            <p:cNvSpPr txBox="1"/>
+            <p:nvPr/>
+          </p:nvSpPr>
+          <p:spPr>
+            <a:xfrm>
+              <a:off x="3227224" y="1860393"/>
+              <a:ext cx="1956665" cy="830997"/>
+            </a:xfrm>
+            <a:prstGeom prst="rect">
+              <a:avLst/>
+            </a:prstGeom>
+            <a:noFill/>
+          </p:spPr>
+          <p:txBody>
+            <a:bodyPr wrap="square" rtlCol="0">
+              <a:spAutoFit/>
+            </a:bodyPr>
+            <a:lstStyle/>
+            <a:p>
+              <a:r>
+                <a:rPr lang="fr-FR" sz="1200" b="1" dirty="0">
+                  <a:solidFill>
+                    <a:schemeClr val="accent6">
+                      <a:lumMod val="40000"/>
+                      <a:lumOff val="60000"/>
+                    </a:schemeClr>
+                  </a:solidFill>
+                  <a:latin typeface="Segoe UI" panose="020B0502040204020203" pitchFamily="34" charset="0"/>
+                  <a:cs typeface="Segoe UI" panose="020B0502040204020203" pitchFamily="34" charset="0"/>
+                </a:rPr>
+                <a:t>Disperser</a:t>
+              </a:r>
+              <a:r>
+                <a:rPr lang="fr-FR" sz="1200" b="1" dirty="0">
+                  <a:solidFill>
+                    <a:schemeClr val="bg1"/>
+                  </a:solidFill>
+                  <a:latin typeface="Segoe UI" panose="020B0502040204020203" pitchFamily="34" charset="0"/>
+                  <a:cs typeface="Segoe UI" panose="020B0502040204020203" pitchFamily="34" charset="0"/>
+                </a:rPr>
+                <a:t>/</a:t>
+              </a:r>
+              <a:r>
+                <a:rPr lang="fr-FR" sz="1200" b="1" dirty="0">
+                  <a:solidFill>
+                    <a:srgbClr val="FFC000"/>
+                  </a:solidFill>
+                  <a:latin typeface="Segoe UI" panose="020B0502040204020203" pitchFamily="34" charset="0"/>
+                  <a:cs typeface="Segoe UI" panose="020B0502040204020203" pitchFamily="34" charset="0"/>
+                </a:rPr>
+                <a:t>Concentrer</a:t>
+              </a:r>
+              <a:r>
+                <a:rPr lang="fr-FR" sz="1200" b="1" dirty="0">
+                  <a:solidFill>
+                    <a:schemeClr val="bg1"/>
+                  </a:solidFill>
+                  <a:latin typeface="Segoe UI" panose="020B0502040204020203" pitchFamily="34" charset="0"/>
+                  <a:cs typeface="Segoe UI" panose="020B0502040204020203" pitchFamily="34" charset="0"/>
+                </a:rPr>
+                <a:t> en ligne droite des troupes </a:t>
+              </a:r>
+              <a:r>
+                <a:rPr lang="fr-FR" sz="1200" b="1" dirty="0">
+                  <a:solidFill>
+                    <a:schemeClr val="accent6">
+                      <a:lumMod val="40000"/>
+                      <a:lumOff val="60000"/>
+                    </a:schemeClr>
+                  </a:solidFill>
+                  <a:latin typeface="Segoe UI" panose="020B0502040204020203" pitchFamily="34" charset="0"/>
+                  <a:cs typeface="Segoe UI" panose="020B0502040204020203" pitchFamily="34" charset="0"/>
+                </a:rPr>
+                <a:t>depuis</a:t>
+              </a:r>
+              <a:r>
+                <a:rPr lang="fr-FR" sz="1200" b="1" dirty="0">
+                  <a:solidFill>
+                    <a:schemeClr val="bg1"/>
+                  </a:solidFill>
+                  <a:latin typeface="Segoe UI" panose="020B0502040204020203" pitchFamily="34" charset="0"/>
+                  <a:cs typeface="Segoe UI" panose="020B0502040204020203" pitchFamily="34" charset="0"/>
+                </a:rPr>
+                <a:t>/</a:t>
+              </a:r>
+              <a:r>
+                <a:rPr lang="fr-FR" sz="1200" b="1" dirty="0">
+                  <a:solidFill>
+                    <a:srgbClr val="FFC000"/>
+                  </a:solidFill>
+                  <a:latin typeface="Segoe UI" panose="020B0502040204020203" pitchFamily="34" charset="0"/>
+                  <a:cs typeface="Segoe UI" panose="020B0502040204020203" pitchFamily="34" charset="0"/>
+                </a:rPr>
+                <a:t>vers</a:t>
+              </a:r>
+              <a:r>
+                <a:rPr lang="fr-FR" sz="1200" b="1" dirty="0">
+                  <a:solidFill>
+                    <a:schemeClr val="bg1"/>
+                  </a:solidFill>
+                  <a:latin typeface="Segoe UI" panose="020B0502040204020203" pitchFamily="34" charset="0"/>
+                  <a:cs typeface="Segoe UI" panose="020B0502040204020203" pitchFamily="34" charset="0"/>
+                </a:rPr>
+                <a:t> la tuile de commandement</a:t>
+              </a:r>
+            </a:p>
+          </p:txBody>
+        </p:sp>
+        <p:sp>
+          <p:nvSpPr>
+            <p:cNvPr id="18" name="Cercle : creux 17">
+              <a:extLst>
+                <a:ext uri="{FF2B5EF4-FFF2-40B4-BE49-F238E27FC236}">
+                  <a16:creationId xmlns:a16="http://schemas.microsoft.com/office/drawing/2014/main" id="{85795305-0810-41DE-4F69-A2023AC272EE}"/>
+                </a:ext>
+              </a:extLst>
+            </p:cNvPr>
+            <p:cNvSpPr/>
+            <p:nvPr/>
+          </p:nvSpPr>
+          <p:spPr>
+            <a:xfrm>
+              <a:off x="3214707" y="4240638"/>
+              <a:ext cx="360000" cy="360000"/>
+            </a:xfrm>
+            <a:prstGeom prst="donut">
+              <a:avLst>
+                <a:gd name="adj" fmla="val 15271"/>
+              </a:avLst>
+            </a:prstGeom>
+            <a:blipFill>
+              <a:blip r:embed="rId5"/>
+              <a:tile tx="0" ty="0" sx="100000" sy="100000" flip="none" algn="tl"/>
+            </a:blipFill>
+            <a:ln w="12700"/>
+          </p:spPr>
+          <p:style>
+            <a:lnRef idx="2">
+              <a:schemeClr val="dk1">
+                <a:shade val="15000"/>
+              </a:schemeClr>
+            </a:lnRef>
+            <a:fillRef idx="1">
+              <a:schemeClr val="dk1"/>
+            </a:fillRef>
+            <a:effectRef idx="0">
+              <a:schemeClr val="dk1"/>
+            </a:effectRef>
+            <a:fontRef idx="minor">
+              <a:schemeClr val="lt1"/>
+            </a:fontRef>
+          </p:style>
+          <p:txBody>
+            <a:bodyPr rtlCol="0" anchor="ctr"/>
+            <a:lstStyle/>
+            <a:p>
+              <a:pPr algn="ctr"/>
+              <a:r>
+                <a:rPr lang="fr-FR" b="1" dirty="0">
+                  <a:solidFill>
+                    <a:schemeClr val="bg1"/>
+                  </a:solidFill>
+                  <a:latin typeface="Segoe UI" panose="020B0502040204020203" pitchFamily="34" charset="0"/>
+                  <a:cs typeface="Segoe UI" panose="020B0502040204020203" pitchFamily="34" charset="0"/>
+                </a:rPr>
+                <a:t>1</a:t>
+              </a:r>
+            </a:p>
+          </p:txBody>
+        </p:sp>
+        <p:grpSp>
+          <p:nvGrpSpPr>
+            <p:cNvPr id="110" name="Groupe 109">
+              <a:extLst>
+                <a:ext uri="{FF2B5EF4-FFF2-40B4-BE49-F238E27FC236}">
+                  <a16:creationId xmlns:a16="http://schemas.microsoft.com/office/drawing/2014/main" id="{1689C847-B266-7325-47F2-24864D823EE2}"/>
+                </a:ext>
+              </a:extLst>
+            </p:cNvPr>
+            <p:cNvGrpSpPr/>
+            <p:nvPr/>
+          </p:nvGrpSpPr>
+          <p:grpSpPr>
+            <a:xfrm>
+              <a:off x="3349730" y="3222293"/>
+              <a:ext cx="1592053" cy="405933"/>
+              <a:chOff x="3369594" y="3325288"/>
+              <a:chExt cx="1592053" cy="405933"/>
+            </a:xfrm>
+          </p:grpSpPr>
+          <p:sp>
+            <p:nvSpPr>
+              <p:cNvPr id="21" name="Hexagone 20">
+                <a:extLst>
+                  <a:ext uri="{FF2B5EF4-FFF2-40B4-BE49-F238E27FC236}">
+                    <a16:creationId xmlns:a16="http://schemas.microsoft.com/office/drawing/2014/main" id="{E623FA65-9F3F-6561-380C-FA92A62B9B76}"/>
+                  </a:ext>
+                </a:extLst>
+              </p:cNvPr>
+              <p:cNvSpPr/>
+              <p:nvPr/>
+            </p:nvSpPr>
+            <p:spPr>
+              <a:xfrm rot="5400000">
+                <a:off x="4583647" y="3343288"/>
+                <a:ext cx="396000" cy="360000"/>
+              </a:xfrm>
+              <a:prstGeom prst="hexagon">
+                <a:avLst/>
+              </a:prstGeom>
+              <a:blipFill>
+                <a:blip r:embed="rId6">
+                  <a:extLst>
+                    <a:ext uri="{BEBA8EAE-BF5A-486C-A8C5-ECC9F3942E4B}">
+                      <a14:imgProps xmlns:a14="http://schemas.microsoft.com/office/drawing/2010/main">
+                        <a14:imgLayer r:embed="rId7">
+                          <a14:imgEffect>
+                            <a14:brightnessContrast bright="-20000" contrast="-40000"/>
+                          </a14:imgEffect>
+                        </a14:imgLayer>
+                      </a14:imgProps>
+                    </a:ext>
+                  </a:extLst>
+                </a:blip>
+                <a:tile tx="0" ty="0" sx="100000" sy="100000" flip="none" algn="tl"/>
+              </a:blipFill>
+              <a:ln w="12700">
+                <a:solidFill>
+                  <a:schemeClr val="tx1"/>
+                </a:solidFill>
+              </a:ln>
+            </p:spPr>
+            <p:style>
+              <a:lnRef idx="2">
+                <a:schemeClr val="accent1">
+                  <a:shade val="15000"/>
+                </a:schemeClr>
+              </a:lnRef>
+              <a:fillRef idx="1">
+                <a:schemeClr val="accent1"/>
+              </a:fillRef>
+              <a:effectRef idx="0">
+                <a:schemeClr val="accent1"/>
+              </a:effectRef>
+              <a:fontRef idx="minor">
+                <a:schemeClr val="lt1"/>
+              </a:fontRef>
+            </p:style>
+            <p:txBody>
+              <a:bodyPr rtlCol="0" anchor="ctr"/>
+              <a:lstStyle/>
+              <a:p>
+                <a:pPr algn="ctr"/>
+                <a:endParaRPr lang="fr-FR"/>
+              </a:p>
+            </p:txBody>
+          </p:sp>
+          <p:sp>
+            <p:nvSpPr>
+              <p:cNvPr id="24" name="Hexagone 23">
+                <a:extLst>
+                  <a:ext uri="{FF2B5EF4-FFF2-40B4-BE49-F238E27FC236}">
+                    <a16:creationId xmlns:a16="http://schemas.microsoft.com/office/drawing/2014/main" id="{B807D213-2629-3659-B228-C391CB1AAEAC}"/>
+                  </a:ext>
+                </a:extLst>
+              </p:cNvPr>
+              <p:cNvSpPr/>
+              <p:nvPr/>
+            </p:nvSpPr>
+            <p:spPr>
+              <a:xfrm rot="5400000">
+                <a:off x="4174372" y="3343288"/>
+                <a:ext cx="396000" cy="360000"/>
+              </a:xfrm>
+              <a:prstGeom prst="hexagon">
+                <a:avLst/>
+              </a:prstGeom>
+              <a:blipFill>
+                <a:blip r:embed="rId6">
+                  <a:extLst>
+                    <a:ext uri="{BEBA8EAE-BF5A-486C-A8C5-ECC9F3942E4B}">
+                      <a14:imgProps xmlns:a14="http://schemas.microsoft.com/office/drawing/2010/main">
+                        <a14:imgLayer r:embed="rId7">
+                          <a14:imgEffect>
+                            <a14:brightnessContrast bright="-20000" contrast="-40000"/>
+                          </a14:imgEffect>
+                        </a14:imgLayer>
+                      </a14:imgProps>
+                    </a:ext>
+                  </a:extLst>
+                </a:blip>
+                <a:tile tx="0" ty="0" sx="100000" sy="100000" flip="none" algn="tl"/>
+              </a:blipFill>
+              <a:ln w="12700">
+                <a:solidFill>
+                  <a:schemeClr val="tx1"/>
+                </a:solidFill>
+              </a:ln>
+            </p:spPr>
+            <p:style>
+              <a:lnRef idx="2">
+                <a:schemeClr val="accent1">
+                  <a:shade val="15000"/>
+                </a:schemeClr>
+              </a:lnRef>
+              <a:fillRef idx="1">
+                <a:schemeClr val="accent1"/>
+              </a:fillRef>
+              <a:effectRef idx="0">
+                <a:schemeClr val="accent1"/>
+              </a:effectRef>
+              <a:fontRef idx="minor">
+                <a:schemeClr val="lt1"/>
+              </a:fontRef>
+            </p:style>
+            <p:txBody>
+              <a:bodyPr rtlCol="0" anchor="ctr"/>
+              <a:lstStyle/>
+              <a:p>
+                <a:pPr algn="ctr"/>
+                <a:endParaRPr lang="fr-FR"/>
+              </a:p>
+            </p:txBody>
+          </p:sp>
+          <p:sp>
+            <p:nvSpPr>
+              <p:cNvPr id="29" name="Hexagone 28">
+                <a:extLst>
+                  <a:ext uri="{FF2B5EF4-FFF2-40B4-BE49-F238E27FC236}">
+                    <a16:creationId xmlns:a16="http://schemas.microsoft.com/office/drawing/2014/main" id="{71C32418-B647-C696-341E-F8C554281360}"/>
+                  </a:ext>
+                </a:extLst>
+              </p:cNvPr>
+              <p:cNvSpPr/>
+              <p:nvPr/>
+            </p:nvSpPr>
+            <p:spPr>
+              <a:xfrm rot="5400000">
+                <a:off x="3765097" y="3353221"/>
+                <a:ext cx="396000" cy="360000"/>
+              </a:xfrm>
+              <a:prstGeom prst="hexagon">
+                <a:avLst/>
+              </a:prstGeom>
+              <a:blipFill>
+                <a:blip r:embed="rId6">
+                  <a:extLst>
+                    <a:ext uri="{BEBA8EAE-BF5A-486C-A8C5-ECC9F3942E4B}">
+                      <a14:imgProps xmlns:a14="http://schemas.microsoft.com/office/drawing/2010/main">
+                        <a14:imgLayer r:embed="rId7">
+                          <a14:imgEffect>
+                            <a14:brightnessContrast bright="-20000" contrast="-40000"/>
+                          </a14:imgEffect>
+                        </a14:imgLayer>
+                      </a14:imgProps>
+                    </a:ext>
+                  </a:extLst>
+                </a:blip>
+                <a:tile tx="0" ty="0" sx="100000" sy="100000" flip="none" algn="tl"/>
+              </a:blipFill>
+              <a:ln w="12700">
+                <a:solidFill>
+                  <a:schemeClr val="tx1"/>
+                </a:solidFill>
+              </a:ln>
+            </p:spPr>
+            <p:style>
+              <a:lnRef idx="2">
+                <a:schemeClr val="accent1">
+                  <a:shade val="15000"/>
+                </a:schemeClr>
+              </a:lnRef>
+              <a:fillRef idx="1">
+                <a:schemeClr val="accent1"/>
+              </a:fillRef>
+              <a:effectRef idx="0">
+                <a:schemeClr val="accent1"/>
+              </a:effectRef>
+              <a:fontRef idx="minor">
+                <a:schemeClr val="lt1"/>
+              </a:fontRef>
+            </p:style>
+            <p:txBody>
+              <a:bodyPr rtlCol="0" anchor="ctr"/>
+              <a:lstStyle/>
+              <a:p>
+                <a:pPr algn="ctr"/>
+                <a:endParaRPr lang="fr-FR"/>
+              </a:p>
+            </p:txBody>
+          </p:sp>
+          <p:sp>
+            <p:nvSpPr>
+              <p:cNvPr id="33" name="Hexagone 32">
+                <a:extLst>
+                  <a:ext uri="{FF2B5EF4-FFF2-40B4-BE49-F238E27FC236}">
+                    <a16:creationId xmlns:a16="http://schemas.microsoft.com/office/drawing/2014/main" id="{77F92EA8-3433-367B-00B8-58DEBBF07D4F}"/>
+                  </a:ext>
+                </a:extLst>
+              </p:cNvPr>
+              <p:cNvSpPr/>
+              <p:nvPr/>
+            </p:nvSpPr>
+            <p:spPr>
+              <a:xfrm rot="5400000">
+                <a:off x="3351594" y="3353221"/>
+                <a:ext cx="396000" cy="360000"/>
+              </a:xfrm>
+              <a:prstGeom prst="hexagon">
+                <a:avLst/>
+              </a:prstGeom>
+              <a:solidFill>
+                <a:schemeClr val="bg1"/>
+              </a:solidFill>
+              <a:ln w="12700">
+                <a:solidFill>
+                  <a:schemeClr val="tx1"/>
+                </a:solidFill>
+              </a:ln>
+            </p:spPr>
+            <p:style>
+              <a:lnRef idx="2">
+                <a:schemeClr val="accent1">
+                  <a:shade val="15000"/>
+                </a:schemeClr>
+              </a:lnRef>
+              <a:fillRef idx="1">
+                <a:schemeClr val="accent1"/>
+              </a:fillRef>
+              <a:effectRef idx="0">
+                <a:schemeClr val="accent1"/>
+              </a:effectRef>
+              <a:fontRef idx="minor">
+                <a:schemeClr val="lt1"/>
+              </a:fontRef>
+            </p:style>
+            <p:txBody>
+              <a:bodyPr rtlCol="0" anchor="ctr"/>
+              <a:lstStyle/>
+              <a:p>
+                <a:pPr algn="ctr"/>
+                <a:endParaRPr lang="fr-FR"/>
+              </a:p>
+            </p:txBody>
+          </p:sp>
+          <p:cxnSp>
+            <p:nvCxnSpPr>
+              <p:cNvPr id="36" name="Connecteur droit avec flèche 35">
+                <a:extLst>
+                  <a:ext uri="{FF2B5EF4-FFF2-40B4-BE49-F238E27FC236}">
+                    <a16:creationId xmlns:a16="http://schemas.microsoft.com/office/drawing/2014/main" id="{736882CF-9DC7-3AD3-A901-225A6A5369D8}"/>
+                  </a:ext>
+                </a:extLst>
+              </p:cNvPr>
+              <p:cNvCxnSpPr>
+                <a:cxnSpLocks/>
+              </p:cNvCxnSpPr>
+              <p:nvPr/>
+            </p:nvCxnSpPr>
+            <p:spPr>
+              <a:xfrm>
+                <a:off x="3569494" y="3527262"/>
+                <a:ext cx="1269309" cy="0"/>
+              </a:xfrm>
+              <a:prstGeom prst="straightConnector1">
+                <a:avLst/>
+              </a:prstGeom>
+              <a:ln w="57150">
+                <a:solidFill>
+                  <a:srgbClr val="E5EFC9"/>
+                </a:solidFill>
+                <a:tailEnd type="triangle"/>
+              </a:ln>
+            </p:spPr>
+            <p:style>
+              <a:lnRef idx="2">
+                <a:schemeClr val="dk1"/>
+              </a:lnRef>
+              <a:fillRef idx="0">
+                <a:schemeClr val="dk1"/>
+              </a:fillRef>
+              <a:effectRef idx="1">
+                <a:schemeClr val="dk1"/>
+              </a:effectRef>
+              <a:fontRef idx="minor">
+                <a:schemeClr val="tx1"/>
+              </a:fontRef>
+            </p:style>
+          </p:cxnSp>
+          <p:cxnSp>
+            <p:nvCxnSpPr>
+              <p:cNvPr id="40" name="Connecteur droit avec flèche 39">
+                <a:extLst>
+                  <a:ext uri="{FF2B5EF4-FFF2-40B4-BE49-F238E27FC236}">
+                    <a16:creationId xmlns:a16="http://schemas.microsoft.com/office/drawing/2014/main" id="{99EB6A6A-F4C8-7000-15FA-EDF9378269CE}"/>
+                  </a:ext>
+                </a:extLst>
+              </p:cNvPr>
+              <p:cNvCxnSpPr>
+                <a:cxnSpLocks/>
+              </p:cNvCxnSpPr>
+              <p:nvPr/>
+            </p:nvCxnSpPr>
+            <p:spPr>
+              <a:xfrm>
+                <a:off x="3571416" y="3530348"/>
+                <a:ext cx="898091" cy="0"/>
+              </a:xfrm>
+              <a:prstGeom prst="straightConnector1">
+                <a:avLst/>
+              </a:prstGeom>
+              <a:ln w="57150">
+                <a:solidFill>
+                  <a:srgbClr val="E5EFC9"/>
+                </a:solidFill>
+                <a:tailEnd type="triangle"/>
+              </a:ln>
+            </p:spPr>
+            <p:style>
+              <a:lnRef idx="2">
+                <a:schemeClr val="dk1"/>
+              </a:lnRef>
+              <a:fillRef idx="0">
+                <a:schemeClr val="dk1"/>
+              </a:fillRef>
+              <a:effectRef idx="1">
+                <a:schemeClr val="dk1"/>
+              </a:effectRef>
+              <a:fontRef idx="minor">
+                <a:schemeClr val="tx1"/>
+              </a:fontRef>
+            </p:style>
+          </p:cxnSp>
+          <p:cxnSp>
+            <p:nvCxnSpPr>
+              <p:cNvPr id="44" name="Connecteur droit avec flèche 43">
+                <a:extLst>
+                  <a:ext uri="{FF2B5EF4-FFF2-40B4-BE49-F238E27FC236}">
+                    <a16:creationId xmlns:a16="http://schemas.microsoft.com/office/drawing/2014/main" id="{C95CD993-F2EC-0B30-5C9F-F069E221074B}"/>
+                  </a:ext>
+                </a:extLst>
+              </p:cNvPr>
+              <p:cNvCxnSpPr>
+                <a:cxnSpLocks/>
+              </p:cNvCxnSpPr>
+              <p:nvPr/>
+            </p:nvCxnSpPr>
+            <p:spPr>
+              <a:xfrm>
+                <a:off x="3571416" y="3530348"/>
+                <a:ext cx="498112" cy="0"/>
+              </a:xfrm>
+              <a:prstGeom prst="straightConnector1">
+                <a:avLst/>
+              </a:prstGeom>
+              <a:ln w="57150">
+                <a:solidFill>
+                  <a:srgbClr val="E5EFC9"/>
+                </a:solidFill>
+                <a:tailEnd type="triangle"/>
+              </a:ln>
+            </p:spPr>
+            <p:style>
+              <a:lnRef idx="2">
+                <a:schemeClr val="dk1"/>
+              </a:lnRef>
+              <a:fillRef idx="0">
+                <a:schemeClr val="dk1"/>
+              </a:fillRef>
+              <a:effectRef idx="1">
+                <a:schemeClr val="dk1"/>
+              </a:effectRef>
+              <a:fontRef idx="minor">
+                <a:schemeClr val="tx1"/>
+              </a:fontRef>
+            </p:style>
+          </p:cxnSp>
+          <p:sp>
+            <p:nvSpPr>
+              <p:cNvPr id="47" name="Ellipse 46">
+                <a:extLst>
+                  <a:ext uri="{FF2B5EF4-FFF2-40B4-BE49-F238E27FC236}">
+                    <a16:creationId xmlns:a16="http://schemas.microsoft.com/office/drawing/2014/main" id="{150349EB-492C-940D-1F8F-8155A4479238}"/>
+                  </a:ext>
+                </a:extLst>
+              </p:cNvPr>
+              <p:cNvSpPr/>
+              <p:nvPr/>
+            </p:nvSpPr>
+            <p:spPr>
+              <a:xfrm>
+                <a:off x="3459594" y="3446348"/>
+                <a:ext cx="180000" cy="180000"/>
+              </a:xfrm>
+              <a:prstGeom prst="ellipse">
+                <a:avLst/>
+              </a:prstGeom>
+              <a:blipFill>
+                <a:blip r:embed="rId8"/>
+                <a:tile tx="0" ty="0" sx="100000" sy="100000" flip="none" algn="tl"/>
+              </a:blipFill>
+              <a:ln w="12700">
+                <a:solidFill>
+                  <a:schemeClr val="tx1"/>
+                </a:solidFill>
+              </a:ln>
+            </p:spPr>
+            <p:style>
+              <a:lnRef idx="2">
+                <a:schemeClr val="dk1">
+                  <a:shade val="15000"/>
+                </a:schemeClr>
+              </a:lnRef>
+              <a:fillRef idx="1">
+                <a:schemeClr val="dk1"/>
+              </a:fillRef>
+              <a:effectRef idx="0">
+                <a:schemeClr val="dk1"/>
+              </a:effectRef>
+              <a:fontRef idx="minor">
+                <a:schemeClr val="lt1"/>
+              </a:fontRef>
+            </p:style>
+            <p:txBody>
+              <a:bodyPr rtlCol="0" anchor="ctr"/>
+              <a:lstStyle/>
+              <a:p>
+                <a:pPr algn="ctr"/>
+                <a:endParaRPr lang="fr-FR"/>
+              </a:p>
+            </p:txBody>
+          </p:sp>
+        </p:grpSp>
+        <p:sp>
+          <p:nvSpPr>
+            <p:cNvPr id="58" name="ZoneTexte 57">
+              <a:extLst>
+                <a:ext uri="{FF2B5EF4-FFF2-40B4-BE49-F238E27FC236}">
+                  <a16:creationId xmlns:a16="http://schemas.microsoft.com/office/drawing/2014/main" id="{F51D4383-C9D9-27BF-16FE-F3D6BD97089C}"/>
+                </a:ext>
+              </a:extLst>
+            </p:cNvPr>
+            <p:cNvSpPr txBox="1"/>
+            <p:nvPr/>
+          </p:nvSpPr>
+          <p:spPr>
+            <a:xfrm>
+              <a:off x="3240355" y="2715144"/>
+              <a:ext cx="1296933" cy="461665"/>
+            </a:xfrm>
+            <a:prstGeom prst="rect">
+              <a:avLst/>
+            </a:prstGeom>
+            <a:noFill/>
+          </p:spPr>
+          <p:txBody>
+            <a:bodyPr wrap="square" rtlCol="0">
+              <a:spAutoFit/>
+            </a:bodyPr>
+            <a:lstStyle/>
+            <a:p>
+              <a:r>
+                <a:rPr lang="fr-FR" sz="1200" b="1" dirty="0">
+                  <a:solidFill>
+                    <a:schemeClr val="bg1"/>
+                  </a:solidFill>
+                  <a:latin typeface="Segoe UI" panose="020B0502040204020203" pitchFamily="34" charset="0"/>
+                  <a:cs typeface="Segoe UI" panose="020B0502040204020203" pitchFamily="34" charset="0"/>
+                </a:rPr>
+                <a:t>Résoudre les affrontements</a:t>
+              </a:r>
+            </a:p>
+          </p:txBody>
+        </p:sp>
+        <p:sp>
+          <p:nvSpPr>
+            <p:cNvPr id="75" name="Hexagone 74">
+              <a:extLst>
+                <a:ext uri="{FF2B5EF4-FFF2-40B4-BE49-F238E27FC236}">
+                  <a16:creationId xmlns:a16="http://schemas.microsoft.com/office/drawing/2014/main" id="{0251A5E2-1C13-CFD0-9521-2EA4F5A79E12}"/>
+                </a:ext>
+              </a:extLst>
+            </p:cNvPr>
+            <p:cNvSpPr/>
+            <p:nvPr/>
+          </p:nvSpPr>
+          <p:spPr>
+            <a:xfrm rot="5400000">
+              <a:off x="3632453" y="4231662"/>
+              <a:ext cx="390567" cy="368869"/>
+            </a:xfrm>
+            <a:prstGeom prst="hexagon">
+              <a:avLst/>
+            </a:prstGeom>
+            <a:blipFill>
+              <a:blip r:embed="rId9">
+                <a:extLst>
+                  <a:ext uri="{BEBA8EAE-BF5A-486C-A8C5-ECC9F3942E4B}">
+                    <a14:imgProps xmlns:a14="http://schemas.microsoft.com/office/drawing/2010/main">
+                      <a14:imgLayer r:embed="rId10">
+                        <a14:imgEffect>
+                          <a14:artisticGlass/>
+                        </a14:imgEffect>
+                      </a14:imgLayer>
+                    </a14:imgProps>
+                  </a:ext>
+                </a:extLst>
+              </a:blip>
+              <a:tile tx="0" ty="0" sx="100000" sy="100000" flip="none" algn="tl"/>
+            </a:blipFill>
+            <a:ln w="12700">
+              <a:solidFill>
+                <a:schemeClr val="tx1"/>
+              </a:solidFill>
+            </a:ln>
+          </p:spPr>
+          <p:style>
+            <a:lnRef idx="2">
+              <a:schemeClr val="accent1">
+                <a:shade val="15000"/>
+              </a:schemeClr>
+            </a:lnRef>
+            <a:fillRef idx="1">
+              <a:schemeClr val="accent1"/>
+            </a:fillRef>
+            <a:effectRef idx="0">
+              <a:schemeClr val="accent1"/>
+            </a:effectRef>
+            <a:fontRef idx="minor">
+              <a:schemeClr val="lt1"/>
+            </a:fontRef>
+          </p:style>
+          <p:txBody>
+            <a:bodyPr rtlCol="0" anchor="ctr"/>
+            <a:lstStyle/>
+            <a:p>
+              <a:pPr algn="ctr"/>
+              <a:endParaRPr lang="fr-FR"/>
+            </a:p>
+          </p:txBody>
+        </p:sp>
+        <p:sp>
+          <p:nvSpPr>
+            <p:cNvPr id="76" name="Rectangle 75">
+              <a:extLst>
+                <a:ext uri="{FF2B5EF4-FFF2-40B4-BE49-F238E27FC236}">
+                  <a16:creationId xmlns:a16="http://schemas.microsoft.com/office/drawing/2014/main" id="{D8990306-6172-B672-2E45-27485F40E252}"/>
+                </a:ext>
+              </a:extLst>
+            </p:cNvPr>
+            <p:cNvSpPr/>
+            <p:nvPr/>
+          </p:nvSpPr>
+          <p:spPr>
+            <a:xfrm>
+              <a:off x="3782231" y="4396316"/>
+              <a:ext cx="91844" cy="124982"/>
+            </a:xfrm>
+            <a:prstGeom prst="rect">
+              <a:avLst/>
+            </a:prstGeom>
+            <a:solidFill>
+              <a:schemeClr val="bg1"/>
+            </a:solidFill>
+            <a:ln w="12700">
+              <a:solidFill>
+                <a:schemeClr val="tx1"/>
+              </a:solidFill>
+            </a:ln>
+          </p:spPr>
+          <p:style>
+            <a:lnRef idx="2">
+              <a:schemeClr val="accent1">
+                <a:shade val="15000"/>
+              </a:schemeClr>
+            </a:lnRef>
+            <a:fillRef idx="1">
+              <a:schemeClr val="accent1"/>
+            </a:fillRef>
+            <a:effectRef idx="0">
+              <a:schemeClr val="accent1"/>
+            </a:effectRef>
+            <a:fontRef idx="minor">
+              <a:schemeClr val="lt1"/>
+            </a:fontRef>
+          </p:style>
+          <p:txBody>
+            <a:bodyPr rtlCol="0" anchor="ctr"/>
+            <a:lstStyle/>
+            <a:p>
+              <a:pPr algn="ctr"/>
+              <a:endParaRPr lang="fr-FR"/>
+            </a:p>
+          </p:txBody>
+        </p:sp>
+        <p:sp>
+          <p:nvSpPr>
+            <p:cNvPr id="81" name="Ellipse 80">
+              <a:extLst>
+                <a:ext uri="{FF2B5EF4-FFF2-40B4-BE49-F238E27FC236}">
+                  <a16:creationId xmlns:a16="http://schemas.microsoft.com/office/drawing/2014/main" id="{60BA55C4-D641-236B-F765-0F396A8689C4}"/>
+                </a:ext>
+              </a:extLst>
+            </p:cNvPr>
+            <p:cNvSpPr/>
+            <p:nvPr/>
+          </p:nvSpPr>
+          <p:spPr>
+            <a:xfrm>
+              <a:off x="3780190" y="4302724"/>
+              <a:ext cx="91844" cy="91844"/>
+            </a:xfrm>
+            <a:prstGeom prst="ellipse">
+              <a:avLst/>
+            </a:prstGeom>
+            <a:solidFill>
+              <a:schemeClr val="bg1"/>
+            </a:solidFill>
+            <a:ln w="12700">
+              <a:solidFill>
+                <a:schemeClr val="tx1"/>
+              </a:solidFill>
+            </a:ln>
+          </p:spPr>
+          <p:style>
+            <a:lnRef idx="2">
+              <a:schemeClr val="dk1">
+                <a:shade val="15000"/>
+              </a:schemeClr>
+            </a:lnRef>
+            <a:fillRef idx="1">
+              <a:schemeClr val="dk1"/>
+            </a:fillRef>
+            <a:effectRef idx="0">
+              <a:schemeClr val="dk1"/>
+            </a:effectRef>
+            <a:fontRef idx="minor">
+              <a:schemeClr val="lt1"/>
+            </a:fontRef>
+          </p:style>
+          <p:txBody>
+            <a:bodyPr rtlCol="0" anchor="ctr"/>
+            <a:lstStyle/>
+            <a:p>
+              <a:pPr algn="ctr"/>
+              <a:endParaRPr lang="fr-FR"/>
+            </a:p>
+          </p:txBody>
+        </p:sp>
+        <p:sp>
+          <p:nvSpPr>
+            <p:cNvPr id="100" name="Hexagone 99">
+              <a:extLst>
+                <a:ext uri="{FF2B5EF4-FFF2-40B4-BE49-F238E27FC236}">
+                  <a16:creationId xmlns:a16="http://schemas.microsoft.com/office/drawing/2014/main" id="{4DAEB8A2-D883-3AE5-4974-BBFCC420530D}"/>
+                </a:ext>
+              </a:extLst>
+            </p:cNvPr>
+            <p:cNvSpPr/>
+            <p:nvPr/>
+          </p:nvSpPr>
+          <p:spPr>
+            <a:xfrm rot="5400000">
+              <a:off x="4067480" y="4236904"/>
+              <a:ext cx="396000" cy="373999"/>
+            </a:xfrm>
+            <a:prstGeom prst="hexagon">
+              <a:avLst/>
+            </a:prstGeom>
+            <a:blipFill>
+              <a:blip r:embed="rId9">
+                <a:extLst>
+                  <a:ext uri="{BEBA8EAE-BF5A-486C-A8C5-ECC9F3942E4B}">
+                    <a14:imgProps xmlns:a14="http://schemas.microsoft.com/office/drawing/2010/main">
+                      <a14:imgLayer r:embed="rId10">
+                        <a14:imgEffect>
+                          <a14:artisticGlass/>
+                        </a14:imgEffect>
+                      </a14:imgLayer>
+                    </a14:imgProps>
+                  </a:ext>
+                </a:extLst>
+              </a:blip>
+              <a:tile tx="0" ty="0" sx="100000" sy="100000" flip="none" algn="tl"/>
+            </a:blipFill>
+            <a:ln w="12700">
+              <a:solidFill>
+                <a:schemeClr val="tx1"/>
+              </a:solidFill>
+            </a:ln>
+          </p:spPr>
+          <p:style>
+            <a:lnRef idx="2">
+              <a:schemeClr val="accent1">
+                <a:shade val="15000"/>
+              </a:schemeClr>
+            </a:lnRef>
+            <a:fillRef idx="1">
+              <a:schemeClr val="accent1"/>
+            </a:fillRef>
+            <a:effectRef idx="0">
+              <a:schemeClr val="accent1"/>
+            </a:effectRef>
+            <a:fontRef idx="minor">
+              <a:schemeClr val="lt1"/>
+            </a:fontRef>
+          </p:style>
+          <p:txBody>
+            <a:bodyPr rtlCol="0" anchor="ctr"/>
+            <a:lstStyle/>
+            <a:p>
+              <a:pPr algn="ctr"/>
+              <a:endParaRPr lang="fr-FR"/>
+            </a:p>
+          </p:txBody>
+        </p:sp>
+        <p:sp>
+          <p:nvSpPr>
+            <p:cNvPr id="101" name="Rectangle 100">
+              <a:extLst>
+                <a:ext uri="{FF2B5EF4-FFF2-40B4-BE49-F238E27FC236}">
+                  <a16:creationId xmlns:a16="http://schemas.microsoft.com/office/drawing/2014/main" id="{F583FF82-982B-BB60-FDAA-E5248049DA6F}"/>
+                </a:ext>
+              </a:extLst>
+            </p:cNvPr>
+            <p:cNvSpPr/>
+            <p:nvPr/>
+          </p:nvSpPr>
+          <p:spPr>
+            <a:xfrm>
+              <a:off x="4208421" y="4335171"/>
+              <a:ext cx="93121" cy="177465"/>
+            </a:xfrm>
+            <a:prstGeom prst="rect">
+              <a:avLst/>
+            </a:prstGeom>
+            <a:solidFill>
+              <a:schemeClr val="bg1"/>
+            </a:solidFill>
+            <a:ln w="12700">
+              <a:solidFill>
+                <a:schemeClr val="tx1"/>
+              </a:solidFill>
+            </a:ln>
+          </p:spPr>
+          <p:style>
+            <a:lnRef idx="2">
+              <a:schemeClr val="accent1">
+                <a:shade val="15000"/>
+              </a:schemeClr>
+            </a:lnRef>
+            <a:fillRef idx="1">
+              <a:schemeClr val="accent1"/>
+            </a:fillRef>
+            <a:effectRef idx="0">
+              <a:schemeClr val="accent1"/>
+            </a:effectRef>
+            <a:fontRef idx="minor">
+              <a:schemeClr val="lt1"/>
+            </a:fontRef>
+          </p:style>
+          <p:txBody>
+            <a:bodyPr rtlCol="0" anchor="ctr"/>
+            <a:lstStyle/>
+            <a:p>
+              <a:pPr algn="ctr"/>
+              <a:endParaRPr lang="fr-FR"/>
+            </a:p>
+          </p:txBody>
+        </p:sp>
+        <p:sp>
+          <p:nvSpPr>
+            <p:cNvPr id="83" name="Hexagone 82">
+              <a:extLst>
+                <a:ext uri="{FF2B5EF4-FFF2-40B4-BE49-F238E27FC236}">
+                  <a16:creationId xmlns:a16="http://schemas.microsoft.com/office/drawing/2014/main" id="{E9727FA2-A160-4828-A2A6-E0CC100A5CFB}"/>
+                </a:ext>
+              </a:extLst>
+            </p:cNvPr>
+            <p:cNvSpPr/>
+            <p:nvPr/>
+          </p:nvSpPr>
+          <p:spPr>
+            <a:xfrm rot="5400000">
+              <a:off x="4507789" y="4231813"/>
+              <a:ext cx="396000" cy="374000"/>
+            </a:xfrm>
+            <a:prstGeom prst="hexagon">
+              <a:avLst/>
+            </a:prstGeom>
+            <a:blipFill>
+              <a:blip r:embed="rId9">
+                <a:extLst>
+                  <a:ext uri="{BEBA8EAE-BF5A-486C-A8C5-ECC9F3942E4B}">
+                    <a14:imgProps xmlns:a14="http://schemas.microsoft.com/office/drawing/2010/main">
+                      <a14:imgLayer r:embed="rId10">
+                        <a14:imgEffect>
+                          <a14:artisticGlass/>
+                        </a14:imgEffect>
+                      </a14:imgLayer>
+                    </a14:imgProps>
+                  </a:ext>
+                </a:extLst>
+              </a:blip>
+              <a:tile tx="0" ty="0" sx="100000" sy="100000" flip="none" algn="tl"/>
+            </a:blipFill>
+            <a:ln w="12700">
+              <a:solidFill>
+                <a:schemeClr val="tx1"/>
+              </a:solidFill>
+            </a:ln>
+          </p:spPr>
+          <p:style>
+            <a:lnRef idx="2">
+              <a:schemeClr val="accent1">
+                <a:shade val="15000"/>
+              </a:schemeClr>
+            </a:lnRef>
+            <a:fillRef idx="1">
+              <a:schemeClr val="accent1"/>
+            </a:fillRef>
+            <a:effectRef idx="0">
+              <a:schemeClr val="accent1"/>
+            </a:effectRef>
+            <a:fontRef idx="minor">
+              <a:schemeClr val="lt1"/>
+            </a:fontRef>
+          </p:style>
+          <p:txBody>
+            <a:bodyPr rtlCol="0" anchor="ctr"/>
+            <a:lstStyle/>
+            <a:p>
+              <a:pPr algn="ctr"/>
+              <a:endParaRPr lang="fr-FR"/>
+            </a:p>
+          </p:txBody>
+        </p:sp>
+        <p:sp>
+          <p:nvSpPr>
+            <p:cNvPr id="84" name="Rectangle 83">
+              <a:extLst>
+                <a:ext uri="{FF2B5EF4-FFF2-40B4-BE49-F238E27FC236}">
+                  <a16:creationId xmlns:a16="http://schemas.microsoft.com/office/drawing/2014/main" id="{9207F287-B272-0AF9-6078-EC1EA7C73DFA}"/>
+                </a:ext>
+              </a:extLst>
+            </p:cNvPr>
+            <p:cNvSpPr/>
+            <p:nvPr/>
+          </p:nvSpPr>
+          <p:spPr>
+            <a:xfrm>
+              <a:off x="4579441" y="4330080"/>
+              <a:ext cx="93122" cy="177465"/>
+            </a:xfrm>
+            <a:prstGeom prst="rect">
+              <a:avLst/>
+            </a:prstGeom>
+            <a:solidFill>
+              <a:schemeClr val="bg1"/>
+            </a:solidFill>
+            <a:ln w="12700">
+              <a:solidFill>
+                <a:schemeClr val="tx1"/>
+              </a:solidFill>
+            </a:ln>
+          </p:spPr>
+          <p:style>
+            <a:lnRef idx="2">
+              <a:schemeClr val="accent1">
+                <a:shade val="15000"/>
+              </a:schemeClr>
+            </a:lnRef>
+            <a:fillRef idx="1">
+              <a:schemeClr val="accent1"/>
+            </a:fillRef>
+            <a:effectRef idx="0">
+              <a:schemeClr val="accent1"/>
+            </a:effectRef>
+            <a:fontRef idx="minor">
+              <a:schemeClr val="lt1"/>
+            </a:fontRef>
+          </p:style>
+          <p:txBody>
+            <a:bodyPr rtlCol="0" anchor="ctr"/>
+            <a:lstStyle/>
+            <a:p>
+              <a:pPr algn="ctr"/>
+              <a:endParaRPr lang="fr-FR"/>
+            </a:p>
+          </p:txBody>
+        </p:sp>
+        <p:pic>
+          <p:nvPicPr>
+            <p:cNvPr id="85" name="Graphique 84" descr="Pion avec un remplissage uni">
+              <a:extLst>
+                <a:ext uri="{FF2B5EF4-FFF2-40B4-BE49-F238E27FC236}">
+                  <a16:creationId xmlns:a16="http://schemas.microsoft.com/office/drawing/2014/main" id="{1376AE10-5A16-81AE-866C-D12F91256BB6}"/>
+                </a:ext>
+              </a:extLst>
+            </p:cNvPr>
+            <p:cNvPicPr>
+              <a:picLocks noChangeAspect="1"/>
+            </p:cNvPicPr>
+            <p:nvPr/>
+          </p:nvPicPr>
+          <p:blipFill>
+            <a:blip>
+              <a:extLst>
+                <a:ext uri="{96DAC541-7B7A-43D3-8B79-37D633B846F1}">
+                  <asvg:svgBlip xmlns:asvg="http://schemas.microsoft.com/office/drawing/2016/SVG/main" r:embed="rId11"/>
+                </a:ext>
+              </a:extLst>
+            </a:blip>
+            <a:srcRect l="28037" t="14617" r="27500" b="15665"/>
+            <a:stretch>
+              <a:fillRect/>
+            </a:stretch>
+          </p:blipFill>
+          <p:spPr>
+            <a:xfrm>
+              <a:off x="4710395" y="4317980"/>
+              <a:ext cx="120894" cy="189565"/>
+            </a:xfrm>
+            <a:prstGeom prst="rect">
+              <a:avLst/>
+            </a:prstGeom>
+          </p:spPr>
+        </p:pic>
+        <p:sp>
+          <p:nvSpPr>
+            <p:cNvPr id="97" name="Rectangle 96">
+              <a:extLst>
+                <a:ext uri="{FF2B5EF4-FFF2-40B4-BE49-F238E27FC236}">
+                  <a16:creationId xmlns:a16="http://schemas.microsoft.com/office/drawing/2014/main" id="{4B74F0ED-0507-5FB0-69CC-3ECC69FF21CD}"/>
+                </a:ext>
+              </a:extLst>
+            </p:cNvPr>
+            <p:cNvSpPr/>
+            <p:nvPr/>
+          </p:nvSpPr>
+          <p:spPr>
+            <a:xfrm>
+              <a:off x="3152197" y="1377054"/>
+              <a:ext cx="432000" cy="432000"/>
+            </a:xfrm>
+            <a:prstGeom prst="rect">
+              <a:avLst/>
+            </a:prstGeom>
+            <a:blipFill dpi="0" rotWithShape="1">
+              <a:blip r:embed="rId3">
+                <a:alphaModFix amt="50000"/>
+                <a:extLst>
+                  <a:ext uri="{BEBA8EAE-BF5A-486C-A8C5-ECC9F3942E4B}">
+                    <a14:imgProps xmlns:a14="http://schemas.microsoft.com/office/drawing/2010/main">
+                      <a14:imgLayer r:embed="rId4">
+                        <a14:imgEffect>
+                          <a14:artisticWatercolorSponge/>
+                        </a14:imgEffect>
+                        <a14:imgEffect>
+                          <a14:brightnessContrast bright="-40000" contrast="20000"/>
+                        </a14:imgEffect>
+                      </a14:imgLayer>
+                    </a14:imgProps>
+                  </a:ext>
+                </a:extLst>
+              </a:blip>
+              <a:srcRect/>
+              <a:tile tx="0" ty="0" sx="100000" sy="100000" flip="none" algn="tl"/>
+            </a:blipFill>
+            <a:ln>
+              <a:solidFill>
+                <a:schemeClr val="tx1"/>
+              </a:solidFill>
+            </a:ln>
+          </p:spPr>
+          <p:style>
+            <a:lnRef idx="2">
+              <a:schemeClr val="accent1">
+                <a:shade val="15000"/>
+              </a:schemeClr>
+            </a:lnRef>
+            <a:fillRef idx="1">
+              <a:schemeClr val="accent1"/>
+            </a:fillRef>
+            <a:effectRef idx="0">
+              <a:schemeClr val="accent1"/>
+            </a:effectRef>
+            <a:fontRef idx="minor">
+              <a:schemeClr val="lt1"/>
+            </a:fontRef>
+          </p:style>
+          <p:txBody>
+            <a:bodyPr lIns="0" tIns="0" rIns="0" bIns="0" rtlCol="0" anchor="ctr"/>
+            <a:lstStyle/>
+            <a:p>
+              <a:pPr algn="ctr"/>
+              <a:r>
+                <a:rPr lang="fr-FR" sz="1600" b="1" dirty="0">
+                  <a:solidFill>
+                    <a:schemeClr val="bg1"/>
+                  </a:solidFill>
+                  <a:latin typeface="Segoe UI" panose="020B0502040204020203" pitchFamily="34" charset="0"/>
+                  <a:cs typeface="Segoe UI" panose="020B0502040204020203" pitchFamily="34" charset="0"/>
+                </a:rPr>
+                <a:t>D</a:t>
+              </a:r>
+            </a:p>
+          </p:txBody>
+        </p:sp>
+        <p:sp>
+          <p:nvSpPr>
+            <p:cNvPr id="98" name="Rectangle 97">
+              <a:extLst>
+                <a:ext uri="{FF2B5EF4-FFF2-40B4-BE49-F238E27FC236}">
+                  <a16:creationId xmlns:a16="http://schemas.microsoft.com/office/drawing/2014/main" id="{74869369-1BDD-DB37-BABB-FE80513418A5}"/>
+                </a:ext>
+              </a:extLst>
+            </p:cNvPr>
+            <p:cNvSpPr/>
+            <p:nvPr/>
+          </p:nvSpPr>
+          <p:spPr>
+            <a:xfrm>
+              <a:off x="4844197" y="1378272"/>
+              <a:ext cx="432000" cy="432000"/>
+            </a:xfrm>
+            <a:prstGeom prst="rect">
+              <a:avLst/>
+            </a:prstGeom>
+            <a:blipFill dpi="0" rotWithShape="1">
+              <a:blip r:embed="rId3">
+                <a:alphaModFix amt="50000"/>
+                <a:extLst>
+                  <a:ext uri="{BEBA8EAE-BF5A-486C-A8C5-ECC9F3942E4B}">
+                    <a14:imgProps xmlns:a14="http://schemas.microsoft.com/office/drawing/2010/main">
+                      <a14:imgLayer r:embed="rId4">
+                        <a14:imgEffect>
+                          <a14:artisticWatercolorSponge/>
+                        </a14:imgEffect>
+                        <a14:imgEffect>
+                          <a14:brightnessContrast bright="-40000" contrast="20000"/>
+                        </a14:imgEffect>
+                      </a14:imgLayer>
+                    </a14:imgProps>
+                  </a:ext>
+                </a:extLst>
+              </a:blip>
+              <a:srcRect/>
+              <a:tile tx="0" ty="0" sx="100000" sy="100000" flip="none" algn="tl"/>
+            </a:blipFill>
+            <a:ln>
+              <a:solidFill>
+                <a:schemeClr val="tx1"/>
+              </a:solidFill>
+            </a:ln>
+          </p:spPr>
+          <p:style>
+            <a:lnRef idx="2">
+              <a:schemeClr val="accent1">
+                <a:shade val="15000"/>
+              </a:schemeClr>
+            </a:lnRef>
+            <a:fillRef idx="1">
+              <a:schemeClr val="accent1"/>
+            </a:fillRef>
+            <a:effectRef idx="0">
+              <a:schemeClr val="accent1"/>
+            </a:effectRef>
+            <a:fontRef idx="minor">
+              <a:schemeClr val="lt1"/>
+            </a:fontRef>
+          </p:style>
+          <p:txBody>
+            <a:bodyPr lIns="0" tIns="0" rIns="0" bIns="0" rtlCol="0" anchor="ctr"/>
+            <a:lstStyle/>
+            <a:p>
+              <a:pPr algn="ctr"/>
+              <a:r>
+                <a:rPr lang="fr-FR" sz="1600" b="1" dirty="0">
+                  <a:solidFill>
+                    <a:schemeClr val="bg1"/>
+                  </a:solidFill>
+                  <a:latin typeface="Segoe UI" panose="020B0502040204020203" pitchFamily="34" charset="0"/>
+                  <a:cs typeface="Segoe UI" panose="020B0502040204020203" pitchFamily="34" charset="0"/>
+                </a:rPr>
+                <a:t>D</a:t>
+              </a:r>
+            </a:p>
+          </p:txBody>
+        </p:sp>
+        <p:pic>
+          <p:nvPicPr>
+            <p:cNvPr id="99" name="Image 98">
+              <a:extLst>
+                <a:ext uri="{FF2B5EF4-FFF2-40B4-BE49-F238E27FC236}">
+                  <a16:creationId xmlns:a16="http://schemas.microsoft.com/office/drawing/2014/main" id="{157FC146-F5F8-7814-347A-12270DFE9449}"/>
+                </a:ext>
+              </a:extLst>
+            </p:cNvPr>
+            <p:cNvPicPr>
+              <a:picLocks noChangeAspect="1"/>
+            </p:cNvPicPr>
+            <p:nvPr/>
+          </p:nvPicPr>
+          <p:blipFill>
+            <a:blip r:embed="rId12">
+              <a:extLst>
+                <a:ext uri="{BEBA8EAE-BF5A-486C-A8C5-ECC9F3942E4B}">
+                  <a14:imgProps xmlns:a14="http://schemas.microsoft.com/office/drawing/2010/main">
+                    <a14:imgLayer r:embed="rId13">
+                      <a14:imgEffect>
+                        <a14:brightnessContrast contrast="40000"/>
+                      </a14:imgEffect>
+                    </a14:imgLayer>
+                  </a14:imgProps>
+                </a:ext>
+                <a:ext uri="{28A0092B-C50C-407E-A947-70E740481C1C}">
+                  <a14:useLocalDpi xmlns:a14="http://schemas.microsoft.com/office/drawing/2010/main" val="0"/>
+                </a:ext>
+              </a:extLst>
+            </a:blip>
+            <a:stretch>
+              <a:fillRect/>
+            </a:stretch>
+          </p:blipFill>
+          <p:spPr>
+            <a:xfrm>
+              <a:off x="4457415" y="2538404"/>
+              <a:ext cx="540000" cy="540000"/>
+            </a:xfrm>
+            <a:prstGeom prst="rect">
+              <a:avLst/>
+            </a:prstGeom>
+          </p:spPr>
+        </p:pic>
+        <p:grpSp>
+          <p:nvGrpSpPr>
+            <p:cNvPr id="111" name="Groupe 110">
+              <a:extLst>
+                <a:ext uri="{FF2B5EF4-FFF2-40B4-BE49-F238E27FC236}">
+                  <a16:creationId xmlns:a16="http://schemas.microsoft.com/office/drawing/2014/main" id="{97CE3427-9907-BA58-6DFA-96C09F5E9D73}"/>
+                </a:ext>
+              </a:extLst>
+            </p:cNvPr>
+            <p:cNvGrpSpPr/>
+            <p:nvPr/>
+          </p:nvGrpSpPr>
+          <p:grpSpPr>
+            <a:xfrm>
+              <a:off x="3352321" y="3672739"/>
+              <a:ext cx="1592053" cy="405933"/>
+              <a:chOff x="3577654" y="3804073"/>
+              <a:chExt cx="1592053" cy="405933"/>
+            </a:xfrm>
+          </p:grpSpPr>
+          <p:sp>
+            <p:nvSpPr>
+              <p:cNvPr id="102" name="Hexagone 101">
+                <a:extLst>
+                  <a:ext uri="{FF2B5EF4-FFF2-40B4-BE49-F238E27FC236}">
+                    <a16:creationId xmlns:a16="http://schemas.microsoft.com/office/drawing/2014/main" id="{89DC41F8-9A7A-4EA5-E756-36B1012ED376}"/>
+                  </a:ext>
+                </a:extLst>
+              </p:cNvPr>
+              <p:cNvSpPr/>
+              <p:nvPr/>
+            </p:nvSpPr>
+            <p:spPr>
+              <a:xfrm rot="5400000">
+                <a:off x="4791707" y="3822073"/>
+                <a:ext cx="396000" cy="360000"/>
+              </a:xfrm>
+              <a:prstGeom prst="hexagon">
+                <a:avLst/>
+              </a:prstGeom>
+              <a:blipFill>
+                <a:blip r:embed="rId6">
+                  <a:extLst>
+                    <a:ext uri="{BEBA8EAE-BF5A-486C-A8C5-ECC9F3942E4B}">
+                      <a14:imgProps xmlns:a14="http://schemas.microsoft.com/office/drawing/2010/main">
+                        <a14:imgLayer r:embed="rId7">
+                          <a14:imgEffect>
+                            <a14:brightnessContrast bright="-20000" contrast="-40000"/>
+                          </a14:imgEffect>
+                        </a14:imgLayer>
+                      </a14:imgProps>
+                    </a:ext>
+                  </a:extLst>
+                </a:blip>
+                <a:tile tx="0" ty="0" sx="100000" sy="100000" flip="none" algn="tl"/>
+              </a:blipFill>
+              <a:ln w="12700">
+                <a:solidFill>
+                  <a:schemeClr val="tx1"/>
+                </a:solidFill>
+              </a:ln>
+            </p:spPr>
+            <p:style>
+              <a:lnRef idx="2">
+                <a:schemeClr val="accent1">
+                  <a:shade val="15000"/>
+                </a:schemeClr>
+              </a:lnRef>
+              <a:fillRef idx="1">
+                <a:schemeClr val="accent1"/>
+              </a:fillRef>
+              <a:effectRef idx="0">
+                <a:schemeClr val="accent1"/>
+              </a:effectRef>
+              <a:fontRef idx="minor">
+                <a:schemeClr val="lt1"/>
+              </a:fontRef>
+            </p:style>
+            <p:txBody>
+              <a:bodyPr rtlCol="0" anchor="ctr"/>
+              <a:lstStyle/>
+              <a:p>
+                <a:pPr algn="ctr"/>
+                <a:endParaRPr lang="fr-FR"/>
+              </a:p>
+            </p:txBody>
+          </p:sp>
+          <p:sp>
+            <p:nvSpPr>
+              <p:cNvPr id="103" name="Hexagone 102">
+                <a:extLst>
+                  <a:ext uri="{FF2B5EF4-FFF2-40B4-BE49-F238E27FC236}">
+                    <a16:creationId xmlns:a16="http://schemas.microsoft.com/office/drawing/2014/main" id="{AFDE2005-57BD-32CA-F7A7-43E73961F6F8}"/>
+                  </a:ext>
+                </a:extLst>
+              </p:cNvPr>
+              <p:cNvSpPr/>
+              <p:nvPr/>
+            </p:nvSpPr>
+            <p:spPr>
+              <a:xfrm rot="5400000">
+                <a:off x="4382432" y="3822073"/>
+                <a:ext cx="396000" cy="360000"/>
+              </a:xfrm>
+              <a:prstGeom prst="hexagon">
+                <a:avLst/>
+              </a:prstGeom>
+              <a:blipFill>
+                <a:blip r:embed="rId6">
+                  <a:extLst>
+                    <a:ext uri="{BEBA8EAE-BF5A-486C-A8C5-ECC9F3942E4B}">
+                      <a14:imgProps xmlns:a14="http://schemas.microsoft.com/office/drawing/2010/main">
+                        <a14:imgLayer r:embed="rId7">
+                          <a14:imgEffect>
+                            <a14:brightnessContrast bright="-20000" contrast="-40000"/>
+                          </a14:imgEffect>
+                        </a14:imgLayer>
+                      </a14:imgProps>
+                    </a:ext>
+                  </a:extLst>
+                </a:blip>
+                <a:tile tx="0" ty="0" sx="100000" sy="100000" flip="none" algn="tl"/>
+              </a:blipFill>
+              <a:ln w="12700">
+                <a:solidFill>
+                  <a:schemeClr val="tx1"/>
+                </a:solidFill>
+              </a:ln>
+            </p:spPr>
+            <p:style>
+              <a:lnRef idx="2">
+                <a:schemeClr val="accent1">
+                  <a:shade val="15000"/>
+                </a:schemeClr>
+              </a:lnRef>
+              <a:fillRef idx="1">
+                <a:schemeClr val="accent1"/>
+              </a:fillRef>
+              <a:effectRef idx="0">
+                <a:schemeClr val="accent1"/>
+              </a:effectRef>
+              <a:fontRef idx="minor">
+                <a:schemeClr val="lt1"/>
+              </a:fontRef>
+            </p:style>
+            <p:txBody>
+              <a:bodyPr rtlCol="0" anchor="ctr"/>
+              <a:lstStyle/>
+              <a:p>
+                <a:pPr algn="ctr"/>
+                <a:endParaRPr lang="fr-FR"/>
+              </a:p>
+            </p:txBody>
+          </p:sp>
+          <p:sp>
+            <p:nvSpPr>
+              <p:cNvPr id="104" name="Hexagone 103">
+                <a:extLst>
+                  <a:ext uri="{FF2B5EF4-FFF2-40B4-BE49-F238E27FC236}">
+                    <a16:creationId xmlns:a16="http://schemas.microsoft.com/office/drawing/2014/main" id="{A94DEE98-AD81-70F8-3376-C350A7BDE587}"/>
+                  </a:ext>
+                </a:extLst>
+              </p:cNvPr>
+              <p:cNvSpPr/>
+              <p:nvPr/>
+            </p:nvSpPr>
+            <p:spPr>
+              <a:xfrm rot="5400000">
+                <a:off x="3973157" y="3832006"/>
+                <a:ext cx="396000" cy="360000"/>
+              </a:xfrm>
+              <a:prstGeom prst="hexagon">
+                <a:avLst/>
+              </a:prstGeom>
+              <a:blipFill>
+                <a:blip r:embed="rId6">
+                  <a:extLst>
+                    <a:ext uri="{BEBA8EAE-BF5A-486C-A8C5-ECC9F3942E4B}">
+                      <a14:imgProps xmlns:a14="http://schemas.microsoft.com/office/drawing/2010/main">
+                        <a14:imgLayer r:embed="rId7">
+                          <a14:imgEffect>
+                            <a14:brightnessContrast bright="-20000" contrast="-40000"/>
+                          </a14:imgEffect>
+                        </a14:imgLayer>
+                      </a14:imgProps>
+                    </a:ext>
+                  </a:extLst>
+                </a:blip>
+                <a:tile tx="0" ty="0" sx="100000" sy="100000" flip="none" algn="tl"/>
+              </a:blipFill>
+              <a:ln w="12700">
+                <a:solidFill>
+                  <a:schemeClr val="tx1"/>
+                </a:solidFill>
+              </a:ln>
+            </p:spPr>
+            <p:style>
+              <a:lnRef idx="2">
+                <a:schemeClr val="accent1">
+                  <a:shade val="15000"/>
+                </a:schemeClr>
+              </a:lnRef>
+              <a:fillRef idx="1">
+                <a:schemeClr val="accent1"/>
+              </a:fillRef>
+              <a:effectRef idx="0">
+                <a:schemeClr val="accent1"/>
+              </a:effectRef>
+              <a:fontRef idx="minor">
+                <a:schemeClr val="lt1"/>
+              </a:fontRef>
+            </p:style>
+            <p:txBody>
+              <a:bodyPr rtlCol="0" anchor="ctr"/>
+              <a:lstStyle/>
+              <a:p>
+                <a:pPr algn="ctr"/>
+                <a:endParaRPr lang="fr-FR"/>
+              </a:p>
+            </p:txBody>
+          </p:sp>
+          <p:sp>
+            <p:nvSpPr>
+              <p:cNvPr id="105" name="Hexagone 104">
+                <a:extLst>
+                  <a:ext uri="{FF2B5EF4-FFF2-40B4-BE49-F238E27FC236}">
+                    <a16:creationId xmlns:a16="http://schemas.microsoft.com/office/drawing/2014/main" id="{E38CC7BA-B662-3AE5-5C6E-E52B4A718FB2}"/>
+                  </a:ext>
+                </a:extLst>
+              </p:cNvPr>
+              <p:cNvSpPr/>
+              <p:nvPr/>
+            </p:nvSpPr>
+            <p:spPr>
+              <a:xfrm rot="5400000">
+                <a:off x="3559654" y="3832006"/>
+                <a:ext cx="396000" cy="360000"/>
+              </a:xfrm>
+              <a:prstGeom prst="hexagon">
+                <a:avLst/>
+              </a:prstGeom>
+              <a:solidFill>
+                <a:schemeClr val="bg1"/>
+              </a:solidFill>
+              <a:ln w="12700">
+                <a:solidFill>
+                  <a:schemeClr val="tx1"/>
+                </a:solidFill>
+              </a:ln>
+            </p:spPr>
+            <p:style>
+              <a:lnRef idx="2">
+                <a:schemeClr val="accent1">
+                  <a:shade val="15000"/>
+                </a:schemeClr>
+              </a:lnRef>
+              <a:fillRef idx="1">
+                <a:schemeClr val="accent1"/>
+              </a:fillRef>
+              <a:effectRef idx="0">
+                <a:schemeClr val="accent1"/>
+              </a:effectRef>
+              <a:fontRef idx="minor">
+                <a:schemeClr val="lt1"/>
+              </a:fontRef>
+            </p:style>
+            <p:txBody>
+              <a:bodyPr rtlCol="0" anchor="ctr"/>
+              <a:lstStyle/>
+              <a:p>
+                <a:pPr algn="ctr"/>
+                <a:endParaRPr lang="fr-FR"/>
+              </a:p>
+            </p:txBody>
+          </p:sp>
+          <p:cxnSp>
+            <p:nvCxnSpPr>
+              <p:cNvPr id="106" name="Connecteur droit avec flèche 105">
+                <a:extLst>
+                  <a:ext uri="{FF2B5EF4-FFF2-40B4-BE49-F238E27FC236}">
+                    <a16:creationId xmlns:a16="http://schemas.microsoft.com/office/drawing/2014/main" id="{15B63591-1FDF-B223-9EEA-54AAF01AF616}"/>
+                  </a:ext>
+                </a:extLst>
+              </p:cNvPr>
+              <p:cNvCxnSpPr>
+                <a:cxnSpLocks/>
+              </p:cNvCxnSpPr>
+              <p:nvPr/>
+            </p:nvCxnSpPr>
+            <p:spPr>
+              <a:xfrm flipH="1">
+                <a:off x="3676982" y="4006047"/>
+                <a:ext cx="1303580" cy="0"/>
+              </a:xfrm>
+              <a:prstGeom prst="straightConnector1">
+                <a:avLst/>
+              </a:prstGeom>
+              <a:ln w="57150">
+                <a:solidFill>
+                  <a:srgbClr val="FFC000"/>
+                </a:solidFill>
+                <a:tailEnd type="triangle"/>
+              </a:ln>
+            </p:spPr>
+            <p:style>
+              <a:lnRef idx="2">
+                <a:schemeClr val="dk1"/>
+              </a:lnRef>
+              <a:fillRef idx="0">
+                <a:schemeClr val="dk1"/>
+              </a:fillRef>
+              <a:effectRef idx="1">
+                <a:schemeClr val="dk1"/>
+              </a:effectRef>
+              <a:fontRef idx="minor">
+                <a:schemeClr val="tx1"/>
+              </a:fontRef>
+            </p:style>
+          </p:cxnSp>
+          <p:sp>
+            <p:nvSpPr>
+              <p:cNvPr id="107" name="Ellipse 106">
+                <a:extLst>
+                  <a:ext uri="{FF2B5EF4-FFF2-40B4-BE49-F238E27FC236}">
+                    <a16:creationId xmlns:a16="http://schemas.microsoft.com/office/drawing/2014/main" id="{146CEDAA-20AE-84D0-205A-4F2ACD93A7BB}"/>
+                  </a:ext>
+                </a:extLst>
+              </p:cNvPr>
+              <p:cNvSpPr/>
+              <p:nvPr/>
+            </p:nvSpPr>
+            <p:spPr>
+              <a:xfrm>
+                <a:off x="4081157" y="3922006"/>
+                <a:ext cx="180000" cy="180000"/>
+              </a:xfrm>
+              <a:prstGeom prst="ellipse">
+                <a:avLst/>
+              </a:prstGeom>
+              <a:blipFill>
+                <a:blip r:embed="rId8"/>
+                <a:tile tx="0" ty="0" sx="100000" sy="100000" flip="none" algn="tl"/>
+              </a:blipFill>
+              <a:ln w="12700">
+                <a:solidFill>
+                  <a:schemeClr val="tx1"/>
+                </a:solidFill>
+              </a:ln>
+            </p:spPr>
+            <p:style>
+              <a:lnRef idx="2">
+                <a:schemeClr val="dk1">
+                  <a:shade val="15000"/>
+                </a:schemeClr>
+              </a:lnRef>
+              <a:fillRef idx="1">
+                <a:schemeClr val="dk1"/>
+              </a:fillRef>
+              <a:effectRef idx="0">
+                <a:schemeClr val="dk1"/>
+              </a:effectRef>
+              <a:fontRef idx="minor">
+                <a:schemeClr val="lt1"/>
+              </a:fontRef>
+            </p:style>
+            <p:txBody>
+              <a:bodyPr rtlCol="0" anchor="ctr"/>
+              <a:lstStyle/>
+              <a:p>
+                <a:pPr algn="ctr"/>
+                <a:endParaRPr lang="fr-FR"/>
+              </a:p>
+            </p:txBody>
+          </p:sp>
+          <p:sp>
+            <p:nvSpPr>
+              <p:cNvPr id="108" name="Ellipse 107">
+                <a:extLst>
+                  <a:ext uri="{FF2B5EF4-FFF2-40B4-BE49-F238E27FC236}">
+                    <a16:creationId xmlns:a16="http://schemas.microsoft.com/office/drawing/2014/main" id="{13F3FFBA-6AB1-B1BB-D07E-932061C3EFC9}"/>
+                  </a:ext>
+                </a:extLst>
+              </p:cNvPr>
+              <p:cNvSpPr/>
+              <p:nvPr/>
+            </p:nvSpPr>
+            <p:spPr>
+              <a:xfrm>
+                <a:off x="4490043" y="3922006"/>
+                <a:ext cx="180000" cy="180000"/>
+              </a:xfrm>
+              <a:prstGeom prst="ellipse">
+                <a:avLst/>
+              </a:prstGeom>
+              <a:blipFill>
+                <a:blip r:embed="rId8"/>
+                <a:tile tx="0" ty="0" sx="100000" sy="100000" flip="none" algn="tl"/>
+              </a:blipFill>
+              <a:ln w="12700">
+                <a:solidFill>
+                  <a:schemeClr val="tx1"/>
+                </a:solidFill>
+              </a:ln>
+            </p:spPr>
+            <p:style>
+              <a:lnRef idx="2">
+                <a:schemeClr val="dk1">
+                  <a:shade val="15000"/>
+                </a:schemeClr>
+              </a:lnRef>
+              <a:fillRef idx="1">
+                <a:schemeClr val="dk1"/>
+              </a:fillRef>
+              <a:effectRef idx="0">
+                <a:schemeClr val="dk1"/>
+              </a:effectRef>
+              <a:fontRef idx="minor">
+                <a:schemeClr val="lt1"/>
+              </a:fontRef>
+            </p:style>
+            <p:txBody>
+              <a:bodyPr rtlCol="0" anchor="ctr"/>
+              <a:lstStyle/>
+              <a:p>
+                <a:pPr algn="ctr"/>
+                <a:endParaRPr lang="fr-FR"/>
+              </a:p>
+            </p:txBody>
+          </p:sp>
+          <p:sp>
+            <p:nvSpPr>
+              <p:cNvPr id="109" name="Ellipse 108">
+                <a:extLst>
+                  <a:ext uri="{FF2B5EF4-FFF2-40B4-BE49-F238E27FC236}">
+                    <a16:creationId xmlns:a16="http://schemas.microsoft.com/office/drawing/2014/main" id="{A2452E49-E772-38B9-B174-8EDC5702DCFF}"/>
+                  </a:ext>
+                </a:extLst>
+              </p:cNvPr>
+              <p:cNvSpPr/>
+              <p:nvPr/>
+            </p:nvSpPr>
+            <p:spPr>
+              <a:xfrm>
+                <a:off x="4899524" y="3912073"/>
+                <a:ext cx="180000" cy="180000"/>
+              </a:xfrm>
+              <a:prstGeom prst="ellipse">
+                <a:avLst/>
+              </a:prstGeom>
+              <a:blipFill>
+                <a:blip r:embed="rId8"/>
+                <a:tile tx="0" ty="0" sx="100000" sy="100000" flip="none" algn="tl"/>
+              </a:blipFill>
+              <a:ln w="12700">
+                <a:solidFill>
+                  <a:schemeClr val="tx1"/>
+                </a:solidFill>
+              </a:ln>
+            </p:spPr>
+            <p:style>
+              <a:lnRef idx="2">
+                <a:schemeClr val="dk1">
+                  <a:shade val="15000"/>
+                </a:schemeClr>
+              </a:lnRef>
+              <a:fillRef idx="1">
+                <a:schemeClr val="dk1"/>
+              </a:fillRef>
+              <a:effectRef idx="0">
+                <a:schemeClr val="dk1"/>
+              </a:effectRef>
+              <a:fontRef idx="minor">
+                <a:schemeClr val="lt1"/>
+              </a:fontRef>
+            </p:style>
+            <p:txBody>
+              <a:bodyPr rtlCol="0" anchor="ctr"/>
+              <a:lstStyle/>
+              <a:p>
+                <a:pPr algn="ctr"/>
+                <a:endParaRPr lang="fr-FR"/>
+              </a:p>
+            </p:txBody>
+          </p:sp>
+        </p:grpSp>
+        <p:sp>
+          <p:nvSpPr>
+            <p:cNvPr id="112" name="ZoneTexte 111">
+              <a:extLst>
+                <a:ext uri="{FF2B5EF4-FFF2-40B4-BE49-F238E27FC236}">
+                  <a16:creationId xmlns:a16="http://schemas.microsoft.com/office/drawing/2014/main" id="{7A430CFE-43B9-A3B3-CF82-9F07877EBE9A}"/>
+                </a:ext>
+              </a:extLst>
+            </p:cNvPr>
+            <p:cNvSpPr txBox="1"/>
+            <p:nvPr/>
+          </p:nvSpPr>
+          <p:spPr>
+            <a:xfrm>
+              <a:off x="5046386" y="2838450"/>
+              <a:ext cx="153888" cy="1762188"/>
+            </a:xfrm>
+            <a:prstGeom prst="rect">
+              <a:avLst/>
+            </a:prstGeom>
+            <a:noFill/>
+          </p:spPr>
+          <p:txBody>
+            <a:bodyPr vert="vert270" wrap="square" lIns="0" tIns="0" rIns="0" bIns="0" rtlCol="0">
+              <a:spAutoFit/>
+            </a:bodyPr>
+            <a:lstStyle/>
+            <a:p>
+              <a:r>
+                <a:rPr lang="fr-FR" sz="1000" b="1" dirty="0">
+                  <a:solidFill>
+                    <a:schemeClr val="bg1"/>
+                  </a:solidFill>
+                  <a:latin typeface="Segoe UI" panose="020B0502040204020203" pitchFamily="34" charset="0"/>
+                  <a:cs typeface="Segoe UI" panose="020B0502040204020203" pitchFamily="34" charset="0"/>
+                </a:rPr>
+                <a:t>/ :  choisir en posant la carte</a:t>
+              </a:r>
+            </a:p>
+          </p:txBody>
+        </p:sp>
       </p:grpSp>
     </p:spTree>
     <p:extLst>

</xml_diff>

<commit_message>
Deuxième essai de la carte mixte disperser ou concentrer troupes
</commit_message>
<xml_diff>
--- a/pictures/Cartes-Actions-et-Evenements/Design-Cartes.pptx
+++ b/pictures/Cartes-Actions-et-Evenements/Design-Cartes.pptx
@@ -14467,7 +14467,26 @@
                   <a:latin typeface="Segoe UI" panose="020B0502040204020203" pitchFamily="34" charset="0"/>
                   <a:cs typeface="Segoe UI" panose="020B0502040204020203" pitchFamily="34" charset="0"/>
                 </a:rPr>
-                <a:t>Déplacer Troupes</a:t>
+                <a:t>Déplacer</a:t>
+              </a:r>
+              <a:br>
+                <a:rPr lang="fr-FR" sz="1200" b="1" dirty="0">
+                  <a:solidFill>
+                    <a:schemeClr val="bg1"/>
+                  </a:solidFill>
+                  <a:latin typeface="Segoe UI" panose="020B0502040204020203" pitchFamily="34" charset="0"/>
+                  <a:cs typeface="Segoe UI" panose="020B0502040204020203" pitchFamily="34" charset="0"/>
+                </a:rPr>
+              </a:br>
+              <a:r>
+                <a:rPr lang="fr-FR" sz="1200" b="1" dirty="0">
+                  <a:solidFill>
+                    <a:schemeClr val="bg1"/>
+                  </a:solidFill>
+                  <a:latin typeface="Segoe UI" panose="020B0502040204020203" pitchFamily="34" charset="0"/>
+                  <a:cs typeface="Segoe UI" panose="020B0502040204020203" pitchFamily="34" charset="0"/>
+                </a:rPr>
+                <a:t>Troupes</a:t>
               </a:r>
             </a:p>
           </p:txBody>
@@ -14503,10 +14522,7 @@
               <a:r>
                 <a:rPr lang="fr-FR" sz="1200" b="1" dirty="0">
                   <a:solidFill>
-                    <a:schemeClr val="accent6">
-                      <a:lumMod val="40000"/>
-                      <a:lumOff val="60000"/>
-                    </a:schemeClr>
+                    <a:schemeClr val="bg1"/>
                   </a:solidFill>
                   <a:latin typeface="Segoe UI" panose="020B0502040204020203" pitchFamily="34" charset="0"/>
                   <a:cs typeface="Segoe UI" panose="020B0502040204020203" pitchFamily="34" charset="0"/>
@@ -14516,12 +14532,22 @@
               <a:r>
                 <a:rPr lang="fr-FR" sz="1200" b="1" dirty="0">
                   <a:solidFill>
+                    <a:srgbClr val="FFC000"/>
+                  </a:solidFill>
+                  <a:latin typeface="Segoe UI" panose="020B0502040204020203" pitchFamily="34" charset="0"/>
+                  <a:cs typeface="Segoe UI" panose="020B0502040204020203" pitchFamily="34" charset="0"/>
+                </a:rPr>
+                <a:t>/Concentrer </a:t>
+              </a:r>
+              <a:r>
+                <a:rPr lang="fr-FR" sz="1200" b="1" dirty="0">
+                  <a:solidFill>
                     <a:schemeClr val="bg1"/>
                   </a:solidFill>
                   <a:latin typeface="Segoe UI" panose="020B0502040204020203" pitchFamily="34" charset="0"/>
                   <a:cs typeface="Segoe UI" panose="020B0502040204020203" pitchFamily="34" charset="0"/>
                 </a:rPr>
-                <a:t>/</a:t>
+                <a:t>en ligne droite des troupes depuis</a:t>
               </a:r>
               <a:r>
                 <a:rPr lang="fr-FR" sz="1200" b="1" dirty="0">
@@ -14531,7 +14557,7 @@
                   <a:latin typeface="Segoe UI" panose="020B0502040204020203" pitchFamily="34" charset="0"/>
                   <a:cs typeface="Segoe UI" panose="020B0502040204020203" pitchFamily="34" charset="0"/>
                 </a:rPr>
-                <a:t>Concentrer</a:t>
+                <a:t>/vers </a:t>
               </a:r>
               <a:r>
                 <a:rPr lang="fr-FR" sz="1200" b="1" dirty="0">
@@ -14541,50 +14567,7 @@
                   <a:latin typeface="Segoe UI" panose="020B0502040204020203" pitchFamily="34" charset="0"/>
                   <a:cs typeface="Segoe UI" panose="020B0502040204020203" pitchFamily="34" charset="0"/>
                 </a:rPr>
-                <a:t> en ligne droite des troupes </a:t>
-              </a:r>
-              <a:r>
-                <a:rPr lang="fr-FR" sz="1200" b="1" dirty="0">
-                  <a:solidFill>
-                    <a:schemeClr val="accent6">
-                      <a:lumMod val="40000"/>
-                      <a:lumOff val="60000"/>
-                    </a:schemeClr>
-                  </a:solidFill>
-                  <a:latin typeface="Segoe UI" panose="020B0502040204020203" pitchFamily="34" charset="0"/>
-                  <a:cs typeface="Segoe UI" panose="020B0502040204020203" pitchFamily="34" charset="0"/>
-                </a:rPr>
-                <a:t>depuis</a:t>
-              </a:r>
-              <a:r>
-                <a:rPr lang="fr-FR" sz="1200" b="1" dirty="0">
-                  <a:solidFill>
-                    <a:schemeClr val="bg1"/>
-                  </a:solidFill>
-                  <a:latin typeface="Segoe UI" panose="020B0502040204020203" pitchFamily="34" charset="0"/>
-                  <a:cs typeface="Segoe UI" panose="020B0502040204020203" pitchFamily="34" charset="0"/>
-                </a:rPr>
-                <a:t>/</a:t>
-              </a:r>
-              <a:r>
-                <a:rPr lang="fr-FR" sz="1200" b="1" dirty="0">
-                  <a:solidFill>
-                    <a:srgbClr val="FFC000"/>
-                  </a:solidFill>
-                  <a:latin typeface="Segoe UI" panose="020B0502040204020203" pitchFamily="34" charset="0"/>
-                  <a:cs typeface="Segoe UI" panose="020B0502040204020203" pitchFamily="34" charset="0"/>
-                </a:rPr>
-                <a:t>vers</a:t>
-              </a:r>
-              <a:r>
-                <a:rPr lang="fr-FR" sz="1200" b="1" dirty="0">
-                  <a:solidFill>
-                    <a:schemeClr val="bg1"/>
-                  </a:solidFill>
-                  <a:latin typeface="Segoe UI" panose="020B0502040204020203" pitchFamily="34" charset="0"/>
-                  <a:cs typeface="Segoe UI" panose="020B0502040204020203" pitchFamily="34" charset="0"/>
-                </a:rPr>
-                <a:t> la tuile de commandement</a:t>
+                <a:t>la tuile de commandement</a:t>
               </a:r>
             </a:p>
           </p:txBody>
@@ -14950,7 +14933,7 @@
               </a:prstGeom>
               <a:ln w="57150">
                 <a:solidFill>
-                  <a:srgbClr val="E5EFC9"/>
+                  <a:schemeClr val="tx1"/>
                 </a:solidFill>
                 <a:tailEnd type="triangle"/>
               </a:ln>
@@ -14994,7 +14977,7 @@
               </a:prstGeom>
               <a:ln w="57150">
                 <a:solidFill>
-                  <a:srgbClr val="E5EFC9"/>
+                  <a:schemeClr val="tx1"/>
                 </a:solidFill>
                 <a:tailEnd type="triangle"/>
               </a:ln>
@@ -15038,7 +15021,7 @@
               </a:prstGeom>
               <a:ln w="57150">
                 <a:solidFill>
-                  <a:srgbClr val="E5EFC9"/>
+                  <a:schemeClr val="tx1"/>
                 </a:solidFill>
                 <a:tailEnd type="triangle"/>
               </a:ln>
@@ -15685,7 +15668,7 @@
                   <a:latin typeface="Segoe UI" panose="020B0502040204020203" pitchFamily="34" charset="0"/>
                   <a:cs typeface="Segoe UI" panose="020B0502040204020203" pitchFamily="34" charset="0"/>
                 </a:rPr>
-                <a:t>D</a:t>
+                <a:t>DC</a:t>
               </a:r>
             </a:p>
           </p:txBody>
@@ -15766,7 +15749,7 @@
                   <a:latin typeface="Segoe UI" panose="020B0502040204020203" pitchFamily="34" charset="0"/>
                   <a:cs typeface="Segoe UI" panose="020B0502040204020203" pitchFamily="34" charset="0"/>
                 </a:rPr>
-                <a:t>D</a:t>
+                <a:t>DC</a:t>
               </a:r>
             </a:p>
           </p:txBody>
@@ -16332,7 +16315,7 @@
               <a:r>
                 <a:rPr lang="fr-FR" sz="1000" b="1" dirty="0">
                   <a:solidFill>
-                    <a:schemeClr val="bg1"/>
+                    <a:srgbClr val="FFC000"/>
                   </a:solidFill>
                   <a:latin typeface="Segoe UI" panose="020B0502040204020203" pitchFamily="34" charset="0"/>
                   <a:cs typeface="Segoe UI" panose="020B0502040204020203" pitchFamily="34" charset="0"/>

</xml_diff>